<commit_message>
Revise all 32 CSC270 lecture decks per instructor feedback
Applies the instructor's feedback across the Database Systems deck set:
body text raised to at least 18pt (tables and code 14pt, captions 12pt)
for projection visibility, slide counts expanded toward the 20-25 range
for 75-minute sessions, and step-by-step worked derivations added for
the tricky topics: ER/EER modeling (L12-16), normalization and
functional dependencies (L18-22), and transaction management (L29-31).
Also corrects the Lecture 22 chapter, which said the decomposed
EmpSkills/EmpLanguages pair stores five rows; it stores six (three each).

Co-Authored-By: Claude Sonnet 5 <noreply@anthropic.com>
</commit_message>
<xml_diff>
--- a/slides/CSC270-Lecture-04-Database-Architecture-and-Data-Independence.pptx
+++ b/slides/CSC270-Lecture-04-Database-Architecture-and-Data-Independence.pptx
@@ -8,14 +8,26 @@
     <p:sldId id="256" r:id="rId2"/>
     <p:sldId id="257" r:id="rId3"/>
     <p:sldId id="258" r:id="rId4"/>
+    <p:sldId id="267" r:id="rId18"/>
+    <p:sldId id="268" r:id="rId19"/>
     <p:sldId id="259" r:id="rId5"/>
+    <p:sldId id="269" r:id="rId20"/>
     <p:sldId id="260" r:id="rId6"/>
+    <p:sldId id="270" r:id="rId21"/>
     <p:sldId id="261" r:id="rId7"/>
+    <p:sldId id="271" r:id="rId22"/>
     <p:sldId id="262" r:id="rId8"/>
+    <p:sldId id="272" r:id="rId23"/>
     <p:sldId id="263" r:id="rId9"/>
+    <p:sldId id="273" r:id="rId24"/>
     <p:sldId id="264" r:id="rId10"/>
+    <p:sldId id="274" r:id="rId25"/>
     <p:sldId id="265" r:id="rId11"/>
+    <p:sldId id="275" r:id="rId26"/>
+    <p:sldId id="276" r:id="rId27"/>
+    <p:sldId id="277" r:id="rId28"/>
     <p:sldId id="266" r:id="rId12"/>
+    <p:sldId id="278" r:id="rId29"/>
   </p:sldIdLst>
   <p:notesMasterIdLst>
     <p:notesMasterId r:id="rId13"/>
@@ -1790,7 +1802,7 @@
               <a:buNone/>
             </a:pPr>
             <a:r>
-              <a:rPr lang="en-US" sz="1600" b="1" spc="300" kern="0" dirty="0">
+              <a:rPr lang="en-US" sz="1800" b="1" spc="300" kern="0" dirty="0">
                 <a:solidFill>
                   <a:srgbClr val="2FE6C4"/>
                 </a:solidFill>
@@ -1800,7 +1812,7 @@
               </a:rPr>
               <a:t>LECTURE 4</a:t>
             </a:r>
-            <a:endParaRPr lang="en-US" sz="1600" dirty="0"/>
+            <a:endParaRPr lang="en-US" sz="1800" dirty="0"/>
           </a:p>
         </p:txBody>
       </p:sp>
@@ -1907,7 +1919,7 @@
               <a:buNone/>
             </a:pPr>
             <a:r>
-              <a:rPr lang="en-US" sz="1300" dirty="0">
+              <a:rPr lang="en-US" sz="1800" dirty="0">
                 <a:solidFill>
                   <a:srgbClr val="8A939B"/>
                 </a:solidFill>
@@ -1917,7 +1929,7 @@
               </a:rPr>
               <a:t>COMSATS University Islamabad, Lahore Campus</a:t>
             </a:r>
-            <a:endParaRPr lang="en-US" sz="1300" dirty="0"/>
+            <a:endParaRPr lang="en-US" sz="1800" dirty="0"/>
           </a:p>
         </p:txBody>
       </p:sp>
@@ -1946,7 +1958,7 @@
               <a:buNone/>
             </a:pPr>
             <a:r>
-              <a:rPr lang="en-US" sz="1000" u="sng" dirty="0">
+              <a:rPr lang="en-US" sz="1200" u="sng" dirty="0">
                 <a:solidFill>
                   <a:srgbClr val="8A939B"/>
                 </a:solidFill>
@@ -1967,7 +1979,7 @@
               <a:buNone/>
             </a:pPr>
             <a:r>
-              <a:rPr lang="en-US" sz="1000" dirty="0">
+              <a:rPr lang="en-US" sz="1200" dirty="0">
                 <a:solidFill>
                   <a:srgbClr val="8A939B"/>
                 </a:solidFill>
@@ -1977,7 +1989,7 @@
               </a:rPr>
               <a:t>  ·  1</a:t>
             </a:r>
-            <a:endParaRPr lang="en-US" sz="1000" dirty="0"/>
+            <a:endParaRPr lang="en-US" sz="1200" dirty="0"/>
           </a:p>
         </p:txBody>
       </p:sp>
@@ -2077,7 +2089,7 @@
               <a:buNone/>
             </a:pPr>
             <a:r>
-              <a:rPr lang="en-US" sz="1000" u="sng" dirty="0">
+              <a:rPr lang="en-US" sz="1200" u="sng" dirty="0">
                 <a:solidFill>
                   <a:srgbClr val="8A939B"/>
                 </a:solidFill>
@@ -2098,7 +2110,7 @@
               <a:buNone/>
             </a:pPr>
             <a:r>
-              <a:rPr lang="en-US" sz="1000" dirty="0">
+              <a:rPr lang="en-US" sz="1200" dirty="0">
                 <a:solidFill>
                   <a:srgbClr val="8A939B"/>
                 </a:solidFill>
@@ -2106,9 +2118,9 @@
                 <a:ea typeface="Calibri" pitchFamily="34" charset="-122"/>
                 <a:cs typeface="Calibri" pitchFamily="34" charset="-120"/>
               </a:rPr>
-              <a:t>  ·  10</a:t>
-            </a:r>
-            <a:endParaRPr lang="en-US" sz="1000" dirty="0"/>
+              <a:t>  ·  18</a:t>
+            </a:r>
+            <a:endParaRPr lang="en-US" sz="1200" dirty="0"/>
           </a:p>
         </p:txBody>
       </p:sp>
@@ -2159,7 +2171,7 @@
               <a:buNone/>
             </a:pPr>
             <a:r>
-              <a:rPr lang="en-US" sz="1500" b="1" dirty="0">
+              <a:rPr lang="en-US" sz="1800" b="1" dirty="0">
                 <a:solidFill>
                   <a:srgbClr val="FFFFFF"/>
                 </a:solidFill>
@@ -2169,7 +2181,7 @@
               </a:rPr>
               <a:t>The capacity to change the internal schema — how data is physically stored — without having to change the conceptual schema (and therefore not external schemas or applications either).</a:t>
             </a:r>
-            <a:endParaRPr lang="en-US" sz="1500" dirty="0"/>
+            <a:endParaRPr lang="en-US" sz="1800" dirty="0"/>
           </a:p>
         </p:txBody>
       </p:sp>
@@ -2225,7 +2237,7 @@
               <a:buNone/>
             </a:pPr>
             <a:r>
-              <a:rPr lang="en-US" sz="1250" b="1" dirty="0">
+              <a:rPr lang="en-US" sz="1800" b="1" dirty="0">
                 <a:solidFill>
                   <a:srgbClr val="1F2429"/>
                 </a:solidFill>
@@ -2239,7 +2251,7 @@
               <a:buNone/>
             </a:pPr>
             <a:r>
-              <a:rPr lang="en-US" sz="1250" dirty="0">
+              <a:rPr lang="en-US" sz="1800" dirty="0">
                 <a:solidFill>
                   <a:srgbClr val="1F2429"/>
                 </a:solidFill>
@@ -2249,7 +2261,7 @@
               </a:rPr>
               <a:t>The DBA adds a new index on Student.cnic, or migrates storage from spinning disks to SSDs, or reorganizes how Student records are laid out in their file. None of this touches the conceptual schema — only the conceptual/internal mapping changes.</a:t>
             </a:r>
-            <a:endParaRPr lang="en-US" sz="1250" dirty="0"/>
+            <a:endParaRPr lang="en-US" sz="1800" dirty="0"/>
           </a:p>
         </p:txBody>
       </p:sp>
@@ -2300,7 +2312,7 @@
               <a:buNone/>
             </a:pPr>
             <a:r>
-              <a:rPr lang="en-US" sz="1350" b="1" dirty="0">
+              <a:rPr lang="en-US" sz="1800" b="1" dirty="0">
                 <a:solidFill>
                   <a:srgbClr val="FFFFFF"/>
                 </a:solidFill>
@@ -2310,7 +2322,7 @@
               </a:rPr>
               <a:t>Logical data independence</a:t>
             </a:r>
-            <a:endParaRPr lang="en-US" sz="1350" dirty="0"/>
+            <a:endParaRPr lang="en-US" sz="1800" dirty="0"/>
           </a:p>
         </p:txBody>
       </p:sp>
@@ -2339,7 +2351,7 @@
               <a:buNone/>
             </a:pPr>
             <a:r>
-              <a:rPr lang="en-US" sz="1050" dirty="0">
+              <a:rPr lang="en-US" sz="1800" dirty="0">
                 <a:solidFill>
                   <a:srgbClr val="FFFFFF"/>
                 </a:solidFill>
@@ -2349,7 +2361,7 @@
               </a:rPr>
               <a:t>Conceptual schema changes -&gt; only the external/conceptual mapping updates -&gt; external schemas untouched</a:t>
             </a:r>
-            <a:endParaRPr lang="en-US" sz="1050" dirty="0"/>
+            <a:endParaRPr lang="en-US" sz="1800" dirty="0"/>
           </a:p>
         </p:txBody>
       </p:sp>
@@ -2400,7 +2412,7 @@
               <a:buNone/>
             </a:pPr>
             <a:r>
-              <a:rPr lang="en-US" sz="1350" b="1" dirty="0">
+              <a:rPr lang="en-US" sz="1800" b="1" dirty="0">
                 <a:solidFill>
                   <a:srgbClr val="FFFFFF"/>
                 </a:solidFill>
@@ -2410,7 +2422,7 @@
               </a:rPr>
               <a:t>Physical data independence</a:t>
             </a:r>
-            <a:endParaRPr lang="en-US" sz="1350" dirty="0"/>
+            <a:endParaRPr lang="en-US" sz="1800" dirty="0"/>
           </a:p>
         </p:txBody>
       </p:sp>
@@ -2439,7 +2451,7 @@
               <a:buNone/>
             </a:pPr>
             <a:r>
-              <a:rPr lang="en-US" sz="1050" dirty="0">
+              <a:rPr lang="en-US" sz="1800" dirty="0">
                 <a:solidFill>
                   <a:srgbClr val="FFFFFF"/>
                 </a:solidFill>
@@ -2449,7 +2461,7 @@
               </a:rPr>
               <a:t>Internal schema changes -&gt; only the conceptual/internal mapping updates -&gt; conceptual schema untouched</a:t>
             </a:r>
-            <a:endParaRPr lang="en-US" sz="1050" dirty="0"/>
+            <a:endParaRPr lang="en-US" sz="1800" dirty="0"/>
           </a:p>
         </p:txBody>
       </p:sp>
@@ -2478,7 +2490,7 @@
               <a:buNone/>
             </a:pPr>
             <a:r>
-              <a:rPr lang="en-US" sz="1150" i="1" dirty="0">
+              <a:rPr lang="en-US" sz="1800" i="1" dirty="0">
                 <a:solidFill>
                   <a:srgbClr val="8A939B"/>
                 </a:solidFill>
@@ -2488,7 +2500,7 @@
               </a:rPr>
               <a:t>Anchor them by which schema changes: logical insulates users from conceptual-level changes; physical insulates the conceptual level from internal, physical-storage changes.</a:t>
             </a:r>
-            <a:endParaRPr lang="en-US" sz="1150" dirty="0"/>
+            <a:endParaRPr lang="en-US" sz="1800" dirty="0"/>
           </a:p>
         </p:txBody>
       </p:sp>
@@ -2592,7 +2604,7 @@
               <a:buChar char="•"/>
             </a:pPr>
             <a:r>
-              <a:rPr lang="en-US" sz="1600" dirty="0">
+              <a:rPr lang="en-US" sz="1800" dirty="0">
                 <a:solidFill>
                   <a:srgbClr val="FFFFFF"/>
                 </a:solidFill>
@@ -2602,7 +2614,7 @@
               </a:rPr>
               <a:t>Two-tier client-server architecture splits a system into client and database server; three-tier adds a middle application-server tier for business logic and scalability</a:t>
             </a:r>
-            <a:endParaRPr lang="en-US" sz="1600" dirty="0"/>
+            <a:endParaRPr lang="en-US" sz="1800" dirty="0"/>
           </a:p>
           <a:p>
             <a:pPr marL="342900" indent="-342900">
@@ -2613,7 +2625,7 @@
               <a:buChar char="•"/>
             </a:pPr>
             <a:r>
-              <a:rPr lang="en-US" sz="1600" dirty="0">
+              <a:rPr lang="en-US" sz="1800" dirty="0">
                 <a:solidFill>
                   <a:srgbClr val="FFFFFF"/>
                 </a:solidFill>
@@ -2623,7 +2635,7 @@
               </a:rPr>
               <a:t>The ANSI-SPARC three-schema architecture organizes a database into external (many user views), conceptual (one complete community schema), and internal (physical storage) levels — three descriptions, not three copies of the data</a:t>
             </a:r>
-            <a:endParaRPr lang="en-US" sz="1600" dirty="0"/>
+            <a:endParaRPr lang="en-US" sz="1800" dirty="0"/>
           </a:p>
           <a:p>
             <a:pPr marL="342900" indent="-342900">
@@ -2634,7 +2646,7 @@
               <a:buChar char="•"/>
             </a:pPr>
             <a:r>
-              <a:rPr lang="en-US" sz="1600" dirty="0">
+              <a:rPr lang="en-US" sz="1800" dirty="0">
                 <a:solidFill>
                   <a:srgbClr val="FFFFFF"/>
                 </a:solidFill>
@@ -2644,7 +2656,7 @@
               </a:rPr>
               <a:t>The external/conceptual mapping connects user views to the conceptual schema; the conceptual/internal mapping connects the conceptual schema to physical storage</a:t>
             </a:r>
-            <a:endParaRPr lang="en-US" sz="1600" dirty="0"/>
+            <a:endParaRPr lang="en-US" sz="1800" dirty="0"/>
           </a:p>
           <a:p>
             <a:pPr marL="342900" indent="-342900">
@@ -2655,7 +2667,7 @@
               <a:buChar char="•"/>
             </a:pPr>
             <a:r>
-              <a:rPr lang="en-US" sz="1600" dirty="0">
+              <a:rPr lang="en-US" sz="1800" dirty="0">
                 <a:solidFill>
                   <a:srgbClr val="FFFFFF"/>
                 </a:solidFill>
@@ -2665,7 +2677,7 @@
               </a:rPr>
               <a:t>Logical data independence: changing the conceptual schema without forcing changes to external schemas or applications</a:t>
             </a:r>
-            <a:endParaRPr lang="en-US" sz="1600" dirty="0"/>
+            <a:endParaRPr lang="en-US" sz="1800" dirty="0"/>
           </a:p>
           <a:p>
             <a:pPr marL="342900" indent="-342900">
@@ -2676,7 +2688,7 @@
               <a:buChar char="•"/>
             </a:pPr>
             <a:r>
-              <a:rPr lang="en-US" sz="1600" dirty="0">
+              <a:rPr lang="en-US" sz="1800" dirty="0">
                 <a:solidFill>
                   <a:srgbClr val="FFFFFF"/>
                 </a:solidFill>
@@ -2686,7 +2698,7 @@
               </a:rPr>
               <a:t>Physical data independence: changing the internal (physical storage) schema without forcing changes to the conceptual schema — and therefore not external schemas either</a:t>
             </a:r>
-            <a:endParaRPr lang="en-US" sz="1600" dirty="0"/>
+            <a:endParaRPr lang="en-US" sz="1800" dirty="0"/>
           </a:p>
         </p:txBody>
       </p:sp>
@@ -2715,7 +2727,7 @@
               <a:buNone/>
             </a:pPr>
             <a:r>
-              <a:rPr lang="en-US" sz="1000" u="sng" dirty="0">
+              <a:rPr lang="en-US" sz="1200" u="sng" dirty="0">
                 <a:solidFill>
                   <a:srgbClr val="8A939B"/>
                 </a:solidFill>
@@ -2736,7 +2748,7 @@
               <a:buNone/>
             </a:pPr>
             <a:r>
-              <a:rPr lang="en-US" sz="1000" dirty="0">
+              <a:rPr lang="en-US" sz="1200" dirty="0">
                 <a:solidFill>
                   <a:srgbClr val="8A939B"/>
                 </a:solidFill>
@@ -2744,9 +2756,2115 @@
                 <a:ea typeface="Calibri" pitchFamily="34" charset="-122"/>
                 <a:cs typeface="Calibri" pitchFamily="34" charset="-120"/>
               </a:rPr>
+              <a:t>  ·  22</a:t>
+            </a:r>
+            <a:endParaRPr lang="en-US" sz="1200" dirty="0"/>
+          </a:p>
+        </p:txBody>
+      </p:sp>
+    </p:spTree>
+  </p:cSld>
+  <p:clrMapOvr>
+    <a:masterClrMapping/>
+  </p:clrMapOvr>
+</p:sld>
+</file>
+
+<file path=ppt/slides/slide12.xml><?xml version="1.0" encoding="utf-8"?>
+<p:sld xmlns:a="http://schemas.openxmlformats.org/drawingml/2006/main" xmlns:r="http://schemas.openxmlformats.org/officeDocument/2006/relationships" xmlns:p="http://schemas.openxmlformats.org/presentationml/2006/main">
+  <p:cSld name="Slide 2">
+    <p:bg>
+      <p:bgPr>
+        <a:solidFill>
+          <a:srgbClr val="F7F8F9"/>
+        </a:solidFill>
+      </p:bgPr>
+    </p:bg>
+    <p:spTree>
+      <p:nvGrpSpPr>
+        <p:cNvPr id="1" name=""/>
+        <p:cNvGrpSpPr/>
+        <p:nvPr/>
+      </p:nvGrpSpPr>
+      <p:grpSpPr>
+        <a:xfrm>
+          <a:off x="0" y="0"/>
+          <a:ext cx="0" cy="0"/>
+          <a:chOff x="0" y="0"/>
+          <a:chExt cx="0" cy="0"/>
+        </a:xfrm>
+      </p:grpSpPr>
+      <p:sp>
+        <p:nvSpPr>
+          <p:cNvPr id="2" name="Text 0"/>
+          <p:cNvSpPr txBox="1"/>
+          <p:nvPr/>
+        </p:nvSpPr>
+        <p:spPr>
+          <a:xfrm>
+            <a:off x="548640" y="365760"/>
+            <a:ext cx="11064240" cy="731520"/>
+          </a:xfrm>
+          <a:prstGeom prst="rect">
+            <a:avLst/>
+          </a:prstGeom>
+          <a:noFill/>
+          <a:ln/>
+        </p:spPr>
+        <p:txBody>
+          <a:bodyPr wrap="square" lIns="0" tIns="0" rIns="0" bIns="0" rtlCol="0" anchor="ctr"/>
+          <a:lstStyle/>
+          <a:p>
+            <a:pPr indent="0" marL="0">
+              <a:buNone/>
+            </a:pPr>
+            <a:r>
+              <a:rPr lang="en-US" sz="2800" b="1" dirty="0">
+                <a:solidFill>
+                  <a:srgbClr val="1F2429"/>
+                </a:solidFill>
+                <a:latin typeface="Calibri" pitchFamily="34" charset="0"/>
+                <a:ea typeface="Calibri" pitchFamily="34" charset="-122"/>
+                <a:cs typeface="Calibri" pitchFamily="34" charset="-120"/>
+              </a:rPr>
+              <a:t>Two-Tier, Step by Step: One Teller, One Withdrawal</a:t>
+            </a:r>
+            <a:endParaRPr lang="en-US" sz="2800" dirty="0"/>
+          </a:p>
+        </p:txBody>
+      </p:sp>
+      <p:sp>
+        <p:nvSpPr>
+          <p:cNvPr id="3" name="Text 1"/>
+          <p:cNvSpPr txBox="1"/>
+          <p:nvPr/>
+        </p:nvSpPr>
+        <p:spPr>
+          <a:xfrm>
+            <a:off x="9951415" y="6455664"/>
+            <a:ext cx="2011680" cy="292608"/>
+          </a:xfrm>
+          <a:prstGeom prst="rect">
+            <a:avLst/>
+          </a:prstGeom>
+          <a:noFill/>
+          <a:ln/>
+        </p:spPr>
+        <p:txBody>
+          <a:bodyPr wrap="square" lIns="0" tIns="0" rIns="0" bIns="0" rtlCol="0" anchor="ctr"/>
+          <a:lstStyle/>
+          <a:p>
+            <a:pPr algn="r" indent="0" marL="0">
+              <a:buNone/>
+            </a:pPr>
+            <a:r>
+              <a:rPr lang="en-US" sz="1200" u="sng" dirty="0">
+                <a:solidFill>
+                  <a:srgbClr val="8A939B"/>
+                </a:solidFill>
+                <a:latin typeface="Calibri" pitchFamily="34" charset="0"/>
+                <a:ea typeface="Calibri" pitchFamily="34" charset="-122"/>
+                <a:cs typeface="Calibri" pitchFamily="34" charset="-120"/>
+                <a:hlinkClick r:id="rId1" invalidUrl="" action="" tgtFrame="" tooltip="" history="1" highlightClick="0" endSnd="0">
+                  <a:extLst>
+                    <a:ext uri="{A12FA001-AC4F-418D-AE19-62706E023703}">
+                      <ahyp:hlinkClr xmlns:ahyp="http://schemas.microsoft.com/office/drawing/2018/hyperlinkcolor" val="tx"/>
+                    </a:ext>
+                  </a:extLst>
+                </a:hlinkClick>
+              </a:rPr>
+              <a:t>cuinotes.com</a:t>
+            </a:r>
+            <a:pPr algn="r" indent="0" marL="0">
+              <a:buNone/>
+            </a:pPr>
+            <a:r>
+              <a:rPr lang="en-US" sz="1200" dirty="0">
+                <a:solidFill>
+                  <a:srgbClr val="8A939B"/>
+                </a:solidFill>
+                <a:latin typeface="Calibri" pitchFamily="34" charset="0"/>
+                <a:ea typeface="Calibri" pitchFamily="34" charset="-122"/>
+                <a:cs typeface="Calibri" pitchFamily="34" charset="-120"/>
+              </a:rPr>
+              <a:t>  ·  4</a:t>
+            </a:r>
+            <a:endParaRPr lang="en-US" sz="1200" dirty="0"/>
+          </a:p>
+        </p:txBody>
+      </p:sp>
+      <p:sp>
+        <p:nvSpPr>
+          <p:cNvPr id="4" name="Text 2"/>
+          <p:cNvSpPr txBox="1"/>
+          <p:nvPr/>
+        </p:nvSpPr>
+        <p:spPr>
+          <a:xfrm>
+            <a:off x="640080" y="1371600"/>
+            <a:ext cx="10332720" cy="4846320"/>
+          </a:xfrm>
+          <a:prstGeom prst="rect">
+            <a:avLst/>
+          </a:prstGeom>
+          <a:noFill/>
+          <a:ln/>
+        </p:spPr>
+        <p:txBody>
+          <a:bodyPr wrap="square" lIns="0" tIns="0" rIns="0" bIns="0" rtlCol="0" anchor="t"/>
+          <a:lstStyle/>
+          <a:p>
+            <a:pPr marL="342900" indent="-342900">
+              <a:spcAft>
+                <a:spcPts val="1800"/>
+              </a:spcAft>
+              <a:buSzPct val="100000"/>
+              <a:buChar char="•"/>
+            </a:pPr>
+            <a:r>
+              <a:rPr lang="en-US" sz="1800" dirty="0">
+                <a:solidFill>
+                  <a:srgbClr val="1F2429"/>
+                </a:solidFill>
+                <a:latin typeface="Calibri" pitchFamily="34" charset="0"/>
+                <a:ea typeface="Calibri" pitchFamily="34" charset="-122"/>
+                <a:cs typeface="Calibri" pitchFamily="34" charset="-120"/>
+              </a:rPr>
+              <a:t>The teller enters a withdrawal of 5,000 for account SL21 in the desktop application</a:t>
+            </a:r>
+            <a:endParaRPr lang="en-US" sz="1800" dirty="0"/>
+          </a:p>
+          <a:p>
+            <a:pPr marL="342900" indent="-342900">
+              <a:spcAft>
+                <a:spcPts val="1800"/>
+              </a:spcAft>
+              <a:buSzPct val="100000"/>
+              <a:buChar char="•"/>
+            </a:pPr>
+            <a:r>
+              <a:rPr lang="en-US" sz="1800" dirty="0">
+                <a:solidFill>
+                  <a:srgbClr val="1F2429"/>
+                </a:solidFill>
+                <a:latin typeface="Calibri" pitchFamily="34" charset="0"/>
+                <a:ea typeface="Calibri" pitchFamily="34" charset="-122"/>
+                <a:cs typeface="Calibri" pitchFamily="34" charset="-120"/>
+              </a:rPr>
+              <a:t>The client builds the SQL statement and sends it straight across the bank's network to the database server</a:t>
+            </a:r>
+            <a:endParaRPr lang="en-US" sz="1800" dirty="0"/>
+          </a:p>
+          <a:p>
+            <a:pPr marL="342900" indent="-342900">
+              <a:spcAft>
+                <a:spcPts val="1800"/>
+              </a:spcAft>
+              <a:buSzPct val="100000"/>
+              <a:buChar char="•"/>
+            </a:pPr>
+            <a:r>
+              <a:rPr lang="en-US" sz="1800" dirty="0">
+                <a:solidFill>
+                  <a:srgbClr val="1F2429"/>
+                </a:solidFill>
+                <a:latin typeface="Calibri" pitchFamily="34" charset="0"/>
+                <a:ea typeface="Calibri" pitchFamily="34" charset="-122"/>
+                <a:cs typeface="Calibri" pitchFamily="34" charset="-120"/>
+              </a:rPr>
+              <a:t>The DBMS on the server parses, checks, and executes the statement against the stored Account data</a:t>
+            </a:r>
+            <a:endParaRPr lang="en-US" sz="1800" dirty="0"/>
+          </a:p>
+          <a:p>
+            <a:pPr marL="342900" indent="-342900">
+              <a:spcAft>
+                <a:spcPts val="1800"/>
+              </a:spcAft>
+              <a:buSzPct val="100000"/>
+              <a:buChar char="•"/>
+            </a:pPr>
+            <a:r>
+              <a:rPr lang="en-US" sz="1800" dirty="0">
+                <a:solidFill>
+                  <a:srgbClr val="1F2429"/>
+                </a:solidFill>
+                <a:latin typeface="Calibri" pitchFamily="34" charset="0"/>
+                <a:ea typeface="Calibri" pitchFamily="34" charset="-122"/>
+                <a:cs typeface="Calibri" pitchFamily="34" charset="-120"/>
+              </a:rPr>
+              <a:t>Only the result travels back — the new balance, or an error message</a:t>
+            </a:r>
+            <a:endParaRPr lang="en-US" sz="1800" dirty="0"/>
+          </a:p>
+          <a:p>
+            <a:pPr marL="342900" indent="-342900">
+              <a:spcAft>
+                <a:spcPts val="1800"/>
+              </a:spcAft>
+              <a:buSzPct val="100000"/>
+              <a:buChar char="•"/>
+            </a:pPr>
+            <a:r>
+              <a:rPr lang="en-US" sz="1800" dirty="0">
+                <a:solidFill>
+                  <a:srgbClr val="1F2429"/>
+                </a:solidFill>
+                <a:latin typeface="Calibri" pitchFamily="34" charset="0"/>
+                <a:ea typeface="Calibri" pitchFamily="34" charset="-122"/>
+                <a:cs typeface="Calibri" pitchFamily="34" charset="-120"/>
+              </a:rPr>
+              <a:t>The client formats that result for the teller's screen; the business logic ran on the teller's own machine</a:t>
+            </a:r>
+            <a:endParaRPr lang="en-US" sz="1800" dirty="0"/>
+          </a:p>
+        </p:txBody>
+      </p:sp>
+    </p:spTree>
+  </p:cSld>
+  <p:clrMapOvr>
+    <a:masterClrMapping/>
+  </p:clrMapOvr>
+</p:sld>
+</file>
+
+<file path=ppt/slides/slide13.xml><?xml version="1.0" encoding="utf-8"?>
+<p:sld xmlns:a="http://schemas.openxmlformats.org/drawingml/2006/main" xmlns:r="http://schemas.openxmlformats.org/officeDocument/2006/relationships" xmlns:p="http://schemas.openxmlformats.org/presentationml/2006/main">
+  <p:cSld name="Slide 2">
+    <p:bg>
+      <p:bgPr>
+        <a:solidFill>
+          <a:srgbClr val="F7F8F9"/>
+        </a:solidFill>
+      </p:bgPr>
+    </p:bg>
+    <p:spTree>
+      <p:nvGrpSpPr>
+        <p:cNvPr id="1" name=""/>
+        <p:cNvGrpSpPr/>
+        <p:nvPr/>
+      </p:nvGrpSpPr>
+      <p:grpSpPr>
+        <a:xfrm>
+          <a:off x="0" y="0"/>
+          <a:ext cx="0" cy="0"/>
+          <a:chOff x="0" y="0"/>
+          <a:chExt cx="0" cy="0"/>
+        </a:xfrm>
+      </p:grpSpPr>
+      <p:sp>
+        <p:nvSpPr>
+          <p:cNvPr id="2" name="Text 0"/>
+          <p:cNvSpPr txBox="1"/>
+          <p:nvPr/>
+        </p:nvSpPr>
+        <p:spPr>
+          <a:xfrm>
+            <a:off x="548640" y="365760"/>
+            <a:ext cx="11064240" cy="731520"/>
+          </a:xfrm>
+          <a:prstGeom prst="rect">
+            <a:avLst/>
+          </a:prstGeom>
+          <a:noFill/>
+          <a:ln/>
+        </p:spPr>
+        <p:txBody>
+          <a:bodyPr wrap="square" lIns="0" tIns="0" rIns="0" bIns="0" rtlCol="0" anchor="ctr"/>
+          <a:lstStyle/>
+          <a:p>
+            <a:pPr indent="0" marL="0">
+              <a:buNone/>
+            </a:pPr>
+            <a:r>
+              <a:rPr lang="en-US" sz="2800" b="1" dirty="0">
+                <a:solidFill>
+                  <a:srgbClr val="1F2429"/>
+                </a:solidFill>
+                <a:latin typeface="Calibri" pitchFamily="34" charset="0"/>
+                <a:ea typeface="Calibri" pitchFamily="34" charset="-122"/>
+                <a:cs typeface="Calibri" pitchFamily="34" charset="-120"/>
+              </a:rPr>
+              <a:t>Why Two Tiers Stop Scaling: A Worked Count</a:t>
+            </a:r>
+            <a:endParaRPr lang="en-US" sz="2800" dirty="0"/>
+          </a:p>
+        </p:txBody>
+      </p:sp>
+      <p:sp>
+        <p:nvSpPr>
+          <p:cNvPr id="3" name="Text 1"/>
+          <p:cNvSpPr txBox="1"/>
+          <p:nvPr/>
+        </p:nvSpPr>
+        <p:spPr>
+          <a:xfrm>
+            <a:off x="9951415" y="6455664"/>
+            <a:ext cx="2011680" cy="292608"/>
+          </a:xfrm>
+          <a:prstGeom prst="rect">
+            <a:avLst/>
+          </a:prstGeom>
+          <a:noFill/>
+          <a:ln/>
+        </p:spPr>
+        <p:txBody>
+          <a:bodyPr wrap="square" lIns="0" tIns="0" rIns="0" bIns="0" rtlCol="0" anchor="ctr"/>
+          <a:lstStyle/>
+          <a:p>
+            <a:pPr algn="r" indent="0" marL="0">
+              <a:buNone/>
+            </a:pPr>
+            <a:r>
+              <a:rPr lang="en-US" sz="1200" u="sng" dirty="0">
+                <a:solidFill>
+                  <a:srgbClr val="8A939B"/>
+                </a:solidFill>
+                <a:latin typeface="Calibri" pitchFamily="34" charset="0"/>
+                <a:ea typeface="Calibri" pitchFamily="34" charset="-122"/>
+                <a:cs typeface="Calibri" pitchFamily="34" charset="-120"/>
+                <a:hlinkClick r:id="rId1" invalidUrl="" action="" tgtFrame="" tooltip="" history="1" highlightClick="0" endSnd="0">
+                  <a:extLst>
+                    <a:ext uri="{A12FA001-AC4F-418D-AE19-62706E023703}">
+                      <ahyp:hlinkClr xmlns:ahyp="http://schemas.microsoft.com/office/drawing/2018/hyperlinkcolor" val="tx"/>
+                    </a:ext>
+                  </a:extLst>
+                </a:hlinkClick>
+              </a:rPr>
+              <a:t>cuinotes.com</a:t>
+            </a:r>
+            <a:pPr algn="r" indent="0" marL="0">
+              <a:buNone/>
+            </a:pPr>
+            <a:r>
+              <a:rPr lang="en-US" sz="1200" dirty="0">
+                <a:solidFill>
+                  <a:srgbClr val="8A939B"/>
+                </a:solidFill>
+                <a:latin typeface="Calibri" pitchFamily="34" charset="0"/>
+                <a:ea typeface="Calibri" pitchFamily="34" charset="-122"/>
+                <a:cs typeface="Calibri" pitchFamily="34" charset="-120"/>
+              </a:rPr>
+              <a:t>  ·  5</a:t>
+            </a:r>
+            <a:endParaRPr lang="en-US" sz="1200" dirty="0"/>
+          </a:p>
+        </p:txBody>
+      </p:sp>
+      <p:sp>
+        <p:nvSpPr>
+          <p:cNvPr id="4" name="Text 2"/>
+          <p:cNvSpPr txBox="1"/>
+          <p:nvPr/>
+        </p:nvSpPr>
+        <p:spPr>
+          <a:xfrm>
+            <a:off x="640080" y="1371600"/>
+            <a:ext cx="10332720" cy="4846320"/>
+          </a:xfrm>
+          <a:prstGeom prst="rect">
+            <a:avLst/>
+          </a:prstGeom>
+          <a:noFill/>
+          <a:ln/>
+        </p:spPr>
+        <p:txBody>
+          <a:bodyPr wrap="square" lIns="0" tIns="0" rIns="0" bIns="0" rtlCol="0" anchor="t"/>
+          <a:lstStyle/>
+          <a:p>
+            <a:pPr marL="342900" indent="-342900">
+              <a:spcAft>
+                <a:spcPts val="1800"/>
+              </a:spcAft>
+              <a:buSzPct val="100000"/>
+              <a:buChar char="•"/>
+            </a:pPr>
+            <a:r>
+              <a:rPr lang="en-US" sz="1800" dirty="0">
+                <a:solidFill>
+                  <a:srgbClr val="1F2429"/>
+                </a:solidFill>
+                <a:latin typeface="Calibri" pitchFamily="34" charset="0"/>
+                <a:ea typeface="Calibri" pitchFamily="34" charset="-122"/>
+                <a:cs typeface="Calibri" pitchFamily="34" charset="-120"/>
+              </a:rPr>
+              <a:t>Suppose the bank has 500 tellers, each with the desktop application installed</a:t>
+            </a:r>
+            <a:endParaRPr lang="en-US" sz="1800" dirty="0"/>
+          </a:p>
+          <a:p>
+            <a:pPr marL="342900" indent="-342900">
+              <a:spcAft>
+                <a:spcPts val="1800"/>
+              </a:spcAft>
+              <a:buSzPct val="100000"/>
+              <a:buChar char="•"/>
+            </a:pPr>
+            <a:r>
+              <a:rPr lang="en-US" sz="1800" dirty="0">
+                <a:solidFill>
+                  <a:srgbClr val="1F2429"/>
+                </a:solidFill>
+                <a:latin typeface="Calibri" pitchFamily="34" charset="0"/>
+                <a:ea typeface="Calibri" pitchFamily="34" charset="-122"/>
+                <a:cs typeface="Calibri" pitchFamily="34" charset="-120"/>
+              </a:rPr>
+              <a:t>Every teller holds an open connection straight to the central database server: 500 direct connections</a:t>
+            </a:r>
+            <a:endParaRPr lang="en-US" sz="1800" dirty="0"/>
+          </a:p>
+          <a:p>
+            <a:pPr marL="342900" indent="-342900">
+              <a:spcAft>
+                <a:spcPts val="1800"/>
+              </a:spcAft>
+              <a:buSzPct val="100000"/>
+              <a:buChar char="•"/>
+            </a:pPr>
+            <a:r>
+              <a:rPr lang="en-US" sz="1800" dirty="0">
+                <a:solidFill>
+                  <a:srgbClr val="1F2429"/>
+                </a:solidFill>
+                <a:latin typeface="Calibri" pitchFamily="34" charset="0"/>
+                <a:ea typeface="Calibri" pitchFamily="34" charset="-122"/>
+                <a:cs typeface="Calibri" pitchFamily="34" charset="-120"/>
+              </a:rPr>
+              <a:t>A new daily transfer limit is introduced; the rule is copied into 500 separate client installs</a:t>
+            </a:r>
+            <a:endParaRPr lang="en-US" sz="1800" dirty="0"/>
+          </a:p>
+          <a:p>
+            <a:pPr marL="342900" indent="-342900">
+              <a:spcAft>
+                <a:spcPts val="1800"/>
+              </a:spcAft>
+              <a:buSzPct val="100000"/>
+              <a:buChar char="•"/>
+            </a:pPr>
+            <a:r>
+              <a:rPr lang="en-US" sz="1800" dirty="0">
+                <a:solidFill>
+                  <a:srgbClr val="1F2429"/>
+                </a:solidFill>
+                <a:latin typeface="Calibri" pitchFamily="34" charset="0"/>
+                <a:ea typeface="Calibri" pitchFamily="34" charset="-122"/>
+                <a:cs typeface="Calibri" pitchFamily="34" charset="-120"/>
+              </a:rPr>
+              <a:t>Every one of those installs must be updated and tested — the same rule now lives in 500 places</a:t>
+            </a:r>
+            <a:endParaRPr lang="en-US" sz="1800" dirty="0"/>
+          </a:p>
+          <a:p>
+            <a:pPr marL="342900" indent="-342900">
+              <a:spcAft>
+                <a:spcPts val="1800"/>
+              </a:spcAft>
+              <a:buSzPct val="100000"/>
+              <a:buChar char="•"/>
+            </a:pPr>
+            <a:r>
+              <a:rPr lang="en-US" sz="1800" dirty="0">
+                <a:solidFill>
+                  <a:srgbClr val="1F2429"/>
+                </a:solidFill>
+                <a:latin typeface="Calibri" pitchFamily="34" charset="0"/>
+                <a:ea typeface="Calibri" pitchFamily="34" charset="-122"/>
+                <a:cs typeface="Calibri" pitchFamily="34" charset="-120"/>
+              </a:rPr>
+              <a:t>Growing to 5,000 users multiplies each of these costs, and the server's connection load with them</a:t>
+            </a:r>
+            <a:endParaRPr lang="en-US" sz="1800" dirty="0"/>
+          </a:p>
+        </p:txBody>
+      </p:sp>
+    </p:spTree>
+  </p:cSld>
+  <p:clrMapOvr>
+    <a:masterClrMapping/>
+  </p:clrMapOvr>
+</p:sld>
+</file>
+
+<file path=ppt/slides/slide14.xml><?xml version="1.0" encoding="utf-8"?>
+<p:sld xmlns:a="http://schemas.openxmlformats.org/drawingml/2006/main" xmlns:r="http://schemas.openxmlformats.org/officeDocument/2006/relationships" xmlns:p="http://schemas.openxmlformats.org/presentationml/2006/main">
+  <p:cSld name="Slide 2">
+    <p:bg>
+      <p:bgPr>
+        <a:solidFill>
+          <a:srgbClr val="F7F8F9"/>
+        </a:solidFill>
+      </p:bgPr>
+    </p:bg>
+    <p:spTree>
+      <p:nvGrpSpPr>
+        <p:cNvPr id="1" name=""/>
+        <p:cNvGrpSpPr/>
+        <p:nvPr/>
+      </p:nvGrpSpPr>
+      <p:grpSpPr>
+        <a:xfrm>
+          <a:off x="0" y="0"/>
+          <a:ext cx="0" cy="0"/>
+          <a:chOff x="0" y="0"/>
+          <a:chExt cx="0" cy="0"/>
+        </a:xfrm>
+      </p:grpSpPr>
+      <p:sp>
+        <p:nvSpPr>
+          <p:cNvPr id="2" name="Text 0"/>
+          <p:cNvSpPr txBox="1"/>
+          <p:nvPr/>
+        </p:nvSpPr>
+        <p:spPr>
+          <a:xfrm>
+            <a:off x="548640" y="365760"/>
+            <a:ext cx="11064240" cy="731520"/>
+          </a:xfrm>
+          <a:prstGeom prst="rect">
+            <a:avLst/>
+          </a:prstGeom>
+          <a:noFill/>
+          <a:ln/>
+        </p:spPr>
+        <p:txBody>
+          <a:bodyPr wrap="square" lIns="0" tIns="0" rIns="0" bIns="0" rtlCol="0" anchor="ctr"/>
+          <a:lstStyle/>
+          <a:p>
+            <a:pPr indent="0" marL="0">
+              <a:buNone/>
+            </a:pPr>
+            <a:r>
+              <a:rPr lang="en-US" sz="2800" b="1" dirty="0">
+                <a:solidFill>
+                  <a:srgbClr val="1F2429"/>
+                </a:solidFill>
+                <a:latin typeface="Calibri" pitchFamily="34" charset="0"/>
+                <a:ea typeface="Calibri" pitchFamily="34" charset="-122"/>
+                <a:cs typeface="Calibri" pitchFamily="34" charset="-120"/>
+              </a:rPr>
+              <a:t>Three-Tier, Step by Step: A Transfer Request</a:t>
+            </a:r>
+            <a:endParaRPr lang="en-US" sz="2800" dirty="0"/>
+          </a:p>
+        </p:txBody>
+      </p:sp>
+      <p:sp>
+        <p:nvSpPr>
+          <p:cNvPr id="3" name="Text 1"/>
+          <p:cNvSpPr txBox="1"/>
+          <p:nvPr/>
+        </p:nvSpPr>
+        <p:spPr>
+          <a:xfrm>
+            <a:off x="9951415" y="6455664"/>
+            <a:ext cx="2011680" cy="292608"/>
+          </a:xfrm>
+          <a:prstGeom prst="rect">
+            <a:avLst/>
+          </a:prstGeom>
+          <a:noFill/>
+          <a:ln/>
+        </p:spPr>
+        <p:txBody>
+          <a:bodyPr wrap="square" lIns="0" tIns="0" rIns="0" bIns="0" rtlCol="0" anchor="ctr"/>
+          <a:lstStyle/>
+          <a:p>
+            <a:pPr algn="r" indent="0" marL="0">
+              <a:buNone/>
+            </a:pPr>
+            <a:r>
+              <a:rPr lang="en-US" sz="1200" u="sng" dirty="0">
+                <a:solidFill>
+                  <a:srgbClr val="8A939B"/>
+                </a:solidFill>
+                <a:latin typeface="Calibri" pitchFamily="34" charset="0"/>
+                <a:ea typeface="Calibri" pitchFamily="34" charset="-122"/>
+                <a:cs typeface="Calibri" pitchFamily="34" charset="-120"/>
+                <a:hlinkClick r:id="rId1" invalidUrl="" action="" tgtFrame="" tooltip="" history="1" highlightClick="0" endSnd="0">
+                  <a:extLst>
+                    <a:ext uri="{A12FA001-AC4F-418D-AE19-62706E023703}">
+                      <ahyp:hlinkClr xmlns:ahyp="http://schemas.microsoft.com/office/drawing/2018/hyperlinkcolor" val="tx"/>
+                    </a:ext>
+                  </a:extLst>
+                </a:hlinkClick>
+              </a:rPr>
+              <a:t>cuinotes.com</a:t>
+            </a:r>
+            <a:pPr algn="r" indent="0" marL="0">
+              <a:buNone/>
+            </a:pPr>
+            <a:r>
+              <a:rPr lang="en-US" sz="1200" dirty="0">
+                <a:solidFill>
+                  <a:srgbClr val="8A939B"/>
+                </a:solidFill>
+                <a:latin typeface="Calibri" pitchFamily="34" charset="0"/>
+                <a:ea typeface="Calibri" pitchFamily="34" charset="-122"/>
+                <a:cs typeface="Calibri" pitchFamily="34" charset="-120"/>
+              </a:rPr>
+              <a:t>  ·  7</a:t>
+            </a:r>
+            <a:endParaRPr lang="en-US" sz="1200" dirty="0"/>
+          </a:p>
+        </p:txBody>
+      </p:sp>
+      <p:sp>
+        <p:nvSpPr>
+          <p:cNvPr id="4" name="Text 2"/>
+          <p:cNvSpPr txBox="1"/>
+          <p:nvPr/>
+        </p:nvSpPr>
+        <p:spPr>
+          <a:xfrm>
+            <a:off x="640080" y="1371600"/>
+            <a:ext cx="10332720" cy="4846320"/>
+          </a:xfrm>
+          <a:prstGeom prst="rect">
+            <a:avLst/>
+          </a:prstGeom>
+          <a:noFill/>
+          <a:ln/>
+        </p:spPr>
+        <p:txBody>
+          <a:bodyPr wrap="square" lIns="0" tIns="0" rIns="0" bIns="0" rtlCol="0" anchor="t"/>
+          <a:lstStyle/>
+          <a:p>
+            <a:pPr marL="342900" indent="-342900">
+              <a:spcAft>
+                <a:spcPts val="1800"/>
+              </a:spcAft>
+              <a:buSzPct val="100000"/>
+              <a:buChar char="•"/>
+            </a:pPr>
+            <a:r>
+              <a:rPr lang="en-US" sz="1800" dirty="0">
+                <a:solidFill>
+                  <a:srgbClr val="1F2429"/>
+                </a:solidFill>
+                <a:latin typeface="Calibri" pitchFamily="34" charset="0"/>
+                <a:ea typeface="Calibri" pitchFamily="34" charset="-122"/>
+                <a:cs typeface="Calibri" pitchFamily="34" charset="-120"/>
+              </a:rPr>
+              <a:t>The customer clicks Transfer in the browser; the presentation tier only shows the form</a:t>
+            </a:r>
+            <a:endParaRPr lang="en-US" sz="1800" dirty="0"/>
+          </a:p>
+          <a:p>
+            <a:pPr marL="342900" indent="-342900">
+              <a:spcAft>
+                <a:spcPts val="1800"/>
+              </a:spcAft>
+              <a:buSzPct val="100000"/>
+              <a:buChar char="•"/>
+            </a:pPr>
+            <a:r>
+              <a:rPr lang="en-US" sz="1800" dirty="0">
+                <a:solidFill>
+                  <a:srgbClr val="1F2429"/>
+                </a:solidFill>
+                <a:latin typeface="Calibri" pitchFamily="34" charset="0"/>
+                <a:ea typeface="Calibri" pitchFamily="34" charset="-122"/>
+                <a:cs typeface="Calibri" pitchFamily="34" charset="-120"/>
+              </a:rPr>
+              <a:t>The request reaches the application server, which checks the daily transfer limit and the available balance</a:t>
+            </a:r>
+            <a:endParaRPr lang="en-US" sz="1800" dirty="0"/>
+          </a:p>
+          <a:p>
+            <a:pPr marL="342900" indent="-342900">
+              <a:spcAft>
+                <a:spcPts val="1800"/>
+              </a:spcAft>
+              <a:buSzPct val="100000"/>
+              <a:buChar char="•"/>
+            </a:pPr>
+            <a:r>
+              <a:rPr lang="en-US" sz="1800" dirty="0">
+                <a:solidFill>
+                  <a:srgbClr val="1F2429"/>
+                </a:solidFill>
+                <a:latin typeface="Calibri" pitchFamily="34" charset="0"/>
+                <a:ea typeface="Calibri" pitchFamily="34" charset="-122"/>
+                <a:cs typeface="Calibri" pitchFamily="34" charset="-120"/>
+              </a:rPr>
+              <a:t>Only if the rules pass does the application server ask the database server to update the two accounts</a:t>
+            </a:r>
+            <a:endParaRPr lang="en-US" sz="1800" dirty="0"/>
+          </a:p>
+          <a:p>
+            <a:pPr marL="342900" indent="-342900">
+              <a:spcAft>
+                <a:spcPts val="1800"/>
+              </a:spcAft>
+              <a:buSzPct val="100000"/>
+              <a:buChar char="•"/>
+            </a:pPr>
+            <a:r>
+              <a:rPr lang="en-US" sz="1800" dirty="0">
+                <a:solidFill>
+                  <a:srgbClr val="1F2429"/>
+                </a:solidFill>
+                <a:latin typeface="Calibri" pitchFamily="34" charset="0"/>
+                <a:ea typeface="Calibri" pitchFamily="34" charset="-122"/>
+                <a:cs typeface="Calibri" pitchFamily="34" charset="-120"/>
+              </a:rPr>
+              <a:t>The database server applies both changes in one transaction and returns a confirmation</a:t>
+            </a:r>
+            <a:endParaRPr lang="en-US" sz="1800" dirty="0"/>
+          </a:p>
+          <a:p>
+            <a:pPr marL="342900" indent="-342900">
+              <a:spcAft>
+                <a:spcPts val="1800"/>
+              </a:spcAft>
+              <a:buSzPct val="100000"/>
+              <a:buChar char="•"/>
+            </a:pPr>
+            <a:r>
+              <a:rPr lang="en-US" sz="1800" dirty="0">
+                <a:solidFill>
+                  <a:srgbClr val="1F2429"/>
+                </a:solidFill>
+                <a:latin typeface="Calibri" pitchFamily="34" charset="0"/>
+                <a:ea typeface="Calibri" pitchFamily="34" charset="-122"/>
+                <a:cs typeface="Calibri" pitchFamily="34" charset="-120"/>
+              </a:rPr>
+              <a:t>The application server sends the confirmation back, and the browser displays it</a:t>
+            </a:r>
+            <a:endParaRPr lang="en-US" sz="1800" dirty="0"/>
+          </a:p>
+          <a:p>
+            <a:pPr marL="342900" indent="-342900">
+              <a:spcAft>
+                <a:spcPts val="1800"/>
+              </a:spcAft>
+              <a:buSzPct val="100000"/>
+              <a:buChar char="•"/>
+            </a:pPr>
+            <a:r>
+              <a:rPr lang="en-US" sz="1800" dirty="0">
+                <a:solidFill>
+                  <a:srgbClr val="1F2429"/>
+                </a:solidFill>
+                <a:latin typeface="Calibri" pitchFamily="34" charset="0"/>
+                <a:ea typeface="Calibri" pitchFamily="34" charset="-122"/>
+                <a:cs typeface="Calibri" pitchFamily="34" charset="-120"/>
+              </a:rPr>
+              <a:t>The database never faces the public internet — only trusted application servers talk to it</a:t>
+            </a:r>
+            <a:endParaRPr lang="en-US" sz="1800" dirty="0"/>
+          </a:p>
+        </p:txBody>
+      </p:sp>
+    </p:spTree>
+  </p:cSld>
+  <p:clrMapOvr>
+    <a:masterClrMapping/>
+  </p:clrMapOvr>
+</p:sld>
+</file>
+
+<file path=ppt/slides/slide15.xml><?xml version="1.0" encoding="utf-8"?>
+<p:sld xmlns:a="http://schemas.openxmlformats.org/drawingml/2006/main" xmlns:r="http://schemas.openxmlformats.org/officeDocument/2006/relationships" xmlns:p="http://schemas.openxmlformats.org/presentationml/2006/main">
+  <p:cSld name="Slide 2">
+    <p:bg>
+      <p:bgPr>
+        <a:solidFill>
+          <a:srgbClr val="F7F8F9"/>
+        </a:solidFill>
+      </p:bgPr>
+    </p:bg>
+    <p:spTree>
+      <p:nvGrpSpPr>
+        <p:cNvPr id="1" name=""/>
+        <p:cNvGrpSpPr/>
+        <p:nvPr/>
+      </p:nvGrpSpPr>
+      <p:grpSpPr>
+        <a:xfrm>
+          <a:off x="0" y="0"/>
+          <a:ext cx="0" cy="0"/>
+          <a:chOff x="0" y="0"/>
+          <a:chExt cx="0" cy="0"/>
+        </a:xfrm>
+      </p:grpSpPr>
+      <p:sp>
+        <p:nvSpPr>
+          <p:cNvPr id="2" name="Text 0"/>
+          <p:cNvSpPr txBox="1"/>
+          <p:nvPr/>
+        </p:nvSpPr>
+        <p:spPr>
+          <a:xfrm>
+            <a:off x="548640" y="365760"/>
+            <a:ext cx="11064240" cy="731520"/>
+          </a:xfrm>
+          <a:prstGeom prst="rect">
+            <a:avLst/>
+          </a:prstGeom>
+          <a:noFill/>
+          <a:ln/>
+        </p:spPr>
+        <p:txBody>
+          <a:bodyPr wrap="square" lIns="0" tIns="0" rIns="0" bIns="0" rtlCol="0" anchor="ctr"/>
+          <a:lstStyle/>
+          <a:p>
+            <a:pPr indent="0" marL="0">
+              <a:buNone/>
+            </a:pPr>
+            <a:r>
+              <a:rPr lang="en-US" sz="2800" b="1" dirty="0">
+                <a:solidFill>
+                  <a:srgbClr val="1F2429"/>
+                </a:solidFill>
+                <a:latin typeface="Calibri" pitchFamily="34" charset="0"/>
+                <a:ea typeface="Calibri" pitchFamily="34" charset="-122"/>
+                <a:cs typeface="Calibri" pitchFamily="34" charset="-120"/>
+              </a:rPr>
+              <a:t>The Three Levels, One Student Record</a:t>
+            </a:r>
+            <a:endParaRPr lang="en-US" sz="2800" dirty="0"/>
+          </a:p>
+        </p:txBody>
+      </p:sp>
+      <p:sp>
+        <p:nvSpPr>
+          <p:cNvPr id="3" name="Text 1"/>
+          <p:cNvSpPr txBox="1"/>
+          <p:nvPr/>
+        </p:nvSpPr>
+        <p:spPr>
+          <a:xfrm>
+            <a:off x="9951415" y="6455664"/>
+            <a:ext cx="2011680" cy="292608"/>
+          </a:xfrm>
+          <a:prstGeom prst="rect">
+            <a:avLst/>
+          </a:prstGeom>
+          <a:noFill/>
+          <a:ln/>
+        </p:spPr>
+        <p:txBody>
+          <a:bodyPr wrap="square" lIns="0" tIns="0" rIns="0" bIns="0" rtlCol="0" anchor="ctr"/>
+          <a:lstStyle/>
+          <a:p>
+            <a:pPr algn="r" indent="0" marL="0">
+              <a:buNone/>
+            </a:pPr>
+            <a:r>
+              <a:rPr lang="en-US" sz="1200" u="sng" dirty="0">
+                <a:solidFill>
+                  <a:srgbClr val="8A939B"/>
+                </a:solidFill>
+                <a:latin typeface="Calibri" pitchFamily="34" charset="0"/>
+                <a:ea typeface="Calibri" pitchFamily="34" charset="-122"/>
+                <a:cs typeface="Calibri" pitchFamily="34" charset="-120"/>
+                <a:hlinkClick r:id="rId1" invalidUrl="" action="" tgtFrame="" tooltip="" history="1" highlightClick="0" endSnd="0">
+                  <a:extLst>
+                    <a:ext uri="{A12FA001-AC4F-418D-AE19-62706E023703}">
+                      <ahyp:hlinkClr xmlns:ahyp="http://schemas.microsoft.com/office/drawing/2018/hyperlinkcolor" val="tx"/>
+                    </a:ext>
+                  </a:extLst>
+                </a:hlinkClick>
+              </a:rPr>
+              <a:t>cuinotes.com</a:t>
+            </a:r>
+            <a:pPr algn="r" indent="0" marL="0">
+              <a:buNone/>
+            </a:pPr>
+            <a:r>
+              <a:rPr lang="en-US" sz="1200" dirty="0">
+                <a:solidFill>
+                  <a:srgbClr val="8A939B"/>
+                </a:solidFill>
+                <a:latin typeface="Calibri" pitchFamily="34" charset="0"/>
+                <a:ea typeface="Calibri" pitchFamily="34" charset="-122"/>
+                <a:cs typeface="Calibri" pitchFamily="34" charset="-120"/>
+              </a:rPr>
+              <a:t>  ·  9</a:t>
+            </a:r>
+            <a:endParaRPr lang="en-US" sz="1200" dirty="0"/>
+          </a:p>
+        </p:txBody>
+      </p:sp>
+      <p:sp>
+        <p:nvSpPr>
+          <p:cNvPr id="4" name="Text 2"/>
+          <p:cNvSpPr txBox="1"/>
+          <p:nvPr/>
+        </p:nvSpPr>
+        <p:spPr>
+          <a:xfrm>
+            <a:off x="640080" y="1371600"/>
+            <a:ext cx="10332720" cy="4846320"/>
+          </a:xfrm>
+          <a:prstGeom prst="rect">
+            <a:avLst/>
+          </a:prstGeom>
+          <a:noFill/>
+          <a:ln/>
+        </p:spPr>
+        <p:txBody>
+          <a:bodyPr wrap="square" lIns="0" tIns="0" rIns="0" bIns="0" rtlCol="0" anchor="t"/>
+          <a:lstStyle/>
+          <a:p>
+            <a:pPr marL="342900" indent="-342900">
+              <a:spcAft>
+                <a:spcPts val="1800"/>
+              </a:spcAft>
+              <a:buSzPct val="100000"/>
+              <a:buChar char="•"/>
+            </a:pPr>
+            <a:r>
+              <a:rPr lang="en-US" sz="1800" dirty="0">
+                <a:solidFill>
+                  <a:srgbClr val="1F2429"/>
+                </a:solidFill>
+                <a:latin typeface="Calibri" pitchFamily="34" charset="0"/>
+                <a:ea typeface="Calibri" pitchFamily="34" charset="-122"/>
+                <a:cs typeface="Calibri" pitchFamily="34" charset="-120"/>
+              </a:rPr>
+              <a:t>Data tier: one physical copy of the record sits in a B-tree-indexed file ordered by studentId</a:t>
+            </a:r>
+            <a:endParaRPr lang="en-US" sz="1800" dirty="0"/>
+          </a:p>
+          <a:p>
+            <a:pPr marL="342900" indent="-342900">
+              <a:spcAft>
+                <a:spcPts val="1800"/>
+              </a:spcAft>
+              <a:buSzPct val="100000"/>
+              <a:buChar char="•"/>
+            </a:pPr>
+            <a:r>
+              <a:rPr lang="en-US" sz="1800" dirty="0">
+                <a:solidFill>
+                  <a:srgbClr val="1F2429"/>
+                </a:solidFill>
+                <a:latin typeface="Calibri" pitchFamily="34" charset="0"/>
+                <a:ea typeface="Calibri" pitchFamily="34" charset="-122"/>
+                <a:cs typeface="Calibri" pitchFamily="34" charset="-120"/>
+              </a:rPr>
+              <a:t>Conceptual level: the same record is a Student tuple with studentId, name, cnic, and program, plus its business rules</a:t>
+            </a:r>
+            <a:endParaRPr lang="en-US" sz="1800" dirty="0"/>
+          </a:p>
+          <a:p>
+            <a:pPr marL="342900" indent="-342900">
+              <a:spcAft>
+                <a:spcPts val="1800"/>
+              </a:spcAft>
+              <a:buSzPct val="100000"/>
+              <a:buChar char="•"/>
+            </a:pPr>
+            <a:r>
+              <a:rPr lang="en-US" sz="1800" dirty="0">
+                <a:solidFill>
+                  <a:srgbClr val="1F2429"/>
+                </a:solidFill>
+                <a:latin typeface="Calibri" pitchFamily="34" charset="0"/>
+                <a:ea typeface="Calibri" pitchFamily="34" charset="-122"/>
+                <a:cs typeface="Calibri" pitchFamily="34" charset="-120"/>
+              </a:rPr>
+              <a:t>External level, Course Advisor: the same record appears only as StudentName and Grade for one course</a:t>
+            </a:r>
+            <a:endParaRPr lang="en-US" sz="1800" dirty="0"/>
+          </a:p>
+          <a:p>
+            <a:pPr marL="342900" indent="-342900">
+              <a:spcAft>
+                <a:spcPts val="1800"/>
+              </a:spcAft>
+              <a:buSzPct val="100000"/>
+              <a:buChar char="•"/>
+            </a:pPr>
+            <a:r>
+              <a:rPr lang="en-US" sz="1800" dirty="0">
+                <a:solidFill>
+                  <a:srgbClr val="1F2429"/>
+                </a:solidFill>
+                <a:latin typeface="Calibri" pitchFamily="34" charset="0"/>
+                <a:ea typeface="Calibri" pitchFamily="34" charset="-122"/>
+                <a:cs typeface="Calibri" pitchFamily="34" charset="-120"/>
+              </a:rPr>
+              <a:t>The advisor's view never shows cnic — yet every value on screen still comes from that one stored record</a:t>
+            </a:r>
+            <a:endParaRPr lang="en-US" sz="1800" dirty="0"/>
+          </a:p>
+          <a:p>
+            <a:pPr marL="342900" indent="-342900">
+              <a:spcAft>
+                <a:spcPts val="1800"/>
+              </a:spcAft>
+              <a:buSzPct val="100000"/>
+              <a:buChar char="•"/>
+            </a:pPr>
+            <a:r>
+              <a:rPr lang="en-US" sz="1800" dirty="0">
+                <a:solidFill>
+                  <a:srgbClr val="1F2429"/>
+                </a:solidFill>
+                <a:latin typeface="Calibri" pitchFamily="34" charset="0"/>
+                <a:ea typeface="Calibri" pitchFamily="34" charset="-122"/>
+                <a:cs typeface="Calibri" pitchFamily="34" charset="-120"/>
+              </a:rPr>
+              <a:t>Changing the record changes the one copy; each level simply describes that copy differently</a:t>
+            </a:r>
+            <a:endParaRPr lang="en-US" sz="1800" dirty="0"/>
+          </a:p>
+        </p:txBody>
+      </p:sp>
+    </p:spTree>
+  </p:cSld>
+  <p:clrMapOvr>
+    <a:masterClrMapping/>
+  </p:clrMapOvr>
+</p:sld>
+</file>
+
+<file path=ppt/slides/slide16.xml><?xml version="1.0" encoding="utf-8"?>
+<p:sld xmlns:a="http://schemas.openxmlformats.org/drawingml/2006/main" xmlns:r="http://schemas.openxmlformats.org/officeDocument/2006/relationships" xmlns:p="http://schemas.openxmlformats.org/presentationml/2006/main">
+  <p:cSld name="Slide 2">
+    <p:bg>
+      <p:bgPr>
+        <a:solidFill>
+          <a:srgbClr val="F7F8F9"/>
+        </a:solidFill>
+      </p:bgPr>
+    </p:bg>
+    <p:spTree>
+      <p:nvGrpSpPr>
+        <p:cNvPr id="1" name=""/>
+        <p:cNvGrpSpPr/>
+        <p:nvPr/>
+      </p:nvGrpSpPr>
+      <p:grpSpPr>
+        <a:xfrm>
+          <a:off x="0" y="0"/>
+          <a:ext cx="0" cy="0"/>
+          <a:chOff x="0" y="0"/>
+          <a:chExt cx="0" cy="0"/>
+        </a:xfrm>
+      </p:grpSpPr>
+      <p:sp>
+        <p:nvSpPr>
+          <p:cNvPr id="2" name="Text 0"/>
+          <p:cNvSpPr txBox="1"/>
+          <p:nvPr/>
+        </p:nvSpPr>
+        <p:spPr>
+          <a:xfrm>
+            <a:off x="548640" y="365760"/>
+            <a:ext cx="11064240" cy="731520"/>
+          </a:xfrm>
+          <a:prstGeom prst="rect">
+            <a:avLst/>
+          </a:prstGeom>
+          <a:noFill/>
+          <a:ln/>
+        </p:spPr>
+        <p:txBody>
+          <a:bodyPr wrap="square" lIns="0" tIns="0" rIns="0" bIns="0" rtlCol="0" anchor="ctr"/>
+          <a:lstStyle/>
+          <a:p>
+            <a:pPr indent="0" marL="0">
+              <a:buNone/>
+            </a:pPr>
+            <a:r>
+              <a:rPr lang="en-US" sz="2800" b="1" dirty="0">
+                <a:solidFill>
+                  <a:srgbClr val="1F2429"/>
+                </a:solidFill>
+                <a:latin typeface="Calibri" pitchFamily="34" charset="0"/>
+                <a:ea typeface="Calibri" pitchFamily="34" charset="-122"/>
+                <a:cs typeface="Calibri" pitchFamily="34" charset="-120"/>
+              </a:rPr>
+              <a:t>Why Not Just Give Everyone the Full Schema?</a:t>
+            </a:r>
+            <a:endParaRPr lang="en-US" sz="2800" dirty="0"/>
+          </a:p>
+        </p:txBody>
+      </p:sp>
+      <p:sp>
+        <p:nvSpPr>
+          <p:cNvPr id="3" name="Text 1"/>
+          <p:cNvSpPr txBox="1"/>
+          <p:nvPr/>
+        </p:nvSpPr>
+        <p:spPr>
+          <a:xfrm>
+            <a:off x="9951415" y="6455664"/>
+            <a:ext cx="2011680" cy="292608"/>
+          </a:xfrm>
+          <a:prstGeom prst="rect">
+            <a:avLst/>
+          </a:prstGeom>
+          <a:noFill/>
+          <a:ln/>
+        </p:spPr>
+        <p:txBody>
+          <a:bodyPr wrap="square" lIns="0" tIns="0" rIns="0" bIns="0" rtlCol="0" anchor="ctr"/>
+          <a:lstStyle/>
+          <a:p>
+            <a:pPr algn="r" indent="0" marL="0">
+              <a:buNone/>
+            </a:pPr>
+            <a:r>
+              <a:rPr lang="en-US" sz="1200" u="sng" dirty="0">
+                <a:solidFill>
+                  <a:srgbClr val="8A939B"/>
+                </a:solidFill>
+                <a:latin typeface="Calibri" pitchFamily="34" charset="0"/>
+                <a:ea typeface="Calibri" pitchFamily="34" charset="-122"/>
+                <a:cs typeface="Calibri" pitchFamily="34" charset="-120"/>
+                <a:hlinkClick r:id="rId1" invalidUrl="" action="" tgtFrame="" tooltip="" history="1" highlightClick="0" endSnd="0">
+                  <a:extLst>
+                    <a:ext uri="{A12FA001-AC4F-418D-AE19-62706E023703}">
+                      <ahyp:hlinkClr xmlns:ahyp="http://schemas.microsoft.com/office/drawing/2018/hyperlinkcolor" val="tx"/>
+                    </a:ext>
+                  </a:extLst>
+                </a:hlinkClick>
+              </a:rPr>
+              <a:t>cuinotes.com</a:t>
+            </a:r>
+            <a:pPr algn="r" indent="0" marL="0">
+              <a:buNone/>
+            </a:pPr>
+            <a:r>
+              <a:rPr lang="en-US" sz="1200" dirty="0">
+                <a:solidFill>
+                  <a:srgbClr val="8A939B"/>
+                </a:solidFill>
+                <a:latin typeface="Calibri" pitchFamily="34" charset="0"/>
+                <a:ea typeface="Calibri" pitchFamily="34" charset="-122"/>
+                <a:cs typeface="Calibri" pitchFamily="34" charset="-120"/>
+              </a:rPr>
               <a:t>  ·  11</a:t>
             </a:r>
-            <a:endParaRPr lang="en-US" sz="1000" dirty="0"/>
+            <a:endParaRPr lang="en-US" sz="1200" dirty="0"/>
+          </a:p>
+        </p:txBody>
+      </p:sp>
+      <p:sp>
+        <p:nvSpPr>
+          <p:cNvPr id="4" name="Text 2"/>
+          <p:cNvSpPr txBox="1"/>
+          <p:nvPr/>
+        </p:nvSpPr>
+        <p:spPr>
+          <a:xfrm>
+            <a:off x="640080" y="1371600"/>
+            <a:ext cx="10332720" cy="4846320"/>
+          </a:xfrm>
+          <a:prstGeom prst="rect">
+            <a:avLst/>
+          </a:prstGeom>
+          <a:noFill/>
+          <a:ln/>
+        </p:spPr>
+        <p:txBody>
+          <a:bodyPr wrap="square" lIns="0" tIns="0" rIns="0" bIns="0" rtlCol="0" anchor="t"/>
+          <a:lstStyle/>
+          <a:p>
+            <a:pPr marL="342900" indent="-342900">
+              <a:spcAft>
+                <a:spcPts val="1800"/>
+              </a:spcAft>
+              <a:buSzPct val="100000"/>
+              <a:buChar char="•"/>
+            </a:pPr>
+            <a:r>
+              <a:rPr lang="en-US" sz="1800" dirty="0">
+                <a:solidFill>
+                  <a:srgbClr val="1F2429"/>
+                </a:solidFill>
+                <a:latin typeface="Calibri" pitchFamily="34" charset="0"/>
+                <a:ea typeface="Calibri" pitchFamily="34" charset="-122"/>
+                <a:cs typeface="Calibri" pitchFamily="34" charset="-120"/>
+              </a:rPr>
+              <a:t>Security: the Course Advisor should never see Student.cnic or Instructor.salary</a:t>
+            </a:r>
+            <a:endParaRPr lang="en-US" sz="1800" dirty="0"/>
+          </a:p>
+          <a:p>
+            <a:pPr marL="342900" indent="-342900">
+              <a:spcAft>
+                <a:spcPts val="1800"/>
+              </a:spcAft>
+              <a:buSzPct val="100000"/>
+              <a:buChar char="•"/>
+            </a:pPr>
+            <a:r>
+              <a:rPr lang="en-US" sz="1800" dirty="0">
+                <a:solidFill>
+                  <a:srgbClr val="1F2429"/>
+                </a:solidFill>
+                <a:latin typeface="Calibri" pitchFamily="34" charset="0"/>
+                <a:ea typeface="Calibri" pitchFamily="34" charset="-122"/>
+                <a:cs typeface="Calibri" pitchFamily="34" charset="-120"/>
+              </a:rPr>
+              <a:t>Simplicity: a view shows only the fields one group needs, reshaped for its task</a:t>
+            </a:r>
+            <a:endParaRPr lang="en-US" sz="1800" dirty="0"/>
+          </a:p>
+          <a:p>
+            <a:pPr marL="342900" indent="-342900">
+              <a:spcAft>
+                <a:spcPts val="1800"/>
+              </a:spcAft>
+              <a:buSzPct val="100000"/>
+              <a:buChar char="•"/>
+            </a:pPr>
+            <a:r>
+              <a:rPr lang="en-US" sz="1800" dirty="0">
+                <a:solidFill>
+                  <a:srgbClr val="1F2429"/>
+                </a:solidFill>
+                <a:latin typeface="Calibri" pitchFamily="34" charset="0"/>
+                <a:ea typeface="Calibri" pitchFamily="34" charset="-122"/>
+                <a:cs typeface="Calibri" pitchFamily="34" charset="-120"/>
+              </a:rPr>
+              <a:t>Stability: an external schema built for the advisor keeps working when the conceptual schema grows elsewhere</a:t>
+            </a:r>
+            <a:endParaRPr lang="en-US" sz="1800" dirty="0"/>
+          </a:p>
+          <a:p>
+            <a:pPr marL="342900" indent="-342900">
+              <a:spcAft>
+                <a:spcPts val="1800"/>
+              </a:spcAft>
+              <a:buSzPct val="100000"/>
+              <a:buChar char="•"/>
+            </a:pPr>
+            <a:r>
+              <a:rPr lang="en-US" sz="1800" dirty="0">
+                <a:solidFill>
+                  <a:srgbClr val="1F2429"/>
+                </a:solidFill>
+                <a:latin typeface="Calibri" pitchFamily="34" charset="0"/>
+                <a:ea typeface="Calibri" pitchFamily="34" charset="-122"/>
+                <a:cs typeface="Calibri" pitchFamily="34" charset="-120"/>
+              </a:rPr>
+              <a:t>Privacy: restricting a view is one rule, far more reliable than asking every program to hide fields</a:t>
+            </a:r>
+            <a:endParaRPr lang="en-US" sz="1800" dirty="0"/>
+          </a:p>
+          <a:p>
+            <a:pPr marL="342900" indent="-342900">
+              <a:spcAft>
+                <a:spcPts val="1800"/>
+              </a:spcAft>
+              <a:buSzPct val="100000"/>
+              <a:buChar char="•"/>
+            </a:pPr>
+            <a:r>
+              <a:rPr lang="en-US" sz="1800" dirty="0">
+                <a:solidFill>
+                  <a:srgbClr val="1F2429"/>
+                </a:solidFill>
+                <a:latin typeface="Calibri" pitchFamily="34" charset="0"/>
+                <a:ea typeface="Calibri" pitchFamily="34" charset="-122"/>
+                <a:cs typeface="Calibri" pitchFamily="34" charset="-120"/>
+              </a:rPr>
+              <a:t>The three-schema design makes these protections the default, not an extra step someone must remember</a:t>
+            </a:r>
+            <a:endParaRPr lang="en-US" sz="1800" dirty="0"/>
+          </a:p>
+        </p:txBody>
+      </p:sp>
+    </p:spTree>
+  </p:cSld>
+  <p:clrMapOvr>
+    <a:masterClrMapping/>
+  </p:clrMapOvr>
+</p:sld>
+</file>
+
+<file path=ppt/slides/slide17.xml><?xml version="1.0" encoding="utf-8"?>
+<p:sld xmlns:a="http://schemas.openxmlformats.org/drawingml/2006/main" xmlns:r="http://schemas.openxmlformats.org/officeDocument/2006/relationships" xmlns:p="http://schemas.openxmlformats.org/presentationml/2006/main">
+  <p:cSld name="Slide 2">
+    <p:bg>
+      <p:bgPr>
+        <a:solidFill>
+          <a:srgbClr val="F7F8F9"/>
+        </a:solidFill>
+      </p:bgPr>
+    </p:bg>
+    <p:spTree>
+      <p:nvGrpSpPr>
+        <p:cNvPr id="1" name=""/>
+        <p:cNvGrpSpPr/>
+        <p:nvPr/>
+      </p:nvGrpSpPr>
+      <p:grpSpPr>
+        <a:xfrm>
+          <a:off x="0" y="0"/>
+          <a:ext cx="0" cy="0"/>
+          <a:chOff x="0" y="0"/>
+          <a:chExt cx="0" cy="0"/>
+        </a:xfrm>
+      </p:grpSpPr>
+      <p:sp>
+        <p:nvSpPr>
+          <p:cNvPr id="2" name="Text 0"/>
+          <p:cNvSpPr txBox="1"/>
+          <p:nvPr/>
+        </p:nvSpPr>
+        <p:spPr>
+          <a:xfrm>
+            <a:off x="548640" y="365760"/>
+            <a:ext cx="11064240" cy="731520"/>
+          </a:xfrm>
+          <a:prstGeom prst="rect">
+            <a:avLst/>
+          </a:prstGeom>
+          <a:noFill/>
+          <a:ln/>
+        </p:spPr>
+        <p:txBody>
+          <a:bodyPr wrap="square" lIns="0" tIns="0" rIns="0" bIns="0" rtlCol="0" anchor="ctr"/>
+          <a:lstStyle/>
+          <a:p>
+            <a:pPr indent="0" marL="0">
+              <a:buNone/>
+            </a:pPr>
+            <a:r>
+              <a:rPr lang="en-US" sz="2800" b="1" dirty="0">
+                <a:solidFill>
+                  <a:srgbClr val="1F2429"/>
+                </a:solidFill>
+                <a:latin typeface="Calibri" pitchFamily="34" charset="0"/>
+                <a:ea typeface="Calibri" pitchFamily="34" charset="-122"/>
+                <a:cs typeface="Calibri" pitchFamily="34" charset="-120"/>
+              </a:rPr>
+              <a:t>Following One Request Through the Three Levels</a:t>
+            </a:r>
+            <a:endParaRPr lang="en-US" sz="2800" dirty="0"/>
+          </a:p>
+        </p:txBody>
+      </p:sp>
+      <p:sp>
+        <p:nvSpPr>
+          <p:cNvPr id="3" name="Text 1"/>
+          <p:cNvSpPr txBox="1"/>
+          <p:nvPr/>
+        </p:nvSpPr>
+        <p:spPr>
+          <a:xfrm>
+            <a:off x="9951415" y="6455664"/>
+            <a:ext cx="2011680" cy="292608"/>
+          </a:xfrm>
+          <a:prstGeom prst="rect">
+            <a:avLst/>
+          </a:prstGeom>
+          <a:noFill/>
+          <a:ln/>
+        </p:spPr>
+        <p:txBody>
+          <a:bodyPr wrap="square" lIns="0" tIns="0" rIns="0" bIns="0" rtlCol="0" anchor="ctr"/>
+          <a:lstStyle/>
+          <a:p>
+            <a:pPr algn="r" indent="0" marL="0">
+              <a:buNone/>
+            </a:pPr>
+            <a:r>
+              <a:rPr lang="en-US" sz="1200" u="sng" dirty="0">
+                <a:solidFill>
+                  <a:srgbClr val="8A939B"/>
+                </a:solidFill>
+                <a:latin typeface="Calibri" pitchFamily="34" charset="0"/>
+                <a:ea typeface="Calibri" pitchFamily="34" charset="-122"/>
+                <a:cs typeface="Calibri" pitchFamily="34" charset="-120"/>
+                <a:hlinkClick r:id="rId1" invalidUrl="" action="" tgtFrame="" tooltip="" history="1" highlightClick="0" endSnd="0">
+                  <a:extLst>
+                    <a:ext uri="{A12FA001-AC4F-418D-AE19-62706E023703}">
+                      <ahyp:hlinkClr xmlns:ahyp="http://schemas.microsoft.com/office/drawing/2018/hyperlinkcolor" val="tx"/>
+                    </a:ext>
+                  </a:extLst>
+                </a:hlinkClick>
+              </a:rPr>
+              <a:t>cuinotes.com</a:t>
+            </a:r>
+            <a:pPr algn="r" indent="0" marL="0">
+              <a:buNone/>
+            </a:pPr>
+            <a:r>
+              <a:rPr lang="en-US" sz="1200" dirty="0">
+                <a:solidFill>
+                  <a:srgbClr val="8A939B"/>
+                </a:solidFill>
+                <a:latin typeface="Calibri" pitchFamily="34" charset="0"/>
+                <a:ea typeface="Calibri" pitchFamily="34" charset="-122"/>
+                <a:cs typeface="Calibri" pitchFamily="34" charset="-120"/>
+              </a:rPr>
+              <a:t>  ·  13</a:t>
+            </a:r>
+            <a:endParaRPr lang="en-US" sz="1200" dirty="0"/>
+          </a:p>
+        </p:txBody>
+      </p:sp>
+      <p:sp>
+        <p:nvSpPr>
+          <p:cNvPr id="4" name="Text 2"/>
+          <p:cNvSpPr txBox="1"/>
+          <p:nvPr/>
+        </p:nvSpPr>
+        <p:spPr>
+          <a:xfrm>
+            <a:off x="640080" y="1371600"/>
+            <a:ext cx="10332720" cy="4846320"/>
+          </a:xfrm>
+          <a:prstGeom prst="rect">
+            <a:avLst/>
+          </a:prstGeom>
+          <a:noFill/>
+          <a:ln/>
+        </p:spPr>
+        <p:txBody>
+          <a:bodyPr wrap="square" lIns="0" tIns="0" rIns="0" bIns="0" rtlCol="0" anchor="t"/>
+          <a:lstStyle/>
+          <a:p>
+            <a:pPr marL="342900" indent="-342900">
+              <a:spcAft>
+                <a:spcPts val="1800"/>
+              </a:spcAft>
+              <a:buSzPct val="100000"/>
+              <a:buChar char="•"/>
+            </a:pPr>
+            <a:r>
+              <a:rPr lang="en-US" sz="1800" dirty="0">
+                <a:solidFill>
+                  <a:srgbClr val="1F2429"/>
+                </a:solidFill>
+                <a:latin typeface="Calibri" pitchFamily="34" charset="0"/>
+                <a:ea typeface="Calibri" pitchFamily="34" charset="-122"/>
+                <a:cs typeface="Calibri" pitchFamily="34" charset="-120"/>
+              </a:rPr>
+              <a:t>The Course Advisor's report asks for StudentName for student 2021-CS-14</a:t>
+            </a:r>
+            <a:endParaRPr lang="en-US" sz="1800" dirty="0"/>
+          </a:p>
+          <a:p>
+            <a:pPr marL="342900" indent="-342900">
+              <a:spcAft>
+                <a:spcPts val="1800"/>
+              </a:spcAft>
+              <a:buSzPct val="100000"/>
+              <a:buChar char="•"/>
+            </a:pPr>
+            <a:r>
+              <a:rPr lang="en-US" sz="1800" dirty="0">
+                <a:solidFill>
+                  <a:srgbClr val="1F2429"/>
+                </a:solidFill>
+                <a:latin typeface="Calibri" pitchFamily="34" charset="0"/>
+                <a:ea typeface="Calibri" pitchFamily="34" charset="-122"/>
+                <a:cs typeface="Calibri" pitchFamily="34" charset="-120"/>
+              </a:rPr>
+              <a:t>External/conceptual mapping: StudentName is defined to mean Student.name in the conceptual schema</a:t>
+            </a:r>
+            <a:endParaRPr lang="en-US" sz="1800" dirty="0"/>
+          </a:p>
+          <a:p>
+            <a:pPr marL="342900" indent="-342900">
+              <a:spcAft>
+                <a:spcPts val="1800"/>
+              </a:spcAft>
+              <a:buSzPct val="100000"/>
+              <a:buChar char="•"/>
+            </a:pPr>
+            <a:r>
+              <a:rPr lang="en-US" sz="1800" dirty="0">
+                <a:solidFill>
+                  <a:srgbClr val="1F2429"/>
+                </a:solidFill>
+                <a:latin typeface="Calibri" pitchFamily="34" charset="0"/>
+                <a:ea typeface="Calibri" pitchFamily="34" charset="-122"/>
+                <a:cs typeface="Calibri" pitchFamily="34" charset="-120"/>
+              </a:rPr>
+              <a:t>Conceptual level: the DBMS identifies the Student tuple whose studentId is 2021-CS-14</a:t>
+            </a:r>
+            <a:endParaRPr lang="en-US" sz="1800" dirty="0"/>
+          </a:p>
+          <a:p>
+            <a:pPr marL="342900" indent="-342900">
+              <a:spcAft>
+                <a:spcPts val="1800"/>
+              </a:spcAft>
+              <a:buSzPct val="100000"/>
+              <a:buChar char="•"/>
+            </a:pPr>
+            <a:r>
+              <a:rPr lang="en-US" sz="1800" dirty="0">
+                <a:solidFill>
+                  <a:srgbClr val="1F2429"/>
+                </a:solidFill>
+                <a:latin typeface="Calibri" pitchFamily="34" charset="0"/>
+                <a:ea typeface="Calibri" pitchFamily="34" charset="-122"/>
+                <a:cs typeface="Calibri" pitchFamily="34" charset="-120"/>
+              </a:rPr>
+              <a:t>Conceptual/internal mapping: the DBMS finds where that tuple is stored, via the B-tree on studentId</a:t>
+            </a:r>
+            <a:endParaRPr lang="en-US" sz="1800" dirty="0"/>
+          </a:p>
+          <a:p>
+            <a:pPr marL="342900" indent="-342900">
+              <a:spcAft>
+                <a:spcPts val="1800"/>
+              </a:spcAft>
+              <a:buSzPct val="100000"/>
+              <a:buChar char="•"/>
+            </a:pPr>
+            <a:r>
+              <a:rPr lang="en-US" sz="1800" dirty="0">
+                <a:solidFill>
+                  <a:srgbClr val="1F2429"/>
+                </a:solidFill>
+                <a:latin typeface="Calibri" pitchFamily="34" charset="0"/>
+                <a:ea typeface="Calibri" pitchFamily="34" charset="-122"/>
+                <a:cs typeface="Calibri" pitchFamily="34" charset="-120"/>
+              </a:rPr>
+              <a:t>The stored name is read and returned, reshaped to the advisor's field name</a:t>
+            </a:r>
+            <a:endParaRPr lang="en-US" sz="1800" dirty="0"/>
+          </a:p>
+          <a:p>
+            <a:pPr marL="342900" indent="-342900">
+              <a:spcAft>
+                <a:spcPts val="1800"/>
+              </a:spcAft>
+              <a:buSzPct val="100000"/>
+              <a:buChar char="•"/>
+            </a:pPr>
+            <a:r>
+              <a:rPr lang="en-US" sz="1800" dirty="0">
+                <a:solidFill>
+                  <a:srgbClr val="1F2429"/>
+                </a:solidFill>
+                <a:latin typeface="Calibri" pitchFamily="34" charset="0"/>
+                <a:ea typeface="Calibri" pitchFamily="34" charset="-122"/>
+                <a:cs typeface="Calibri" pitchFamily="34" charset="-120"/>
+              </a:rPr>
+              <a:t>Each translation handled only its own boundary; no level needed the others' internal details</a:t>
+            </a:r>
+            <a:endParaRPr lang="en-US" sz="1800" dirty="0"/>
+          </a:p>
+        </p:txBody>
+      </p:sp>
+    </p:spTree>
+  </p:cSld>
+  <p:clrMapOvr>
+    <a:masterClrMapping/>
+  </p:clrMapOvr>
+</p:sld>
+</file>
+
+<file path=ppt/slides/slide18.xml><?xml version="1.0" encoding="utf-8"?>
+<p:sld xmlns:a="http://schemas.openxmlformats.org/drawingml/2006/main" xmlns:r="http://schemas.openxmlformats.org/officeDocument/2006/relationships" xmlns:p="http://schemas.openxmlformats.org/presentationml/2006/main">
+  <p:cSld name="Slide 2">
+    <p:bg>
+      <p:bgPr>
+        <a:solidFill>
+          <a:srgbClr val="F7F8F9"/>
+        </a:solidFill>
+      </p:bgPr>
+    </p:bg>
+    <p:spTree>
+      <p:nvGrpSpPr>
+        <p:cNvPr id="1" name=""/>
+        <p:cNvGrpSpPr/>
+        <p:nvPr/>
+      </p:nvGrpSpPr>
+      <p:grpSpPr>
+        <a:xfrm>
+          <a:off x="0" y="0"/>
+          <a:ext cx="0" cy="0"/>
+          <a:chOff x="0" y="0"/>
+          <a:chExt cx="0" cy="0"/>
+        </a:xfrm>
+      </p:grpSpPr>
+      <p:sp>
+        <p:nvSpPr>
+          <p:cNvPr id="2" name="Text 0"/>
+          <p:cNvSpPr txBox="1"/>
+          <p:nvPr/>
+        </p:nvSpPr>
+        <p:spPr>
+          <a:xfrm>
+            <a:off x="548640" y="365760"/>
+            <a:ext cx="11064240" cy="731520"/>
+          </a:xfrm>
+          <a:prstGeom prst="rect">
+            <a:avLst/>
+          </a:prstGeom>
+          <a:noFill/>
+          <a:ln/>
+        </p:spPr>
+        <p:txBody>
+          <a:bodyPr wrap="square" lIns="0" tIns="0" rIns="0" bIns="0" rtlCol="0" anchor="ctr"/>
+          <a:lstStyle/>
+          <a:p>
+            <a:pPr indent="0" marL="0">
+              <a:buNone/>
+            </a:pPr>
+            <a:r>
+              <a:rPr lang="en-US" sz="2800" b="1" dirty="0">
+                <a:solidFill>
+                  <a:srgbClr val="1F2429"/>
+                </a:solidFill>
+                <a:latin typeface="Calibri" pitchFamily="34" charset="0"/>
+                <a:ea typeface="Calibri" pitchFamily="34" charset="-122"/>
+                <a:cs typeface="Calibri" pitchFamily="34" charset="-120"/>
+              </a:rPr>
+              <a:t>Worked Example: Renaming a Field Without Breaking Anyone</a:t>
+            </a:r>
+            <a:endParaRPr lang="en-US" sz="2800" dirty="0"/>
+          </a:p>
+        </p:txBody>
+      </p:sp>
+      <p:sp>
+        <p:nvSpPr>
+          <p:cNvPr id="3" name="Text 1"/>
+          <p:cNvSpPr txBox="1"/>
+          <p:nvPr/>
+        </p:nvSpPr>
+        <p:spPr>
+          <a:xfrm>
+            <a:off x="9951415" y="6455664"/>
+            <a:ext cx="2011680" cy="292608"/>
+          </a:xfrm>
+          <a:prstGeom prst="rect">
+            <a:avLst/>
+          </a:prstGeom>
+          <a:noFill/>
+          <a:ln/>
+        </p:spPr>
+        <p:txBody>
+          <a:bodyPr wrap="square" lIns="0" tIns="0" rIns="0" bIns="0" rtlCol="0" anchor="ctr"/>
+          <a:lstStyle/>
+          <a:p>
+            <a:pPr algn="r" indent="0" marL="0">
+              <a:buNone/>
+            </a:pPr>
+            <a:r>
+              <a:rPr lang="en-US" sz="1200" u="sng" dirty="0">
+                <a:solidFill>
+                  <a:srgbClr val="8A939B"/>
+                </a:solidFill>
+                <a:latin typeface="Calibri" pitchFamily="34" charset="0"/>
+                <a:ea typeface="Calibri" pitchFamily="34" charset="-122"/>
+                <a:cs typeface="Calibri" pitchFamily="34" charset="-120"/>
+                <a:hlinkClick r:id="rId1" invalidUrl="" action="" tgtFrame="" tooltip="" history="1" highlightClick="0" endSnd="0">
+                  <a:extLst>
+                    <a:ext uri="{A12FA001-AC4F-418D-AE19-62706E023703}">
+                      <ahyp:hlinkClr xmlns:ahyp="http://schemas.microsoft.com/office/drawing/2018/hyperlinkcolor" val="tx"/>
+                    </a:ext>
+                  </a:extLst>
+                </a:hlinkClick>
+              </a:rPr>
+              <a:t>cuinotes.com</a:t>
+            </a:r>
+            <a:pPr algn="r" indent="0" marL="0">
+              <a:buNone/>
+            </a:pPr>
+            <a:r>
+              <a:rPr lang="en-US" sz="1200" dirty="0">
+                <a:solidFill>
+                  <a:srgbClr val="8A939B"/>
+                </a:solidFill>
+                <a:latin typeface="Calibri" pitchFamily="34" charset="0"/>
+                <a:ea typeface="Calibri" pitchFamily="34" charset="-122"/>
+                <a:cs typeface="Calibri" pitchFamily="34" charset="-120"/>
+              </a:rPr>
+              <a:t>  ·  15</a:t>
+            </a:r>
+            <a:endParaRPr lang="en-US" sz="1200" dirty="0"/>
+          </a:p>
+        </p:txBody>
+      </p:sp>
+      <p:sp>
+        <p:nvSpPr>
+          <p:cNvPr id="4" name="Text 2"/>
+          <p:cNvSpPr txBox="1"/>
+          <p:nvPr/>
+        </p:nvSpPr>
+        <p:spPr>
+          <a:xfrm>
+            <a:off x="640080" y="1371600"/>
+            <a:ext cx="10332720" cy="4846320"/>
+          </a:xfrm>
+          <a:prstGeom prst="rect">
+            <a:avLst/>
+          </a:prstGeom>
+          <a:noFill/>
+          <a:ln/>
+        </p:spPr>
+        <p:txBody>
+          <a:bodyPr wrap="square" lIns="0" tIns="0" rIns="0" bIns="0" rtlCol="0" anchor="t"/>
+          <a:lstStyle/>
+          <a:p>
+            <a:pPr marL="342900" indent="-342900">
+              <a:spcAft>
+                <a:spcPts val="1800"/>
+              </a:spcAft>
+              <a:buSzPct val="100000"/>
+              <a:buChar char="•"/>
+            </a:pPr>
+            <a:r>
+              <a:rPr lang="en-US" sz="1800" dirty="0">
+                <a:solidFill>
+                  <a:srgbClr val="1F2429"/>
+                </a:solidFill>
+                <a:latin typeface="Calibri" pitchFamily="34" charset="0"/>
+                <a:ea typeface="Calibri" pitchFamily="34" charset="-122"/>
+                <a:cs typeface="Calibri" pitchFamily="34" charset="-120"/>
+              </a:rPr>
+              <a:t>The conceptual schema renames Student.name to Student.fullName for clarity</a:t>
+            </a:r>
+            <a:endParaRPr lang="en-US" sz="1800" dirty="0"/>
+          </a:p>
+          <a:p>
+            <a:pPr marL="342900" indent="-342900">
+              <a:spcAft>
+                <a:spcPts val="1800"/>
+              </a:spcAft>
+              <a:buSzPct val="100000"/>
+              <a:buChar char="•"/>
+            </a:pPr>
+            <a:r>
+              <a:rPr lang="en-US" sz="1800" dirty="0">
+                <a:solidFill>
+                  <a:srgbClr val="1F2429"/>
+                </a:solidFill>
+                <a:latin typeface="Calibri" pitchFamily="34" charset="0"/>
+                <a:ea typeface="Calibri" pitchFamily="34" charset="-122"/>
+                <a:cs typeface="Calibri" pitchFamily="34" charset="-120"/>
+              </a:rPr>
+              <a:t>The external/conceptual mapping is updated: StudentName now maps to Student.fullName</a:t>
+            </a:r>
+            <a:endParaRPr lang="en-US" sz="1800" dirty="0"/>
+          </a:p>
+          <a:p>
+            <a:pPr marL="342900" indent="-342900">
+              <a:spcAft>
+                <a:spcPts val="1800"/>
+              </a:spcAft>
+              <a:buSzPct val="100000"/>
+              <a:buChar char="•"/>
+            </a:pPr>
+            <a:r>
+              <a:rPr lang="en-US" sz="1800" dirty="0">
+                <a:solidFill>
+                  <a:srgbClr val="1F2429"/>
+                </a:solidFill>
+                <a:latin typeface="Calibri" pitchFamily="34" charset="0"/>
+                <a:ea typeface="Calibri" pitchFamily="34" charset="-122"/>
+                <a:cs typeface="Calibri" pitchFamily="34" charset="-120"/>
+              </a:rPr>
+              <a:t>The Course Advisor's external schema is untouched — it still says StudentName</a:t>
+            </a:r>
+            <a:endParaRPr lang="en-US" sz="1800" dirty="0"/>
+          </a:p>
+          <a:p>
+            <a:pPr marL="342900" indent="-342900">
+              <a:spcAft>
+                <a:spcPts val="1800"/>
+              </a:spcAft>
+              <a:buSzPct val="100000"/>
+              <a:buChar char="•"/>
+            </a:pPr>
+            <a:r>
+              <a:rPr lang="en-US" sz="1800" dirty="0">
+                <a:solidFill>
+                  <a:srgbClr val="1F2429"/>
+                </a:solidFill>
+                <a:latin typeface="Calibri" pitchFamily="34" charset="0"/>
+                <a:ea typeface="Calibri" pitchFamily="34" charset="-122"/>
+                <a:cs typeface="Calibri" pitchFamily="34" charset="-120"/>
+              </a:rPr>
+              <a:t>Reports and applications built against that view keep running with no code change</a:t>
+            </a:r>
+            <a:endParaRPr lang="en-US" sz="1800" dirty="0"/>
+          </a:p>
+          <a:p>
+            <a:pPr marL="342900" indent="-342900">
+              <a:spcAft>
+                <a:spcPts val="1800"/>
+              </a:spcAft>
+              <a:buSzPct val="100000"/>
+              <a:buChar char="•"/>
+            </a:pPr>
+            <a:r>
+              <a:rPr lang="en-US" sz="1800" dirty="0">
+                <a:solidFill>
+                  <a:srgbClr val="1F2429"/>
+                </a:solidFill>
+                <a:latin typeface="Calibri" pitchFamily="34" charset="0"/>
+                <a:ea typeface="Calibri" pitchFamily="34" charset="-122"/>
+                <a:cs typeface="Calibri" pitchFamily="34" charset="-120"/>
+              </a:rPr>
+              <a:t>Without this mapping layer, every program that referred to name would have to be found and rewritten</a:t>
+            </a:r>
+            <a:endParaRPr lang="en-US" sz="1800" dirty="0"/>
+          </a:p>
+        </p:txBody>
+      </p:sp>
+    </p:spTree>
+  </p:cSld>
+  <p:clrMapOvr>
+    <a:masterClrMapping/>
+  </p:clrMapOvr>
+</p:sld>
+</file>
+
+<file path=ppt/slides/slide19.xml><?xml version="1.0" encoding="utf-8"?>
+<p:sld xmlns:a="http://schemas.openxmlformats.org/drawingml/2006/main" xmlns:r="http://schemas.openxmlformats.org/officeDocument/2006/relationships" xmlns:p="http://schemas.openxmlformats.org/presentationml/2006/main">
+  <p:cSld name="Slide 2">
+    <p:bg>
+      <p:bgPr>
+        <a:solidFill>
+          <a:srgbClr val="F7F8F9"/>
+        </a:solidFill>
+      </p:bgPr>
+    </p:bg>
+    <p:spTree>
+      <p:nvGrpSpPr>
+        <p:cNvPr id="1" name=""/>
+        <p:cNvGrpSpPr/>
+        <p:nvPr/>
+      </p:nvGrpSpPr>
+      <p:grpSpPr>
+        <a:xfrm>
+          <a:off x="0" y="0"/>
+          <a:ext cx="0" cy="0"/>
+          <a:chOff x="0" y="0"/>
+          <a:chExt cx="0" cy="0"/>
+        </a:xfrm>
+      </p:grpSpPr>
+      <p:sp>
+        <p:nvSpPr>
+          <p:cNvPr id="2" name="Text 0"/>
+          <p:cNvSpPr txBox="1"/>
+          <p:nvPr/>
+        </p:nvSpPr>
+        <p:spPr>
+          <a:xfrm>
+            <a:off x="548640" y="365760"/>
+            <a:ext cx="11064240" cy="731520"/>
+          </a:xfrm>
+          <a:prstGeom prst="rect">
+            <a:avLst/>
+          </a:prstGeom>
+          <a:noFill/>
+          <a:ln/>
+        </p:spPr>
+        <p:txBody>
+          <a:bodyPr wrap="square" lIns="0" tIns="0" rIns="0" bIns="0" rtlCol="0" anchor="ctr"/>
+          <a:lstStyle/>
+          <a:p>
+            <a:pPr indent="0" marL="0">
+              <a:buNone/>
+            </a:pPr>
+            <a:r>
+              <a:rPr lang="en-US" sz="2800" b="1" dirty="0">
+                <a:solidFill>
+                  <a:srgbClr val="1F2429"/>
+                </a:solidFill>
+                <a:latin typeface="Calibri" pitchFamily="34" charset="0"/>
+                <a:ea typeface="Calibri" pitchFamily="34" charset="-122"/>
+                <a:cs typeface="Calibri" pitchFamily="34" charset="-120"/>
+              </a:rPr>
+              <a:t>Logical Independence in Practice: Adding and Splitting</a:t>
+            </a:r>
+            <a:endParaRPr lang="en-US" sz="2800" dirty="0"/>
+          </a:p>
+        </p:txBody>
+      </p:sp>
+      <p:sp>
+        <p:nvSpPr>
+          <p:cNvPr id="3" name="Text 1"/>
+          <p:cNvSpPr txBox="1"/>
+          <p:nvPr/>
+        </p:nvSpPr>
+        <p:spPr>
+          <a:xfrm>
+            <a:off x="9951415" y="6455664"/>
+            <a:ext cx="2011680" cy="292608"/>
+          </a:xfrm>
+          <a:prstGeom prst="rect">
+            <a:avLst/>
+          </a:prstGeom>
+          <a:noFill/>
+          <a:ln/>
+        </p:spPr>
+        <p:txBody>
+          <a:bodyPr wrap="square" lIns="0" tIns="0" rIns="0" bIns="0" rtlCol="0" anchor="ctr"/>
+          <a:lstStyle/>
+          <a:p>
+            <a:pPr algn="r" indent="0" marL="0">
+              <a:buNone/>
+            </a:pPr>
+            <a:r>
+              <a:rPr lang="en-US" sz="1200" u="sng" dirty="0">
+                <a:solidFill>
+                  <a:srgbClr val="8A939B"/>
+                </a:solidFill>
+                <a:latin typeface="Calibri" pitchFamily="34" charset="0"/>
+                <a:ea typeface="Calibri" pitchFamily="34" charset="-122"/>
+                <a:cs typeface="Calibri" pitchFamily="34" charset="-120"/>
+                <a:hlinkClick r:id="rId1" invalidUrl="" action="" tgtFrame="" tooltip="" history="1" highlightClick="0" endSnd="0">
+                  <a:extLst>
+                    <a:ext uri="{A12FA001-AC4F-418D-AE19-62706E023703}">
+                      <ahyp:hlinkClr xmlns:ahyp="http://schemas.microsoft.com/office/drawing/2018/hyperlinkcolor" val="tx"/>
+                    </a:ext>
+                  </a:extLst>
+                </a:hlinkClick>
+              </a:rPr>
+              <a:t>cuinotes.com</a:t>
+            </a:r>
+            <a:pPr algn="r" indent="0" marL="0">
+              <a:buNone/>
+            </a:pPr>
+            <a:r>
+              <a:rPr lang="en-US" sz="1200" dirty="0">
+                <a:solidFill>
+                  <a:srgbClr val="8A939B"/>
+                </a:solidFill>
+                <a:latin typeface="Calibri" pitchFamily="34" charset="0"/>
+                <a:ea typeface="Calibri" pitchFamily="34" charset="-122"/>
+                <a:cs typeface="Calibri" pitchFamily="34" charset="-120"/>
+              </a:rPr>
+              <a:t>  ·  17</a:t>
+            </a:r>
+            <a:endParaRPr lang="en-US" sz="1200" dirty="0"/>
+          </a:p>
+        </p:txBody>
+      </p:sp>
+      <p:sp>
+        <p:nvSpPr>
+          <p:cNvPr id="4" name="Text 2"/>
+          <p:cNvSpPr txBox="1"/>
+          <p:nvPr/>
+        </p:nvSpPr>
+        <p:spPr>
+          <a:xfrm>
+            <a:off x="640080" y="1371600"/>
+            <a:ext cx="10332720" cy="4846320"/>
+          </a:xfrm>
+          <a:prstGeom prst="rect">
+            <a:avLst/>
+          </a:prstGeom>
+          <a:noFill/>
+          <a:ln/>
+        </p:spPr>
+        <p:txBody>
+          <a:bodyPr wrap="square" lIns="0" tIns="0" rIns="0" bIns="0" rtlCol="0" anchor="t"/>
+          <a:lstStyle/>
+          <a:p>
+            <a:pPr marL="342900" indent="-342900">
+              <a:spcAft>
+                <a:spcPts val="1800"/>
+              </a:spcAft>
+              <a:buSzPct val="100000"/>
+              <a:buChar char="•"/>
+            </a:pPr>
+            <a:r>
+              <a:rPr lang="en-US" sz="1800" dirty="0">
+                <a:solidFill>
+                  <a:srgbClr val="1F2429"/>
+                </a:solidFill>
+                <a:latin typeface="Calibri" pitchFamily="34" charset="0"/>
+                <a:ea typeface="Calibri" pitchFamily="34" charset="-122"/>
+                <a:cs typeface="Calibri" pitchFamily="34" charset="-120"/>
+              </a:rPr>
+              <a:t>Adding Instructor.officePhone is safe — no external schema referenced instructor contact details</a:t>
+            </a:r>
+            <a:endParaRPr lang="en-US" sz="1800" dirty="0"/>
+          </a:p>
+          <a:p>
+            <a:pPr marL="342900" indent="-342900">
+              <a:spcAft>
+                <a:spcPts val="1800"/>
+              </a:spcAft>
+              <a:buSzPct val="100000"/>
+              <a:buChar char="•"/>
+            </a:pPr>
+            <a:r>
+              <a:rPr lang="en-US" sz="1800" dirty="0">
+                <a:solidFill>
+                  <a:srgbClr val="1F2429"/>
+                </a:solidFill>
+                <a:latin typeface="Calibri" pitchFamily="34" charset="0"/>
+                <a:ea typeface="Calibri" pitchFamily="34" charset="-122"/>
+                <a:cs typeface="Calibri" pitchFamily="34" charset="-120"/>
+              </a:rPr>
+              <a:t>Splitting Student into Student and Address changes the conceptual schema's shape</a:t>
+            </a:r>
+            <a:endParaRPr lang="en-US" sz="1800" dirty="0"/>
+          </a:p>
+          <a:p>
+            <a:pPr marL="342900" indent="-342900">
+              <a:spcAft>
+                <a:spcPts val="1800"/>
+              </a:spcAft>
+              <a:buSzPct val="100000"/>
+              <a:buChar char="•"/>
+            </a:pPr>
+            <a:r>
+              <a:rPr lang="en-US" sz="1800" dirty="0">
+                <a:solidFill>
+                  <a:srgbClr val="1F2429"/>
+                </a:solidFill>
+                <a:latin typeface="Calibri" pitchFamily="34" charset="0"/>
+                <a:ea typeface="Calibri" pitchFamily="34" charset="-122"/>
+                <a:cs typeface="Calibri" pitchFamily="34" charset="-120"/>
+              </a:rPr>
+              <a:t>The external/conceptual mapping is rewritten to rebuild the old Student view from the two new relations</a:t>
+            </a:r>
+            <a:endParaRPr lang="en-US" sz="1800" dirty="0"/>
+          </a:p>
+          <a:p>
+            <a:pPr marL="342900" indent="-342900">
+              <a:spcAft>
+                <a:spcPts val="1800"/>
+              </a:spcAft>
+              <a:buSzPct val="100000"/>
+              <a:buChar char="•"/>
+            </a:pPr>
+            <a:r>
+              <a:rPr lang="en-US" sz="1800" dirty="0">
+                <a:solidFill>
+                  <a:srgbClr val="1F2429"/>
+                </a:solidFill>
+                <a:latin typeface="Calibri" pitchFamily="34" charset="0"/>
+                <a:ea typeface="Calibri" pitchFamily="34" charset="-122"/>
+                <a:cs typeface="Calibri" pitchFamily="34" charset="-120"/>
+              </a:rPr>
+              <a:t>The Course Advisor's external schema still shows the same columns, so its applications keep working</a:t>
+            </a:r>
+            <a:endParaRPr lang="en-US" sz="1800" dirty="0"/>
+          </a:p>
+          <a:p>
+            <a:pPr marL="342900" indent="-342900">
+              <a:spcAft>
+                <a:spcPts val="1800"/>
+              </a:spcAft>
+              <a:buSzPct val="100000"/>
+              <a:buChar char="•"/>
+            </a:pPr>
+            <a:r>
+              <a:rPr lang="en-US" sz="1800" dirty="0">
+                <a:solidFill>
+                  <a:srgbClr val="1F2429"/>
+                </a:solidFill>
+                <a:latin typeface="Calibri" pitchFamily="34" charset="0"/>
+                <a:ea typeface="Calibri" pitchFamily="34" charset="-122"/>
+                <a:cs typeface="Calibri" pitchFamily="34" charset="-120"/>
+              </a:rPr>
+              <a:t>Limit: if a view truly depends on a removed attribute, no mapping can save it — that view must change</a:t>
+            </a:r>
+            <a:endParaRPr lang="en-US" sz="1800" dirty="0"/>
           </a:p>
         </p:txBody>
       </p:sp>
@@ -2846,7 +4964,7 @@
               <a:buNone/>
             </a:pPr>
             <a:r>
-              <a:rPr lang="en-US" sz="1000" u="sng" dirty="0">
+              <a:rPr lang="en-US" sz="1200" u="sng" dirty="0">
                 <a:solidFill>
                   <a:srgbClr val="8A939B"/>
                 </a:solidFill>
@@ -2867,7 +4985,7 @@
               <a:buNone/>
             </a:pPr>
             <a:r>
-              <a:rPr lang="en-US" sz="1000" dirty="0">
+              <a:rPr lang="en-US" sz="1200" dirty="0">
                 <a:solidFill>
                   <a:srgbClr val="8A939B"/>
                 </a:solidFill>
@@ -2877,7 +4995,7 @@
               </a:rPr>
               <a:t>  ·  2</a:t>
             </a:r>
-            <a:endParaRPr lang="en-US" sz="1000" dirty="0"/>
+            <a:endParaRPr lang="en-US" sz="1200" dirty="0"/>
           </a:p>
         </p:txBody>
       </p:sp>
@@ -2910,7 +5028,7 @@
               <a:buChar char="•"/>
             </a:pPr>
             <a:r>
-              <a:rPr lang="en-US" sz="1600" dirty="0">
+              <a:rPr lang="en-US" sz="1800" dirty="0">
                 <a:solidFill>
                   <a:srgbClr val="1F2429"/>
                 </a:solidFill>
@@ -2920,7 +5038,7 @@
               </a:rPr>
               <a:t>Two-tier client-server architecture, and its limitations</a:t>
             </a:r>
-            <a:endParaRPr lang="en-US" sz="1600" dirty="0"/>
+            <a:endParaRPr lang="en-US" sz="1800" dirty="0"/>
           </a:p>
           <a:p>
             <a:pPr marL="342900" indent="-342900">
@@ -2931,7 +5049,7 @@
               <a:buChar char="•"/>
             </a:pPr>
             <a:r>
-              <a:rPr lang="en-US" sz="1600" dirty="0">
+              <a:rPr lang="en-US" sz="1800" dirty="0">
                 <a:solidFill>
                   <a:srgbClr val="1F2429"/>
                 </a:solidFill>
@@ -2941,7 +5059,7 @@
               </a:rPr>
               <a:t>Three-tier client-server architecture, and why it emerged</a:t>
             </a:r>
-            <a:endParaRPr lang="en-US" sz="1600" dirty="0"/>
+            <a:endParaRPr lang="en-US" sz="1800" dirty="0"/>
           </a:p>
           <a:p>
             <a:pPr marL="342900" indent="-342900">
@@ -2952,7 +5070,7 @@
               <a:buChar char="•"/>
             </a:pPr>
             <a:r>
-              <a:rPr lang="en-US" sz="1600" dirty="0">
+              <a:rPr lang="en-US" sz="1800" dirty="0">
                 <a:solidFill>
                   <a:srgbClr val="1F2429"/>
                 </a:solidFill>
@@ -2962,7 +5080,7 @@
               </a:rPr>
               <a:t>The ANSI-SPARC three-schema architecture: external, conceptual, and internal levels</a:t>
             </a:r>
-            <a:endParaRPr lang="en-US" sz="1600" dirty="0"/>
+            <a:endParaRPr lang="en-US" sz="1800" dirty="0"/>
           </a:p>
           <a:p>
             <a:pPr marL="342900" indent="-342900">
@@ -2973,7 +5091,7 @@
               <a:buChar char="•"/>
             </a:pPr>
             <a:r>
-              <a:rPr lang="en-US" sz="1600" dirty="0">
+              <a:rPr lang="en-US" sz="1800" dirty="0">
                 <a:solidFill>
                   <a:srgbClr val="1F2429"/>
                 </a:solidFill>
@@ -2983,7 +5101,7 @@
               </a:rPr>
               <a:t>External/conceptual and conceptual/internal mappings, and what each one does</a:t>
             </a:r>
-            <a:endParaRPr lang="en-US" sz="1600" dirty="0"/>
+            <a:endParaRPr lang="en-US" sz="1800" dirty="0"/>
           </a:p>
           <a:p>
             <a:pPr marL="342900" indent="-342900">
@@ -2994,7 +5112,7 @@
               <a:buChar char="•"/>
             </a:pPr>
             <a:r>
-              <a:rPr lang="en-US" sz="1600" dirty="0">
+              <a:rPr lang="en-US" sz="1800" dirty="0">
                 <a:solidFill>
                   <a:srgbClr val="1F2429"/>
                 </a:solidFill>
@@ -3004,7 +5122,1039 @@
               </a:rPr>
               <a:t>Logical vs. physical data independence — precisely defined, with worked examples</a:t>
             </a:r>
-            <a:endParaRPr lang="en-US" sz="1600" dirty="0"/>
+            <a:endParaRPr lang="en-US" sz="1800" dirty="0"/>
+          </a:p>
+        </p:txBody>
+      </p:sp>
+    </p:spTree>
+  </p:cSld>
+  <p:clrMapOvr>
+    <a:masterClrMapping/>
+  </p:clrMapOvr>
+</p:sld>
+</file>
+
+<file path=ppt/slides/slide20.xml><?xml version="1.0" encoding="utf-8"?>
+<p:sld xmlns:a="http://schemas.openxmlformats.org/drawingml/2006/main" xmlns:r="http://schemas.openxmlformats.org/officeDocument/2006/relationships" xmlns:p="http://schemas.openxmlformats.org/presentationml/2006/main">
+  <p:cSld name="Slide 2">
+    <p:bg>
+      <p:bgPr>
+        <a:solidFill>
+          <a:srgbClr val="F7F8F9"/>
+        </a:solidFill>
+      </p:bgPr>
+    </p:bg>
+    <p:spTree>
+      <p:nvGrpSpPr>
+        <p:cNvPr id="1" name=""/>
+        <p:cNvGrpSpPr/>
+        <p:nvPr/>
+      </p:nvGrpSpPr>
+      <p:grpSpPr>
+        <a:xfrm>
+          <a:off x="0" y="0"/>
+          <a:ext cx="0" cy="0"/>
+          <a:chOff x="0" y="0"/>
+          <a:chExt cx="0" cy="0"/>
+        </a:xfrm>
+      </p:grpSpPr>
+      <p:sp>
+        <p:nvSpPr>
+          <p:cNvPr id="2" name="Text 0"/>
+          <p:cNvSpPr txBox="1"/>
+          <p:nvPr/>
+        </p:nvSpPr>
+        <p:spPr>
+          <a:xfrm>
+            <a:off x="548640" y="365760"/>
+            <a:ext cx="11064240" cy="731520"/>
+          </a:xfrm>
+          <a:prstGeom prst="rect">
+            <a:avLst/>
+          </a:prstGeom>
+          <a:noFill/>
+          <a:ln/>
+        </p:spPr>
+        <p:txBody>
+          <a:bodyPr wrap="square" lIns="0" tIns="0" rIns="0" bIns="0" rtlCol="0" anchor="ctr"/>
+          <a:lstStyle/>
+          <a:p>
+            <a:pPr indent="0" marL="0">
+              <a:buNone/>
+            </a:pPr>
+            <a:r>
+              <a:rPr lang="en-US" sz="2800" b="1" dirty="0">
+                <a:solidFill>
+                  <a:srgbClr val="1F2429"/>
+                </a:solidFill>
+                <a:latin typeface="Calibri" pitchFamily="34" charset="0"/>
+                <a:ea typeface="Calibri" pitchFamily="34" charset="-122"/>
+                <a:cs typeface="Calibri" pitchFamily="34" charset="-120"/>
+              </a:rPr>
+              <a:t>Physical Independence in Practice: Adding an Index</a:t>
+            </a:r>
+            <a:endParaRPr lang="en-US" sz="2800" dirty="0"/>
+          </a:p>
+        </p:txBody>
+      </p:sp>
+      <p:sp>
+        <p:nvSpPr>
+          <p:cNvPr id="3" name="Text 1"/>
+          <p:cNvSpPr txBox="1"/>
+          <p:nvPr/>
+        </p:nvSpPr>
+        <p:spPr>
+          <a:xfrm>
+            <a:off x="9951415" y="6455664"/>
+            <a:ext cx="2011680" cy="292608"/>
+          </a:xfrm>
+          <a:prstGeom prst="rect">
+            <a:avLst/>
+          </a:prstGeom>
+          <a:noFill/>
+          <a:ln/>
+        </p:spPr>
+        <p:txBody>
+          <a:bodyPr wrap="square" lIns="0" tIns="0" rIns="0" bIns="0" rtlCol="0" anchor="ctr"/>
+          <a:lstStyle/>
+          <a:p>
+            <a:pPr algn="r" indent="0" marL="0">
+              <a:buNone/>
+            </a:pPr>
+            <a:r>
+              <a:rPr lang="en-US" sz="1200" u="sng" dirty="0">
+                <a:solidFill>
+                  <a:srgbClr val="8A939B"/>
+                </a:solidFill>
+                <a:latin typeface="Calibri" pitchFamily="34" charset="0"/>
+                <a:ea typeface="Calibri" pitchFamily="34" charset="-122"/>
+                <a:cs typeface="Calibri" pitchFamily="34" charset="-120"/>
+                <a:hlinkClick r:id="rId1" invalidUrl="" action="" tgtFrame="" tooltip="" history="1" highlightClick="0" endSnd="0">
+                  <a:extLst>
+                    <a:ext uri="{A12FA001-AC4F-418D-AE19-62706E023703}">
+                      <ahyp:hlinkClr xmlns:ahyp="http://schemas.microsoft.com/office/drawing/2018/hyperlinkcolor" val="tx"/>
+                    </a:ext>
+                  </a:extLst>
+                </a:hlinkClick>
+              </a:rPr>
+              <a:t>cuinotes.com</a:t>
+            </a:r>
+            <a:pPr algn="r" indent="0" marL="0">
+              <a:buNone/>
+            </a:pPr>
+            <a:r>
+              <a:rPr lang="en-US" sz="1200" dirty="0">
+                <a:solidFill>
+                  <a:srgbClr val="8A939B"/>
+                </a:solidFill>
+                <a:latin typeface="Calibri" pitchFamily="34" charset="0"/>
+                <a:ea typeface="Calibri" pitchFamily="34" charset="-122"/>
+                <a:cs typeface="Calibri" pitchFamily="34" charset="-120"/>
+              </a:rPr>
+              <a:t>  ·  19</a:t>
+            </a:r>
+            <a:endParaRPr lang="en-US" sz="1200" dirty="0"/>
+          </a:p>
+        </p:txBody>
+      </p:sp>
+      <p:sp>
+        <p:nvSpPr>
+          <p:cNvPr id="4" name="Text 2"/>
+          <p:cNvSpPr txBox="1"/>
+          <p:nvPr/>
+        </p:nvSpPr>
+        <p:spPr>
+          <a:xfrm>
+            <a:off x="640080" y="1371600"/>
+            <a:ext cx="10332720" cy="4846320"/>
+          </a:xfrm>
+          <a:prstGeom prst="rect">
+            <a:avLst/>
+          </a:prstGeom>
+          <a:noFill/>
+          <a:ln/>
+        </p:spPr>
+        <p:txBody>
+          <a:bodyPr wrap="square" lIns="0" tIns="0" rIns="0" bIns="0" rtlCol="0" anchor="t"/>
+          <a:lstStyle/>
+          <a:p>
+            <a:pPr marL="342900" indent="-342900">
+              <a:spcAft>
+                <a:spcPts val="1800"/>
+              </a:spcAft>
+              <a:buSzPct val="100000"/>
+              <a:buChar char="•"/>
+            </a:pPr>
+            <a:r>
+              <a:rPr lang="en-US" sz="1800" dirty="0">
+                <a:solidFill>
+                  <a:srgbClr val="1F2429"/>
+                </a:solidFill>
+                <a:latin typeface="Calibri" pitchFamily="34" charset="0"/>
+                <a:ea typeface="Calibri" pitchFamily="34" charset="-122"/>
+                <a:cs typeface="Calibri" pitchFamily="34" charset="-120"/>
+              </a:rPr>
+              <a:t>The DBA adds an index on Student.cnic to speed up lookups by national ID</a:t>
+            </a:r>
+            <a:endParaRPr lang="en-US" sz="1800" dirty="0"/>
+          </a:p>
+          <a:p>
+            <a:pPr marL="342900" indent="-342900">
+              <a:spcAft>
+                <a:spcPts val="1800"/>
+              </a:spcAft>
+              <a:buSzPct val="100000"/>
+              <a:buChar char="•"/>
+            </a:pPr>
+            <a:r>
+              <a:rPr lang="en-US" sz="1800" dirty="0">
+                <a:solidFill>
+                  <a:srgbClr val="1F2429"/>
+                </a:solidFill>
+                <a:latin typeface="Calibri" pitchFamily="34" charset="0"/>
+                <a:ea typeface="Calibri" pitchFamily="34" charset="-122"/>
+                <a:cs typeface="Calibri" pitchFamily="34" charset="-120"/>
+              </a:rPr>
+              <a:t>The conceptual schema is unchanged: Student still has the same attributes and keys</a:t>
+            </a:r>
+            <a:endParaRPr lang="en-US" sz="1800" dirty="0"/>
+          </a:p>
+          <a:p>
+            <a:pPr marL="342900" indent="-342900">
+              <a:spcAft>
+                <a:spcPts val="1800"/>
+              </a:spcAft>
+              <a:buSzPct val="100000"/>
+              <a:buChar char="•"/>
+            </a:pPr>
+            <a:r>
+              <a:rPr lang="en-US" sz="1800" dirty="0">
+                <a:solidFill>
+                  <a:srgbClr val="1F2429"/>
+                </a:solidFill>
+                <a:latin typeface="Calibri" pitchFamily="34" charset="0"/>
+                <a:ea typeface="Calibri" pitchFamily="34" charset="-122"/>
+                <a:cs typeface="Calibri" pitchFamily="34" charset="-120"/>
+              </a:rPr>
+              <a:t>Only the conceptual/internal mapping changes, to record that cnic is now indexed</a:t>
+            </a:r>
+            <a:endParaRPr lang="en-US" sz="1800" dirty="0"/>
+          </a:p>
+          <a:p>
+            <a:pPr marL="342900" indent="-342900">
+              <a:spcAft>
+                <a:spcPts val="1800"/>
+              </a:spcAft>
+              <a:buSzPct val="100000"/>
+              <a:buChar char="•"/>
+            </a:pPr>
+            <a:r>
+              <a:rPr lang="en-US" sz="1800" dirty="0">
+                <a:solidFill>
+                  <a:srgbClr val="1F2429"/>
+                </a:solidFill>
+                <a:latin typeface="Calibri" pitchFamily="34" charset="0"/>
+                <a:ea typeface="Calibri" pitchFamily="34" charset="-122"/>
+                <a:cs typeface="Calibri" pitchFamily="34" charset="-120"/>
+              </a:rPr>
+              <a:t>Every query written against Student runs unchanged; only its execution plan gets faster</a:t>
+            </a:r>
+            <a:endParaRPr lang="en-US" sz="1800" dirty="0"/>
+          </a:p>
+          <a:p>
+            <a:pPr marL="342900" indent="-342900">
+              <a:spcAft>
+                <a:spcPts val="1800"/>
+              </a:spcAft>
+              <a:buSzPct val="100000"/>
+              <a:buChar char="•"/>
+            </a:pPr>
+            <a:r>
+              <a:rPr lang="en-US" sz="1800" dirty="0">
+                <a:solidFill>
+                  <a:srgbClr val="1F2429"/>
+                </a:solidFill>
+                <a:latin typeface="Calibri" pitchFamily="34" charset="0"/>
+                <a:ea typeface="Calibri" pitchFamily="34" charset="-122"/>
+                <a:cs typeface="Calibri" pitchFamily="34" charset="-120"/>
+              </a:rPr>
+              <a:t>Moving the files from spinning disks to SSDs follows the same pattern — no application code changes</a:t>
+            </a:r>
+            <a:endParaRPr lang="en-US" sz="1800" dirty="0"/>
+          </a:p>
+        </p:txBody>
+      </p:sp>
+    </p:spTree>
+  </p:cSld>
+  <p:clrMapOvr>
+    <a:masterClrMapping/>
+  </p:clrMapOvr>
+</p:sld>
+</file>
+
+<file path=ppt/slides/slide21.xml><?xml version="1.0" encoding="utf-8"?>
+<p:sld xmlns:a="http://schemas.openxmlformats.org/drawingml/2006/main" xmlns:r="http://schemas.openxmlformats.org/officeDocument/2006/relationships" xmlns:p="http://schemas.openxmlformats.org/presentationml/2006/main">
+  <p:cSld name="Slide 2">
+    <p:bg>
+      <p:bgPr>
+        <a:solidFill>
+          <a:srgbClr val="F7F8F9"/>
+        </a:solidFill>
+      </p:bgPr>
+    </p:bg>
+    <p:spTree>
+      <p:nvGrpSpPr>
+        <p:cNvPr id="1" name=""/>
+        <p:cNvGrpSpPr/>
+        <p:nvPr/>
+      </p:nvGrpSpPr>
+      <p:grpSpPr>
+        <a:xfrm>
+          <a:off x="0" y="0"/>
+          <a:ext cx="0" cy="0"/>
+          <a:chOff x="0" y="0"/>
+          <a:chExt cx="0" cy="0"/>
+        </a:xfrm>
+      </p:grpSpPr>
+      <p:sp>
+        <p:nvSpPr>
+          <p:cNvPr id="2" name="Text 0"/>
+          <p:cNvSpPr txBox="1"/>
+          <p:nvPr/>
+        </p:nvSpPr>
+        <p:spPr>
+          <a:xfrm>
+            <a:off x="548640" y="365760"/>
+            <a:ext cx="11064240" cy="731520"/>
+          </a:xfrm>
+          <a:prstGeom prst="rect">
+            <a:avLst/>
+          </a:prstGeom>
+          <a:noFill/>
+          <a:ln/>
+        </p:spPr>
+        <p:txBody>
+          <a:bodyPr wrap="square" lIns="0" tIns="0" rIns="0" bIns="0" rtlCol="0" anchor="ctr"/>
+          <a:lstStyle/>
+          <a:p>
+            <a:pPr indent="0" marL="0">
+              <a:buNone/>
+            </a:pPr>
+            <a:r>
+              <a:rPr lang="en-US" sz="2800" b="1" dirty="0">
+                <a:solidFill>
+                  <a:srgbClr val="1F2429"/>
+                </a:solidFill>
+                <a:latin typeface="Calibri" pitchFamily="34" charset="0"/>
+                <a:ea typeface="Calibri" pitchFamily="34" charset="-122"/>
+                <a:cs typeface="Calibri" pitchFamily="34" charset="-120"/>
+              </a:rPr>
+              <a:t>Logical or Physical? Classify the Change</a:t>
+            </a:r>
+            <a:endParaRPr lang="en-US" sz="2800" dirty="0"/>
+          </a:p>
+        </p:txBody>
+      </p:sp>
+      <p:sp>
+        <p:nvSpPr>
+          <p:cNvPr id="3" name="Text 1"/>
+          <p:cNvSpPr txBox="1"/>
+          <p:nvPr/>
+        </p:nvSpPr>
+        <p:spPr>
+          <a:xfrm>
+            <a:off x="9951415" y="6455664"/>
+            <a:ext cx="2011680" cy="292608"/>
+          </a:xfrm>
+          <a:prstGeom prst="rect">
+            <a:avLst/>
+          </a:prstGeom>
+          <a:noFill/>
+          <a:ln/>
+        </p:spPr>
+        <p:txBody>
+          <a:bodyPr wrap="square" lIns="0" tIns="0" rIns="0" bIns="0" rtlCol="0" anchor="ctr"/>
+          <a:lstStyle/>
+          <a:p>
+            <a:pPr algn="r" indent="0" marL="0">
+              <a:buNone/>
+            </a:pPr>
+            <a:r>
+              <a:rPr lang="en-US" sz="1200" u="sng" dirty="0">
+                <a:solidFill>
+                  <a:srgbClr val="8A939B"/>
+                </a:solidFill>
+                <a:latin typeface="Calibri" pitchFamily="34" charset="0"/>
+                <a:ea typeface="Calibri" pitchFamily="34" charset="-122"/>
+                <a:cs typeface="Calibri" pitchFamily="34" charset="-120"/>
+                <a:hlinkClick r:id="rId1" invalidUrl="" action="" tgtFrame="" tooltip="" history="1" highlightClick="0" endSnd="0">
+                  <a:extLst>
+                    <a:ext uri="{A12FA001-AC4F-418D-AE19-62706E023703}">
+                      <ahyp:hlinkClr xmlns:ahyp="http://schemas.microsoft.com/office/drawing/2018/hyperlinkcolor" val="tx"/>
+                    </a:ext>
+                  </a:extLst>
+                </a:hlinkClick>
+              </a:rPr>
+              <a:t>cuinotes.com</a:t>
+            </a:r>
+            <a:pPr algn="r" indent="0" marL="0">
+              <a:buNone/>
+            </a:pPr>
+            <a:r>
+              <a:rPr lang="en-US" sz="1200" dirty="0">
+                <a:solidFill>
+                  <a:srgbClr val="8A939B"/>
+                </a:solidFill>
+                <a:latin typeface="Calibri" pitchFamily="34" charset="0"/>
+                <a:ea typeface="Calibri" pitchFamily="34" charset="-122"/>
+                <a:cs typeface="Calibri" pitchFamily="34" charset="-120"/>
+              </a:rPr>
+              <a:t>  ·  20</a:t>
+            </a:r>
+            <a:endParaRPr lang="en-US" sz="1200" dirty="0"/>
+          </a:p>
+        </p:txBody>
+      </p:sp>
+      <p:sp>
+        <p:nvSpPr>
+          <p:cNvPr id="4" name="Text 2"/>
+          <p:cNvSpPr txBox="1"/>
+          <p:nvPr/>
+        </p:nvSpPr>
+        <p:spPr>
+          <a:xfrm>
+            <a:off x="640080" y="1371600"/>
+            <a:ext cx="10332720" cy="4846320"/>
+          </a:xfrm>
+          <a:prstGeom prst="rect">
+            <a:avLst/>
+          </a:prstGeom>
+          <a:noFill/>
+          <a:ln/>
+        </p:spPr>
+        <p:txBody>
+          <a:bodyPr wrap="square" lIns="0" tIns="0" rIns="0" bIns="0" rtlCol="0" anchor="t"/>
+          <a:lstStyle/>
+          <a:p>
+            <a:pPr marL="342900" indent="-342900">
+              <a:spcAft>
+                <a:spcPts val="1800"/>
+              </a:spcAft>
+              <a:buSzPct val="100000"/>
+              <a:buChar char="•"/>
+            </a:pPr>
+            <a:r>
+              <a:rPr lang="en-US" sz="1800" dirty="0">
+                <a:solidFill>
+                  <a:srgbClr val="1F2429"/>
+                </a:solidFill>
+                <a:latin typeface="Calibri" pitchFamily="34" charset="0"/>
+                <a:ea typeface="Calibri" pitchFamily="34" charset="-122"/>
+                <a:cs typeface="Calibri" pitchFamily="34" charset="-120"/>
+              </a:rPr>
+              <a:t>Add officePhone to Instructor → logical: the conceptual schema changed</a:t>
+            </a:r>
+            <a:endParaRPr lang="en-US" sz="1800" dirty="0"/>
+          </a:p>
+          <a:p>
+            <a:pPr marL="342900" indent="-342900">
+              <a:spcAft>
+                <a:spcPts val="1800"/>
+              </a:spcAft>
+              <a:buSzPct val="100000"/>
+              <a:buChar char="•"/>
+            </a:pPr>
+            <a:r>
+              <a:rPr lang="en-US" sz="1800" dirty="0">
+                <a:solidFill>
+                  <a:srgbClr val="1F2429"/>
+                </a:solidFill>
+                <a:latin typeface="Calibri" pitchFamily="34" charset="0"/>
+                <a:ea typeface="Calibri" pitchFamily="34" charset="-122"/>
+                <a:cs typeface="Calibri" pitchFamily="34" charset="-120"/>
+              </a:rPr>
+              <a:t>Add an index on Student.cnic → physical: the internal schema changed</a:t>
+            </a:r>
+            <a:endParaRPr lang="en-US" sz="1800" dirty="0"/>
+          </a:p>
+          <a:p>
+            <a:pPr marL="342900" indent="-342900">
+              <a:spcAft>
+                <a:spcPts val="1800"/>
+              </a:spcAft>
+              <a:buSzPct val="100000"/>
+              <a:buChar char="•"/>
+            </a:pPr>
+            <a:r>
+              <a:rPr lang="en-US" sz="1800" dirty="0">
+                <a:solidFill>
+                  <a:srgbClr val="1F2429"/>
+                </a:solidFill>
+                <a:latin typeface="Calibri" pitchFamily="34" charset="0"/>
+                <a:ea typeface="Calibri" pitchFamily="34" charset="-122"/>
+                <a:cs typeface="Calibri" pitchFamily="34" charset="-120"/>
+              </a:rPr>
+              <a:t>Split Student into Student and Address → logical: the conceptual schema changed</a:t>
+            </a:r>
+            <a:endParaRPr lang="en-US" sz="1800" dirty="0"/>
+          </a:p>
+          <a:p>
+            <a:pPr marL="342900" indent="-342900">
+              <a:spcAft>
+                <a:spcPts val="1800"/>
+              </a:spcAft>
+              <a:buSzPct val="100000"/>
+              <a:buChar char="•"/>
+            </a:pPr>
+            <a:r>
+              <a:rPr lang="en-US" sz="1800" dirty="0">
+                <a:solidFill>
+                  <a:srgbClr val="1F2429"/>
+                </a:solidFill>
+                <a:latin typeface="Calibri" pitchFamily="34" charset="0"/>
+                <a:ea typeface="Calibri" pitchFamily="34" charset="-122"/>
+                <a:cs typeface="Calibri" pitchFamily="34" charset="-120"/>
+              </a:rPr>
+              <a:t>Move the database files to SSD storage → physical: the internal schema changed</a:t>
+            </a:r>
+            <a:endParaRPr lang="en-US" sz="1800" dirty="0"/>
+          </a:p>
+          <a:p>
+            <a:pPr marL="342900" indent="-342900">
+              <a:spcAft>
+                <a:spcPts val="1800"/>
+              </a:spcAft>
+              <a:buSzPct val="100000"/>
+              <a:buChar char="•"/>
+            </a:pPr>
+            <a:r>
+              <a:rPr lang="en-US" sz="1800" dirty="0">
+                <a:solidFill>
+                  <a:srgbClr val="1F2429"/>
+                </a:solidFill>
+                <a:latin typeface="Calibri" pitchFamily="34" charset="0"/>
+                <a:ea typeface="Calibri" pitchFamily="34" charset="-122"/>
+                <a:cs typeface="Calibri" pitchFamily="34" charset="-120"/>
+              </a:rPr>
+              <a:t>Rename a column label in one user's report only → neither: it is a mapping inside the external level</a:t>
+            </a:r>
+            <a:endParaRPr lang="en-US" sz="1800" dirty="0"/>
+          </a:p>
+          <a:p>
+            <a:pPr marL="342900" indent="-342900">
+              <a:spcAft>
+                <a:spcPts val="1800"/>
+              </a:spcAft>
+              <a:buSzPct val="100000"/>
+              <a:buChar char="•"/>
+            </a:pPr>
+            <a:r>
+              <a:rPr lang="en-US" sz="1800" dirty="0">
+                <a:solidFill>
+                  <a:srgbClr val="1F2429"/>
+                </a:solidFill>
+                <a:latin typeface="Calibri" pitchFamily="34" charset="0"/>
+                <a:ea typeface="Calibri" pitchFamily="34" charset="-122"/>
+                <a:cs typeface="Calibri" pitchFamily="34" charset="-120"/>
+              </a:rPr>
+              <a:t>Anchor: ask which schema changed — conceptual points to logical, internal points to physical</a:t>
+            </a:r>
+            <a:endParaRPr lang="en-US" sz="1800" dirty="0"/>
+          </a:p>
+        </p:txBody>
+      </p:sp>
+    </p:spTree>
+  </p:cSld>
+  <p:clrMapOvr>
+    <a:masterClrMapping/>
+  </p:clrMapOvr>
+</p:sld>
+</file>
+
+<file path=ppt/slides/slide22.xml><?xml version="1.0" encoding="utf-8"?>
+<p:sld xmlns:a="http://schemas.openxmlformats.org/drawingml/2006/main" xmlns:r="http://schemas.openxmlformats.org/officeDocument/2006/relationships" xmlns:p="http://schemas.openxmlformats.org/presentationml/2006/main">
+  <p:cSld name="Slide 2">
+    <p:bg>
+      <p:bgPr>
+        <a:solidFill>
+          <a:srgbClr val="F7F8F9"/>
+        </a:solidFill>
+      </p:bgPr>
+    </p:bg>
+    <p:spTree>
+      <p:nvGrpSpPr>
+        <p:cNvPr id="1" name=""/>
+        <p:cNvGrpSpPr/>
+        <p:nvPr/>
+      </p:nvGrpSpPr>
+      <p:grpSpPr>
+        <a:xfrm>
+          <a:off x="0" y="0"/>
+          <a:ext cx="0" cy="0"/>
+          <a:chOff x="0" y="0"/>
+          <a:chExt cx="0" cy="0"/>
+        </a:xfrm>
+      </p:grpSpPr>
+      <p:sp>
+        <p:nvSpPr>
+          <p:cNvPr id="2" name="Text 0"/>
+          <p:cNvSpPr txBox="1"/>
+          <p:nvPr/>
+        </p:nvSpPr>
+        <p:spPr>
+          <a:xfrm>
+            <a:off x="548640" y="365760"/>
+            <a:ext cx="11064240" cy="731520"/>
+          </a:xfrm>
+          <a:prstGeom prst="rect">
+            <a:avLst/>
+          </a:prstGeom>
+          <a:noFill/>
+          <a:ln/>
+        </p:spPr>
+        <p:txBody>
+          <a:bodyPr wrap="square" lIns="0" tIns="0" rIns="0" bIns="0" rtlCol="0" anchor="ctr"/>
+          <a:lstStyle/>
+          <a:p>
+            <a:pPr indent="0" marL="0">
+              <a:buNone/>
+            </a:pPr>
+            <a:r>
+              <a:rPr lang="en-US" sz="2800" b="1" dirty="0">
+                <a:solidFill>
+                  <a:srgbClr val="1F2429"/>
+                </a:solidFill>
+                <a:latin typeface="Calibri" pitchFamily="34" charset="0"/>
+                <a:ea typeface="Calibri" pitchFamily="34" charset="-122"/>
+                <a:cs typeface="Calibri" pitchFamily="34" charset="-120"/>
+              </a:rPr>
+              <a:t>From Architecture to Independence: Recap</a:t>
+            </a:r>
+            <a:endParaRPr lang="en-US" sz="2800" dirty="0"/>
+          </a:p>
+        </p:txBody>
+      </p:sp>
+      <p:sp>
+        <p:nvSpPr>
+          <p:cNvPr id="3" name="Text 1"/>
+          <p:cNvSpPr txBox="1"/>
+          <p:nvPr/>
+        </p:nvSpPr>
+        <p:spPr>
+          <a:xfrm>
+            <a:off x="9951415" y="6455664"/>
+            <a:ext cx="2011680" cy="292608"/>
+          </a:xfrm>
+          <a:prstGeom prst="rect">
+            <a:avLst/>
+          </a:prstGeom>
+          <a:noFill/>
+          <a:ln/>
+        </p:spPr>
+        <p:txBody>
+          <a:bodyPr wrap="square" lIns="0" tIns="0" rIns="0" bIns="0" rtlCol="0" anchor="ctr"/>
+          <a:lstStyle/>
+          <a:p>
+            <a:pPr algn="r" indent="0" marL="0">
+              <a:buNone/>
+            </a:pPr>
+            <a:r>
+              <a:rPr lang="en-US" sz="1200" u="sng" dirty="0">
+                <a:solidFill>
+                  <a:srgbClr val="8A939B"/>
+                </a:solidFill>
+                <a:latin typeface="Calibri" pitchFamily="34" charset="0"/>
+                <a:ea typeface="Calibri" pitchFamily="34" charset="-122"/>
+                <a:cs typeface="Calibri" pitchFamily="34" charset="-120"/>
+                <a:hlinkClick r:id="rId1" invalidUrl="" action="" tgtFrame="" tooltip="" history="1" highlightClick="0" endSnd="0">
+                  <a:extLst>
+                    <a:ext uri="{A12FA001-AC4F-418D-AE19-62706E023703}">
+                      <ahyp:hlinkClr xmlns:ahyp="http://schemas.microsoft.com/office/drawing/2018/hyperlinkcolor" val="tx"/>
+                    </a:ext>
+                  </a:extLst>
+                </a:hlinkClick>
+              </a:rPr>
+              <a:t>cuinotes.com</a:t>
+            </a:r>
+            <a:pPr algn="r" indent="0" marL="0">
+              <a:buNone/>
+            </a:pPr>
+            <a:r>
+              <a:rPr lang="en-US" sz="1200" dirty="0">
+                <a:solidFill>
+                  <a:srgbClr val="8A939B"/>
+                </a:solidFill>
+                <a:latin typeface="Calibri" pitchFamily="34" charset="0"/>
+                <a:ea typeface="Calibri" pitchFamily="34" charset="-122"/>
+                <a:cs typeface="Calibri" pitchFamily="34" charset="-120"/>
+              </a:rPr>
+              <a:t>  ·  21</a:t>
+            </a:r>
+            <a:endParaRPr lang="en-US" sz="1200" dirty="0"/>
+          </a:p>
+        </p:txBody>
+      </p:sp>
+      <p:sp>
+        <p:nvSpPr>
+          <p:cNvPr id="4" name="Text 2"/>
+          <p:cNvSpPr txBox="1"/>
+          <p:nvPr/>
+        </p:nvSpPr>
+        <p:spPr>
+          <a:xfrm>
+            <a:off x="640080" y="1371600"/>
+            <a:ext cx="10332720" cy="4846320"/>
+          </a:xfrm>
+          <a:prstGeom prst="rect">
+            <a:avLst/>
+          </a:prstGeom>
+          <a:noFill/>
+          <a:ln/>
+        </p:spPr>
+        <p:txBody>
+          <a:bodyPr wrap="square" lIns="0" tIns="0" rIns="0" bIns="0" rtlCol="0" anchor="t"/>
+          <a:lstStyle/>
+          <a:p>
+            <a:pPr marL="342900" indent="-342900">
+              <a:spcAft>
+                <a:spcPts val="1800"/>
+              </a:spcAft>
+              <a:buSzPct val="100000"/>
+              <a:buChar char="•"/>
+            </a:pPr>
+            <a:r>
+              <a:rPr lang="en-US" sz="1800" dirty="0">
+                <a:solidFill>
+                  <a:srgbClr val="1F2429"/>
+                </a:solidFill>
+                <a:latin typeface="Calibri" pitchFamily="34" charset="0"/>
+                <a:ea typeface="Calibri" pitchFamily="34" charset="-122"/>
+                <a:cs typeface="Calibri" pitchFamily="34" charset="-120"/>
+              </a:rPr>
+              <a:t>Client-server architecture describes where components run: two tiers put logic on every client, three tiers centralize it</a:t>
+            </a:r>
+            <a:endParaRPr lang="en-US" sz="1800" dirty="0"/>
+          </a:p>
+          <a:p>
+            <a:pPr marL="342900" indent="-342900">
+              <a:spcAft>
+                <a:spcPts val="1800"/>
+              </a:spcAft>
+              <a:buSzPct val="100000"/>
+              <a:buChar char="•"/>
+            </a:pPr>
+            <a:r>
+              <a:rPr lang="en-US" sz="1800" dirty="0">
+                <a:solidFill>
+                  <a:srgbClr val="1F2429"/>
+                </a:solidFill>
+                <a:latin typeface="Calibri" pitchFamily="34" charset="0"/>
+                <a:ea typeface="Calibri" pitchFamily="34" charset="-122"/>
+                <a:cs typeface="Calibri" pitchFamily="34" charset="-120"/>
+              </a:rPr>
+              <a:t>The three-schema architecture describes how one copy of the data is seen at three levels</a:t>
+            </a:r>
+            <a:endParaRPr lang="en-US" sz="1800" dirty="0"/>
+          </a:p>
+          <a:p>
+            <a:pPr marL="342900" indent="-342900">
+              <a:spcAft>
+                <a:spcPts val="1800"/>
+              </a:spcAft>
+              <a:buSzPct val="100000"/>
+              <a:buChar char="•"/>
+            </a:pPr>
+            <a:r>
+              <a:rPr lang="en-US" sz="1800" dirty="0">
+                <a:solidFill>
+                  <a:srgbClr val="1F2429"/>
+                </a:solidFill>
+                <a:latin typeface="Calibri" pitchFamily="34" charset="0"/>
+                <a:ea typeface="Calibri" pitchFamily="34" charset="-122"/>
+                <a:cs typeface="Calibri" pitchFamily="34" charset="-120"/>
+              </a:rPr>
+              <a:t>Mappings translate each request between levels, and they are the only place that changes when a schema changes</a:t>
+            </a:r>
+            <a:endParaRPr lang="en-US" sz="1800" dirty="0"/>
+          </a:p>
+          <a:p>
+            <a:pPr marL="342900" indent="-342900">
+              <a:spcAft>
+                <a:spcPts val="1800"/>
+              </a:spcAft>
+              <a:buSzPct val="100000"/>
+              <a:buChar char="•"/>
+            </a:pPr>
+            <a:r>
+              <a:rPr lang="en-US" sz="1800" dirty="0">
+                <a:solidFill>
+                  <a:srgbClr val="1F2429"/>
+                </a:solidFill>
+                <a:latin typeface="Calibri" pitchFamily="34" charset="0"/>
+                <a:ea typeface="Calibri" pitchFamily="34" charset="-122"/>
+                <a:cs typeface="Calibri" pitchFamily="34" charset="-120"/>
+              </a:rPr>
+              <a:t>Logical independence shields users from conceptual changes; physical independence shields the conceptual level from storage changes</a:t>
+            </a:r>
+            <a:endParaRPr lang="en-US" sz="1800" dirty="0"/>
+          </a:p>
+          <a:p>
+            <a:pPr marL="342900" indent="-342900">
+              <a:spcAft>
+                <a:spcPts val="1800"/>
+              </a:spcAft>
+              <a:buSzPct val="100000"/>
+              <a:buChar char="•"/>
+            </a:pPr>
+            <a:r>
+              <a:rPr lang="en-US" sz="1800" dirty="0">
+                <a:solidFill>
+                  <a:srgbClr val="1F2429"/>
+                </a:solidFill>
+                <a:latin typeface="Calibri" pitchFamily="34" charset="0"/>
+                <a:ea typeface="Calibri" pitchFamily="34" charset="-122"/>
+                <a:cs typeface="Calibri" pitchFamily="34" charset="-120"/>
+              </a:rPr>
+              <a:t>This is the direct answer to Lecture 2's data-dependence problem: changes stay contained instead of cascading</a:t>
+            </a:r>
+            <a:endParaRPr lang="en-US" sz="1800" dirty="0"/>
+          </a:p>
+        </p:txBody>
+      </p:sp>
+    </p:spTree>
+  </p:cSld>
+  <p:clrMapOvr>
+    <a:masterClrMapping/>
+  </p:clrMapOvr>
+</p:sld>
+</file>
+
+<file path=ppt/slides/slide23.xml><?xml version="1.0" encoding="utf-8"?>
+<p:sld xmlns:a="http://schemas.openxmlformats.org/drawingml/2006/main" xmlns:r="http://schemas.openxmlformats.org/officeDocument/2006/relationships" xmlns:p="http://schemas.openxmlformats.org/presentationml/2006/main">
+  <p:cSld name="Slide 2">
+    <p:bg>
+      <p:bgPr>
+        <a:solidFill>
+          <a:srgbClr val="F7F8F9"/>
+        </a:solidFill>
+      </p:bgPr>
+    </p:bg>
+    <p:spTree>
+      <p:nvGrpSpPr>
+        <p:cNvPr id="1" name=""/>
+        <p:cNvGrpSpPr/>
+        <p:nvPr/>
+      </p:nvGrpSpPr>
+      <p:grpSpPr>
+        <a:xfrm>
+          <a:off x="0" y="0"/>
+          <a:ext cx="0" cy="0"/>
+          <a:chOff x="0" y="0"/>
+          <a:chExt cx="0" cy="0"/>
+        </a:xfrm>
+      </p:grpSpPr>
+      <p:sp>
+        <p:nvSpPr>
+          <p:cNvPr id="2" name="Text 0"/>
+          <p:cNvSpPr txBox="1"/>
+          <p:nvPr/>
+        </p:nvSpPr>
+        <p:spPr>
+          <a:xfrm>
+            <a:off x="548640" y="365760"/>
+            <a:ext cx="11064240" cy="731520"/>
+          </a:xfrm>
+          <a:prstGeom prst="rect">
+            <a:avLst/>
+          </a:prstGeom>
+          <a:noFill/>
+          <a:ln/>
+        </p:spPr>
+        <p:txBody>
+          <a:bodyPr wrap="square" lIns="0" tIns="0" rIns="0" bIns="0" rtlCol="0" anchor="ctr"/>
+          <a:lstStyle/>
+          <a:p>
+            <a:pPr indent="0" marL="0">
+              <a:buNone/>
+            </a:pPr>
+            <a:r>
+              <a:rPr lang="en-US" sz="2800" b="1" dirty="0">
+                <a:solidFill>
+                  <a:srgbClr val="1F2429"/>
+                </a:solidFill>
+                <a:latin typeface="Calibri" pitchFamily="34" charset="0"/>
+                <a:ea typeface="Calibri" pitchFamily="34" charset="-122"/>
+                <a:cs typeface="Calibri" pitchFamily="34" charset="-120"/>
+              </a:rPr>
+              <a:t>Looking Ahead: Lecture 5 — The Relational Model</a:t>
+            </a:r>
+            <a:endParaRPr lang="en-US" sz="2800" dirty="0"/>
+          </a:p>
+        </p:txBody>
+      </p:sp>
+      <p:sp>
+        <p:nvSpPr>
+          <p:cNvPr id="3" name="Text 1"/>
+          <p:cNvSpPr txBox="1"/>
+          <p:nvPr/>
+        </p:nvSpPr>
+        <p:spPr>
+          <a:xfrm>
+            <a:off x="9951415" y="6455664"/>
+            <a:ext cx="2011680" cy="292608"/>
+          </a:xfrm>
+          <a:prstGeom prst="rect">
+            <a:avLst/>
+          </a:prstGeom>
+          <a:noFill/>
+          <a:ln/>
+        </p:spPr>
+        <p:txBody>
+          <a:bodyPr wrap="square" lIns="0" tIns="0" rIns="0" bIns="0" rtlCol="0" anchor="ctr"/>
+          <a:lstStyle/>
+          <a:p>
+            <a:pPr algn="r" indent="0" marL="0">
+              <a:buNone/>
+            </a:pPr>
+            <a:r>
+              <a:rPr lang="en-US" sz="1200" u="sng" dirty="0">
+                <a:solidFill>
+                  <a:srgbClr val="8A939B"/>
+                </a:solidFill>
+                <a:latin typeface="Calibri" pitchFamily="34" charset="0"/>
+                <a:ea typeface="Calibri" pitchFamily="34" charset="-122"/>
+                <a:cs typeface="Calibri" pitchFamily="34" charset="-120"/>
+                <a:hlinkClick r:id="rId1" invalidUrl="" action="" tgtFrame="" tooltip="" history="1" highlightClick="0" endSnd="0">
+                  <a:extLst>
+                    <a:ext uri="{A12FA001-AC4F-418D-AE19-62706E023703}">
+                      <ahyp:hlinkClr xmlns:ahyp="http://schemas.microsoft.com/office/drawing/2018/hyperlinkcolor" val="tx"/>
+                    </a:ext>
+                  </a:extLst>
+                </a:hlinkClick>
+              </a:rPr>
+              <a:t>cuinotes.com</a:t>
+            </a:r>
+            <a:pPr algn="r" indent="0" marL="0">
+              <a:buNone/>
+            </a:pPr>
+            <a:r>
+              <a:rPr lang="en-US" sz="1200" dirty="0">
+                <a:solidFill>
+                  <a:srgbClr val="8A939B"/>
+                </a:solidFill>
+                <a:latin typeface="Calibri" pitchFamily="34" charset="0"/>
+                <a:ea typeface="Calibri" pitchFamily="34" charset="-122"/>
+                <a:cs typeface="Calibri" pitchFamily="34" charset="-120"/>
+              </a:rPr>
+              <a:t>  ·  23</a:t>
+            </a:r>
+            <a:endParaRPr lang="en-US" sz="1200" dirty="0"/>
+          </a:p>
+        </p:txBody>
+      </p:sp>
+      <p:sp>
+        <p:nvSpPr>
+          <p:cNvPr id="4" name="Text 2"/>
+          <p:cNvSpPr txBox="1"/>
+          <p:nvPr/>
+        </p:nvSpPr>
+        <p:spPr>
+          <a:xfrm>
+            <a:off x="640080" y="1371600"/>
+            <a:ext cx="10332720" cy="4846320"/>
+          </a:xfrm>
+          <a:prstGeom prst="rect">
+            <a:avLst/>
+          </a:prstGeom>
+          <a:noFill/>
+          <a:ln/>
+        </p:spPr>
+        <p:txBody>
+          <a:bodyPr wrap="square" lIns="0" tIns="0" rIns="0" bIns="0" rtlCol="0" anchor="t"/>
+          <a:lstStyle/>
+          <a:p>
+            <a:pPr marL="342900" indent="-342900">
+              <a:spcAft>
+                <a:spcPts val="1800"/>
+              </a:spcAft>
+              <a:buSzPct val="100000"/>
+              <a:buChar char="•"/>
+            </a:pPr>
+            <a:r>
+              <a:rPr lang="en-US" sz="1800" dirty="0">
+                <a:solidFill>
+                  <a:srgbClr val="1F2429"/>
+                </a:solidFill>
+                <a:latin typeface="Calibri" pitchFamily="34" charset="0"/>
+                <a:ea typeface="Calibri" pitchFamily="34" charset="-122"/>
+                <a:cs typeface="Calibri" pitchFamily="34" charset="-120"/>
+              </a:rPr>
+              <a:t>Lecture 5 formalizes the conceptual level introduced here as the relational model</a:t>
+            </a:r>
+            <a:endParaRPr lang="en-US" sz="1800" dirty="0"/>
+          </a:p>
+          <a:p>
+            <a:pPr marL="342900" indent="-342900">
+              <a:spcAft>
+                <a:spcPts val="1800"/>
+              </a:spcAft>
+              <a:buSzPct val="100000"/>
+              <a:buChar char="•"/>
+            </a:pPr>
+            <a:r>
+              <a:rPr lang="en-US" sz="1800" dirty="0">
+                <a:solidFill>
+                  <a:srgbClr val="1F2429"/>
+                </a:solidFill>
+                <a:latin typeface="Calibri" pitchFamily="34" charset="0"/>
+                <a:ea typeface="Calibri" pitchFamily="34" charset="-122"/>
+                <a:cs typeface="Calibri" pitchFamily="34" charset="-120"/>
+              </a:rPr>
+              <a:t>You'll meet relations, tuples, attributes, and domains with precise definitions</a:t>
+            </a:r>
+            <a:endParaRPr lang="en-US" sz="1800" dirty="0"/>
+          </a:p>
+          <a:p>
+            <a:pPr marL="342900" indent="-342900">
+              <a:spcAft>
+                <a:spcPts val="1800"/>
+              </a:spcAft>
+              <a:buSzPct val="100000"/>
+              <a:buChar char="•"/>
+            </a:pPr>
+            <a:r>
+              <a:rPr lang="en-US" sz="1800" dirty="0">
+                <a:solidFill>
+                  <a:srgbClr val="1F2429"/>
+                </a:solidFill>
+                <a:latin typeface="Calibri" pitchFamily="34" charset="0"/>
+                <a:ea typeface="Calibri" pitchFamily="34" charset="-122"/>
+                <a:cs typeface="Calibri" pitchFamily="34" charset="-120"/>
+              </a:rPr>
+              <a:t>You'll learn keys and integrity constraints — the rules the conceptual schema must enforce</a:t>
+            </a:r>
+            <a:endParaRPr lang="en-US" sz="1800" dirty="0"/>
+          </a:p>
+          <a:p>
+            <a:pPr marL="342900" indent="-342900">
+              <a:spcAft>
+                <a:spcPts val="1800"/>
+              </a:spcAft>
+              <a:buSzPct val="100000"/>
+              <a:buChar char="•"/>
+            </a:pPr>
+            <a:r>
+              <a:rPr lang="en-US" sz="1800" dirty="0">
+                <a:solidFill>
+                  <a:srgbClr val="1F2429"/>
+                </a:solidFill>
+                <a:latin typeface="Calibri" pitchFamily="34" charset="0"/>
+                <a:ea typeface="Calibri" pitchFamily="34" charset="-122"/>
+                <a:cs typeface="Calibri" pitchFamily="34" charset="-120"/>
+              </a:rPr>
+              <a:t>Everything so far in this course — the database approach, languages, and architecture — rests on that model</a:t>
+            </a:r>
+            <a:endParaRPr lang="en-US" sz="1800" dirty="0"/>
           </a:p>
         </p:txBody>
       </p:sp>
@@ -3104,7 +6254,7 @@
               <a:buNone/>
             </a:pPr>
             <a:r>
-              <a:rPr lang="en-US" sz="1000" u="sng" dirty="0">
+              <a:rPr lang="en-US" sz="1200" u="sng" dirty="0">
                 <a:solidFill>
                   <a:srgbClr val="8A939B"/>
                 </a:solidFill>
@@ -3125,7 +6275,7 @@
               <a:buNone/>
             </a:pPr>
             <a:r>
-              <a:rPr lang="en-US" sz="1000" dirty="0">
+              <a:rPr lang="en-US" sz="1200" dirty="0">
                 <a:solidFill>
                   <a:srgbClr val="8A939B"/>
                 </a:solidFill>
@@ -3135,7 +6285,7 @@
               </a:rPr>
               <a:t>  ·  3</a:t>
             </a:r>
-            <a:endParaRPr lang="en-US" sz="1000" dirty="0"/>
+            <a:endParaRPr lang="en-US" sz="1200" dirty="0"/>
           </a:p>
         </p:txBody>
       </p:sp>
@@ -3164,7 +6314,7 @@
               <a:buNone/>
             </a:pPr>
             <a:r>
-              <a:rPr lang="en-US" sz="1450" dirty="0">
+              <a:rPr lang="en-US" sz="1800" dirty="0">
                 <a:solidFill>
                   <a:srgbClr val="1F2429"/>
                 </a:solidFill>
@@ -3174,7 +6324,7 @@
               </a:rPr>
               <a:t>Before looking inside a DBMS, it's worth asking where it physically runs. In a two-tier architecture, the system splits into exactly two parts:</a:t>
             </a:r>
-            <a:endParaRPr lang="en-US" sz="1450" dirty="0"/>
+            <a:endParaRPr lang="en-US" sz="1800" dirty="0"/>
           </a:p>
         </p:txBody>
       </p:sp>
@@ -3203,7 +6353,7 @@
               <a:buNone/>
             </a:pPr>
             <a:r>
-              <a:rPr lang="en-US" sz="1200" b="1" dirty="0">
+              <a:rPr lang="en-US" sz="1800" b="1" dirty="0">
                 <a:solidFill>
                   <a:srgbClr val="8A939B"/>
                 </a:solidFill>
@@ -3213,7 +6363,7 @@
               </a:rPr>
               <a:t>Two-tier client-server architecture</a:t>
             </a:r>
-            <a:endParaRPr lang="en-US" sz="1200" dirty="0"/>
+            <a:endParaRPr lang="en-US" sz="1800" dirty="0"/>
           </a:p>
         </p:txBody>
       </p:sp>
@@ -3264,7 +6414,7 @@
               <a:buNone/>
             </a:pPr>
             <a:r>
-              <a:rPr lang="en-US" sz="1300" b="1" dirty="0">
+              <a:rPr lang="en-US" sz="1800" b="1" dirty="0">
                 <a:solidFill>
                   <a:srgbClr val="FFFFFF"/>
                 </a:solidFill>
@@ -3274,7 +6424,7 @@
               </a:rPr>
               <a:t>Client</a:t>
             </a:r>
-            <a:endParaRPr lang="en-US" sz="1300" dirty="0"/>
+            <a:endParaRPr lang="en-US" sz="1800" dirty="0"/>
           </a:p>
         </p:txBody>
       </p:sp>
@@ -3303,7 +6453,7 @@
               <a:buNone/>
             </a:pPr>
             <a:r>
-              <a:rPr lang="en-US" sz="1000" dirty="0">
+              <a:rPr lang="en-US" sz="1800" dirty="0">
                 <a:solidFill>
                   <a:srgbClr val="FFFFFF"/>
                 </a:solidFill>
@@ -3313,7 +6463,7 @@
               </a:rPr>
               <a:t>UI + application/business logic (e.g. a bank teller's desktop application)</a:t>
             </a:r>
-            <a:endParaRPr lang="en-US" sz="1000" dirty="0"/>
+            <a:endParaRPr lang="en-US" sz="1800" dirty="0"/>
           </a:p>
         </p:txBody>
       </p:sp>
@@ -3384,7 +6534,7 @@
               <a:buNone/>
             </a:pPr>
             <a:r>
-              <a:rPr lang="en-US" sz="1300" b="1" dirty="0">
+              <a:rPr lang="en-US" sz="1800" b="1" dirty="0">
                 <a:solidFill>
                   <a:srgbClr val="FFFFFF"/>
                 </a:solidFill>
@@ -3394,7 +6544,7 @@
               </a:rPr>
               <a:t>Server</a:t>
             </a:r>
-            <a:endParaRPr lang="en-US" sz="1300" dirty="0"/>
+            <a:endParaRPr lang="en-US" sz="1800" dirty="0"/>
           </a:p>
         </p:txBody>
       </p:sp>
@@ -3423,7 +6573,7 @@
               <a:buNone/>
             </a:pPr>
             <a:r>
-              <a:rPr lang="en-US" sz="1000" dirty="0">
+              <a:rPr lang="en-US" sz="1800" dirty="0">
                 <a:solidFill>
                   <a:srgbClr val="FFFFFF"/>
                 </a:solidFill>
@@ -3433,7 +6583,7 @@
               </a:rPr>
               <a:t>DBMS + the stored database</a:t>
             </a:r>
-            <a:endParaRPr lang="en-US" sz="1000" dirty="0"/>
+            <a:endParaRPr lang="en-US" sz="1800" dirty="0"/>
           </a:p>
         </p:txBody>
       </p:sp>
@@ -3462,7 +6612,7 @@
               <a:buNone/>
             </a:pPr>
             <a:r>
-              <a:rPr lang="en-US" sz="1300" dirty="0">
+              <a:rPr lang="en-US" sz="1800" dirty="0">
                 <a:solidFill>
                   <a:srgbClr val="1F2429"/>
                 </a:solidFill>
@@ -3472,7 +6622,7 @@
               </a:rPr>
               <a:t>A classic example: an old-style desktop banking application on each teller's workstation, connecting straight to a central database server over the bank's internal network.</a:t>
             </a:r>
-            <a:endParaRPr lang="en-US" sz="1300" dirty="0"/>
+            <a:endParaRPr lang="en-US" sz="1800" dirty="0"/>
           </a:p>
         </p:txBody>
       </p:sp>
@@ -3528,7 +6678,7 @@
               <a:buNone/>
             </a:pPr>
             <a:r>
-              <a:rPr lang="en-US" sz="1300" b="1" dirty="0">
+              <a:rPr lang="en-US" sz="1800" b="1" dirty="0">
                 <a:solidFill>
                   <a:srgbClr val="1F2429"/>
                 </a:solidFill>
@@ -3542,7 +6692,7 @@
               <a:buNone/>
             </a:pPr>
             <a:r>
-              <a:rPr lang="en-US" sz="1300" dirty="0">
+              <a:rPr lang="en-US" sz="1800" dirty="0">
                 <a:solidFill>
                   <a:srgbClr val="1F2429"/>
                 </a:solidFill>
@@ -3552,7 +6702,7 @@
               </a:rPr>
               <a:t>This works well for a limited number of clients on a trusted internal network, but every client machine needs the full application installed and updated, business logic is duplicated across every client, and the database server must handle a direct connection from every single client — it stops scaling gracefully as users grow.</a:t>
             </a:r>
-            <a:endParaRPr lang="en-US" sz="1300" dirty="0"/>
+            <a:endParaRPr lang="en-US" sz="1800" dirty="0"/>
           </a:p>
         </p:txBody>
       </p:sp>
@@ -3652,7 +6802,7 @@
               <a:buNone/>
             </a:pPr>
             <a:r>
-              <a:rPr lang="en-US" sz="1000" u="sng" dirty="0">
+              <a:rPr lang="en-US" sz="1200" u="sng" dirty="0">
                 <a:solidFill>
                   <a:srgbClr val="8A939B"/>
                 </a:solidFill>
@@ -3673,7 +6823,7 @@
               <a:buNone/>
             </a:pPr>
             <a:r>
-              <a:rPr lang="en-US" sz="1000" dirty="0">
+              <a:rPr lang="en-US" sz="1200" dirty="0">
                 <a:solidFill>
                   <a:srgbClr val="8A939B"/>
                 </a:solidFill>
@@ -3681,9 +6831,9 @@
                 <a:ea typeface="Calibri" pitchFamily="34" charset="-122"/>
                 <a:cs typeface="Calibri" pitchFamily="34" charset="-120"/>
               </a:rPr>
-              <a:t>  ·  4</a:t>
-            </a:r>
-            <a:endParaRPr lang="en-US" sz="1000" dirty="0"/>
+              <a:t>  ·  6</a:t>
+            </a:r>
+            <a:endParaRPr lang="en-US" sz="1200" dirty="0"/>
           </a:p>
         </p:txBody>
       </p:sp>
@@ -3712,7 +6862,7 @@
               <a:buNone/>
             </a:pPr>
             <a:r>
-              <a:rPr lang="en-US" sz="1450" dirty="0">
+              <a:rPr lang="en-US" sz="1800" dirty="0">
                 <a:solidFill>
                   <a:srgbClr val="1F2429"/>
                 </a:solidFill>
@@ -3722,7 +6872,7 @@
               </a:rPr>
               <a:t>A three-tier architecture splits the client's responsibilities further, inserting a middle layer between the user-facing client and the database server:</a:t>
             </a:r>
-            <a:endParaRPr lang="en-US" sz="1450" dirty="0"/>
+            <a:endParaRPr lang="en-US" sz="1800" dirty="0"/>
           </a:p>
         </p:txBody>
       </p:sp>
@@ -3751,7 +6901,7 @@
               <a:buNone/>
             </a:pPr>
             <a:r>
-              <a:rPr lang="en-US" sz="1200" b="1" dirty="0">
+              <a:rPr lang="en-US" sz="1800" b="1" dirty="0">
                 <a:solidFill>
                   <a:srgbClr val="8A939B"/>
                 </a:solidFill>
@@ -3761,7 +6911,7 @@
               </a:rPr>
               <a:t>Three-tier client-server architecture</a:t>
             </a:r>
-            <a:endParaRPr lang="en-US" sz="1200" dirty="0"/>
+            <a:endParaRPr lang="en-US" sz="1800" dirty="0"/>
           </a:p>
         </p:txBody>
       </p:sp>
@@ -3812,7 +6962,7 @@
               <a:buNone/>
             </a:pPr>
             <a:r>
-              <a:rPr lang="en-US" sz="1300" b="1" dirty="0">
+              <a:rPr lang="en-US" sz="1600" b="1" dirty="0">
                 <a:solidFill>
                   <a:srgbClr val="FFFFFF"/>
                 </a:solidFill>
@@ -3822,7 +6972,7 @@
               </a:rPr>
               <a:t>Presentation tier</a:t>
             </a:r>
-            <a:endParaRPr lang="en-US" sz="1300" dirty="0"/>
+            <a:endParaRPr lang="en-US" sz="1400" dirty="0"/>
           </a:p>
         </p:txBody>
       </p:sp>
@@ -3851,7 +7001,7 @@
               <a:buNone/>
             </a:pPr>
             <a:r>
-              <a:rPr lang="en-US" sz="1000" dirty="0">
+              <a:rPr lang="en-US" sz="1400" dirty="0">
                 <a:solidFill>
                   <a:srgbClr val="FFFFFF"/>
                 </a:solidFill>
@@ -3861,7 +7011,7 @@
               </a:rPr>
               <a:t>The client — a browser or thin app showing the UI only</a:t>
             </a:r>
-            <a:endParaRPr lang="en-US" sz="1000" dirty="0"/>
+            <a:endParaRPr lang="en-US" sz="1400" dirty="0"/>
           </a:p>
         </p:txBody>
       </p:sp>
@@ -3932,7 +7082,7 @@
               <a:buNone/>
             </a:pPr>
             <a:r>
-              <a:rPr lang="en-US" sz="1300" b="1" dirty="0">
+              <a:rPr lang="en-US" sz="1600" b="1" dirty="0">
                 <a:solidFill>
                   <a:srgbClr val="FFFFFF"/>
                 </a:solidFill>
@@ -3942,7 +7092,7 @@
               </a:rPr>
               <a:t>Application tier</a:t>
             </a:r>
-            <a:endParaRPr lang="en-US" sz="1300" dirty="0"/>
+            <a:endParaRPr lang="en-US" sz="1400" dirty="0"/>
           </a:p>
         </p:txBody>
       </p:sp>
@@ -3971,7 +7121,7 @@
               <a:buNone/>
             </a:pPr>
             <a:r>
-              <a:rPr lang="en-US" sz="1000" dirty="0">
+              <a:rPr lang="en-US" sz="1400" dirty="0">
                 <a:solidFill>
                   <a:srgbClr val="FFFFFF"/>
                 </a:solidFill>
@@ -3981,7 +7131,7 @@
               </a:rPr>
               <a:t>Application server — business logic and rules</a:t>
             </a:r>
-            <a:endParaRPr lang="en-US" sz="1000" dirty="0"/>
+            <a:endParaRPr lang="en-US" sz="1400" dirty="0"/>
           </a:p>
         </p:txBody>
       </p:sp>
@@ -4052,7 +7202,7 @@
               <a:buNone/>
             </a:pPr>
             <a:r>
-              <a:rPr lang="en-US" sz="1300" b="1" dirty="0">
+              <a:rPr lang="en-US" sz="1600" b="1" dirty="0">
                 <a:solidFill>
                   <a:srgbClr val="FFFFFF"/>
                 </a:solidFill>
@@ -4062,7 +7212,7 @@
               </a:rPr>
               <a:t>Data tier</a:t>
             </a:r>
-            <a:endParaRPr lang="en-US" sz="1300" dirty="0"/>
+            <a:endParaRPr lang="en-US" sz="1400" dirty="0"/>
           </a:p>
         </p:txBody>
       </p:sp>
@@ -4091,7 +7241,7 @@
               <a:buNone/>
             </a:pPr>
             <a:r>
-              <a:rPr lang="en-US" sz="1000" dirty="0">
+              <a:rPr lang="en-US" sz="1400" dirty="0">
                 <a:solidFill>
                   <a:srgbClr val="FFFFFF"/>
                 </a:solidFill>
@@ -4101,7 +7251,7 @@
               </a:rPr>
               <a:t>Database server — the DBMS and the stored database</a:t>
             </a:r>
-            <a:endParaRPr lang="en-US" sz="1000" dirty="0"/>
+            <a:endParaRPr lang="en-US" sz="1400" dirty="0"/>
           </a:p>
         </p:txBody>
       </p:sp>
@@ -4130,7 +7280,7 @@
               <a:buNone/>
             </a:pPr>
             <a:r>
-              <a:rPr lang="en-US" sz="1300" dirty="0">
+              <a:rPr lang="en-US" sz="1800" dirty="0">
                 <a:solidFill>
                   <a:srgbClr val="1F2429"/>
                 </a:solidFill>
@@ -4140,7 +7290,7 @@
               </a:rPr>
               <a:t>A modern online banking website is a textbook three-tier system: the webpage is the presentation tier, the bank's application servers enforcing daily transfer limits are the application tier, and the account database is the data tier.</a:t>
             </a:r>
-            <a:endParaRPr lang="en-US" sz="1300" dirty="0"/>
+            <a:endParaRPr lang="en-US" sz="1800" dirty="0"/>
           </a:p>
         </p:txBody>
       </p:sp>
@@ -4196,7 +7346,7 @@
               <a:buNone/>
             </a:pPr>
             <a:r>
-              <a:rPr lang="en-US" sz="1250" b="1" dirty="0">
+              <a:rPr lang="en-US" sz="1800" b="1" dirty="0">
                 <a:solidFill>
                   <a:srgbClr val="1F2429"/>
                 </a:solidFill>
@@ -4210,7 +7360,7 @@
               <a:buNone/>
             </a:pPr>
             <a:r>
-              <a:rPr lang="en-US" sz="1250" dirty="0">
+              <a:rPr lang="en-US" sz="1800" dirty="0">
                 <a:solidFill>
                   <a:srgbClr val="1F2429"/>
                 </a:solidFill>
@@ -4220,7 +7370,7 @@
               </a:rPr>
               <a:t>A single-tier desktop database and a three-tier web application can both internally follow the same three-schema organization.</a:t>
             </a:r>
-            <a:endParaRPr lang="en-US" sz="1250" dirty="0"/>
+            <a:endParaRPr lang="en-US" sz="1800" dirty="0"/>
           </a:p>
         </p:txBody>
       </p:sp>
@@ -4320,7 +7470,7 @@
               <a:buNone/>
             </a:pPr>
             <a:r>
-              <a:rPr lang="en-US" sz="1000" u="sng" dirty="0">
+              <a:rPr lang="en-US" sz="1200" u="sng" dirty="0">
                 <a:solidFill>
                   <a:srgbClr val="8A939B"/>
                 </a:solidFill>
@@ -4341,7 +7491,7 @@
               <a:buNone/>
             </a:pPr>
             <a:r>
-              <a:rPr lang="en-US" sz="1000" dirty="0">
+              <a:rPr lang="en-US" sz="1200" dirty="0">
                 <a:solidFill>
                   <a:srgbClr val="8A939B"/>
                 </a:solidFill>
@@ -4349,9 +7499,9 @@
                 <a:ea typeface="Calibri" pitchFamily="34" charset="-122"/>
                 <a:cs typeface="Calibri" pitchFamily="34" charset="-120"/>
               </a:rPr>
-              <a:t>  ·  5</a:t>
-            </a:r>
-            <a:endParaRPr lang="en-US" sz="1000" dirty="0"/>
+              <a:t>  ·  8</a:t>
+            </a:r>
+            <a:endParaRPr lang="en-US" sz="1200" dirty="0"/>
           </a:p>
         </p:txBody>
       </p:sp>
@@ -4380,7 +7530,7 @@
               <a:buNone/>
             </a:pPr>
             <a:r>
-              <a:rPr lang="en-US" sz="1400" dirty="0">
+              <a:rPr lang="en-US" sz="1800" dirty="0">
                 <a:solidFill>
                   <a:srgbClr val="1F2429"/>
                 </a:solidFill>
@@ -4390,7 +7540,7 @@
               </a:rPr>
               <a:t>The standard blueprint for how a DBMS organizes a database's structure into three levels, each describing the same underlying data from a different point of view:</a:t>
             </a:r>
-            <a:endParaRPr lang="en-US" sz="1400" dirty="0"/>
+            <a:endParaRPr lang="en-US" sz="1800" dirty="0"/>
           </a:p>
         </p:txBody>
       </p:sp>
@@ -4419,7 +7569,7 @@
               <a:buNone/>
             </a:pPr>
             <a:r>
-              <a:rPr lang="en-US" sz="1200" b="1" dirty="0">
+              <a:rPr lang="en-US" sz="1800" b="1" dirty="0">
                 <a:solidFill>
                   <a:srgbClr val="8A939B"/>
                 </a:solidFill>
@@ -4429,7 +7579,7 @@
               </a:rPr>
               <a:t>The ANSI-SPARC three-schema architecture</a:t>
             </a:r>
-            <a:endParaRPr lang="en-US" sz="1200" dirty="0"/>
+            <a:endParaRPr lang="en-US" sz="1800" dirty="0"/>
           </a:p>
         </p:txBody>
       </p:sp>
@@ -4480,7 +7630,7 @@
               <a:buNone/>
             </a:pPr>
             <a:r>
-              <a:rPr lang="en-US" sz="1500" b="1" dirty="0">
+              <a:rPr lang="en-US" sz="1600" b="1" dirty="0">
                 <a:solidFill>
                   <a:srgbClr val="FFFFFF"/>
                 </a:solidFill>
@@ -4519,7 +7669,7 @@
               <a:buNone/>
             </a:pPr>
             <a:r>
-              <a:rPr lang="en-US" sz="1100" dirty="0">
+              <a:rPr lang="en-US" sz="1800" dirty="0">
                 <a:solidFill>
                   <a:srgbClr val="FFFFFF"/>
                 </a:solidFill>
@@ -4529,7 +7679,7 @@
               </a:rPr>
               <a:t>Many external schemas, one per user group — each shows only the data that group needs</a:t>
             </a:r>
-            <a:endParaRPr lang="en-US" sz="1100" dirty="0"/>
+            <a:endParaRPr lang="en-US" sz="1800" dirty="0"/>
           </a:p>
         </p:txBody>
       </p:sp>
@@ -4580,7 +7730,7 @@
               <a:buNone/>
             </a:pPr>
             <a:r>
-              <a:rPr lang="en-US" sz="1500" b="1" dirty="0">
+              <a:rPr lang="en-US" sz="1600" b="1" dirty="0">
                 <a:solidFill>
                   <a:srgbClr val="FFFFFF"/>
                 </a:solidFill>
@@ -4619,7 +7769,7 @@
               <a:buNone/>
             </a:pPr>
             <a:r>
-              <a:rPr lang="en-US" sz="1100" dirty="0">
+              <a:rPr lang="en-US" sz="1800" dirty="0">
                 <a:solidFill>
                   <a:srgbClr val="FFFFFF"/>
                 </a:solidFill>
@@ -4629,7 +7779,7 @@
               </a:rPr>
               <a:t>One conceptual schema — the complete community view of the whole database's structure and rules</a:t>
             </a:r>
-            <a:endParaRPr lang="en-US" sz="1100" dirty="0"/>
+            <a:endParaRPr lang="en-US" sz="1800" dirty="0"/>
           </a:p>
         </p:txBody>
       </p:sp>
@@ -4680,7 +7830,7 @@
               <a:buNone/>
             </a:pPr>
             <a:r>
-              <a:rPr lang="en-US" sz="1500" b="1" dirty="0">
+              <a:rPr lang="en-US" sz="1600" b="1" dirty="0">
                 <a:solidFill>
                   <a:srgbClr val="FFFFFF"/>
                 </a:solidFill>
@@ -4719,7 +7869,7 @@
               <a:buNone/>
             </a:pPr>
             <a:r>
-              <a:rPr lang="en-US" sz="1100" dirty="0">
+              <a:rPr lang="en-US" sz="1800" dirty="0">
                 <a:solidFill>
                   <a:srgbClr val="FFFFFF"/>
                 </a:solidFill>
@@ -4729,7 +7879,7 @@
               </a:rPr>
               <a:t>One internal schema — how the data is actually stored on physical media</a:t>
             </a:r>
-            <a:endParaRPr lang="en-US" sz="1100" dirty="0"/>
+            <a:endParaRPr lang="en-US" sz="1800" dirty="0"/>
           </a:p>
         </p:txBody>
       </p:sp>
@@ -4785,7 +7935,7 @@
               <a:buNone/>
             </a:pPr>
             <a:r>
-              <a:rPr lang="en-US" sz="1250" b="1" dirty="0">
+              <a:rPr lang="en-US" sz="1800" b="1" dirty="0">
                 <a:solidFill>
                   <a:srgbClr val="1F2429"/>
                 </a:solidFill>
@@ -4799,7 +7949,7 @@
               <a:buNone/>
             </a:pPr>
             <a:r>
-              <a:rPr lang="en-US" sz="1250" dirty="0">
+              <a:rPr lang="en-US" sz="1800" dirty="0">
                 <a:solidFill>
                   <a:srgbClr val="1F2429"/>
                 </a:solidFill>
@@ -4809,7 +7959,7 @@
               </a:rPr>
               <a:t>There is exactly one physical copy of the data, described at the internal level. The external and conceptual levels are descriptions — schemas — not additional data stores.</a:t>
             </a:r>
-            <a:endParaRPr lang="en-US" sz="1250" dirty="0"/>
+            <a:endParaRPr lang="en-US" sz="1800" dirty="0"/>
           </a:p>
         </p:txBody>
       </p:sp>
@@ -4909,7 +8059,7 @@
               <a:buNone/>
             </a:pPr>
             <a:r>
-              <a:rPr lang="en-US" sz="1000" u="sng" dirty="0">
+              <a:rPr lang="en-US" sz="1200" u="sng" dirty="0">
                 <a:solidFill>
                   <a:srgbClr val="8A939B"/>
                 </a:solidFill>
@@ -4930,7 +8080,7 @@
               <a:buNone/>
             </a:pPr>
             <a:r>
-              <a:rPr lang="en-US" sz="1000" dirty="0">
+              <a:rPr lang="en-US" sz="1200" dirty="0">
                 <a:solidFill>
                   <a:srgbClr val="8A939B"/>
                 </a:solidFill>
@@ -4938,9 +8088,9 @@
                 <a:ea typeface="Calibri" pitchFamily="34" charset="-122"/>
                 <a:cs typeface="Calibri" pitchFamily="34" charset="-120"/>
               </a:rPr>
-              <a:t>  ·  6</a:t>
-            </a:r>
-            <a:endParaRPr lang="en-US" sz="1000" dirty="0"/>
+              <a:t>  ·  10</a:t>
+            </a:r>
+            <a:endParaRPr lang="en-US" sz="1200" dirty="0"/>
           </a:p>
         </p:txBody>
       </p:sp>
@@ -4969,7 +8119,7 @@
               <a:buNone/>
             </a:pPr>
             <a:r>
-              <a:rPr lang="en-US" sz="1450" b="1" dirty="0">
+              <a:rPr lang="en-US" sz="1800" b="1" dirty="0">
                 <a:solidFill>
                   <a:srgbClr val="2FE6C4"/>
                 </a:solidFill>
@@ -4983,7 +8133,7 @@
               <a:buNone/>
             </a:pPr>
             <a:r>
-              <a:rPr lang="en-US" sz="1450" dirty="0">
+              <a:rPr lang="en-US" sz="1800" dirty="0">
                 <a:solidFill>
                   <a:srgbClr val="1F2429"/>
                 </a:solidFill>
@@ -4993,7 +8143,7 @@
               </a:rPr>
               <a:t> is closest to individual users: a number of external schemas (user views), one per distinct user group, each describing only the part of the database that group cares about.</a:t>
             </a:r>
-            <a:endParaRPr lang="en-US" sz="1450" dirty="0"/>
+            <a:endParaRPr lang="en-US" sz="1800" dirty="0"/>
           </a:p>
         </p:txBody>
       </p:sp>
@@ -5022,7 +8172,7 @@
               <a:buNone/>
             </a:pPr>
             <a:r>
-              <a:rPr lang="en-US" sz="1300" dirty="0">
+              <a:rPr lang="en-US" sz="1800" dirty="0">
                 <a:solidFill>
                   <a:srgbClr val="8A939B"/>
                 </a:solidFill>
@@ -5032,7 +8182,7 @@
               </a:rPr>
               <a:t>Worked example: a university enrollment database. The conceptual schema holds full Student, Course, Enrollment, and Instructor relations, including sensitive fields like Student.cnic and Instructor.salary.</a:t>
             </a:r>
-            <a:endParaRPr lang="en-US" sz="1300" dirty="0"/>
+            <a:endParaRPr lang="en-US" sz="1800" dirty="0"/>
           </a:p>
         </p:txBody>
       </p:sp>
@@ -5061,7 +8211,7 @@
               <a:buNone/>
             </a:pPr>
             <a:r>
-              <a:rPr lang="en-US" sz="1200" b="1" dirty="0">
+              <a:rPr lang="en-US" sz="1800" b="1" dirty="0">
                 <a:solidFill>
                   <a:srgbClr val="8A939B"/>
                 </a:solidFill>
@@ -5071,7 +8221,7 @@
               </a:rPr>
               <a:t>Two external schemas over the same conceptual data</a:t>
             </a:r>
-            <a:endParaRPr lang="en-US" sz="1200" dirty="0"/>
+            <a:endParaRPr lang="en-US" sz="1800" dirty="0"/>
           </a:p>
         </p:txBody>
       </p:sp>
@@ -5122,7 +8272,7 @@
               <a:buNone/>
             </a:pPr>
             <a:r>
-              <a:rPr lang="en-US" sz="1350" b="1" dirty="0">
+              <a:rPr lang="en-US" sz="1800" b="1" dirty="0">
                 <a:solidFill>
                   <a:srgbClr val="FFFFFF"/>
                 </a:solidFill>
@@ -5132,7 +8282,7 @@
               </a:rPr>
               <a:t>External schema: Course Advisor</a:t>
             </a:r>
-            <a:endParaRPr lang="en-US" sz="1350" dirty="0"/>
+            <a:endParaRPr lang="en-US" sz="1800" dirty="0"/>
           </a:p>
         </p:txBody>
       </p:sp>
@@ -5161,7 +8311,7 @@
               <a:buNone/>
             </a:pPr>
             <a:r>
-              <a:rPr lang="en-US" sz="1050" dirty="0">
+              <a:rPr lang="en-US" sz="1800" dirty="0">
                 <a:solidFill>
                   <a:srgbClr val="FFFFFF"/>
                 </a:solidFill>
@@ -5171,7 +8321,7 @@
               </a:rPr>
               <a:t>StudentName, CourseTitle, Grade — no CNIC, no salary data at all</a:t>
             </a:r>
-            <a:endParaRPr lang="en-US" sz="1050" dirty="0"/>
+            <a:endParaRPr lang="en-US" sz="1800" dirty="0"/>
           </a:p>
         </p:txBody>
       </p:sp>
@@ -5222,7 +8372,7 @@
               <a:buNone/>
             </a:pPr>
             <a:r>
-              <a:rPr lang="en-US" sz="1350" b="1" dirty="0">
+              <a:rPr lang="en-US" sz="1800" b="1" dirty="0">
                 <a:solidFill>
                   <a:srgbClr val="FFFFFF"/>
                 </a:solidFill>
@@ -5232,7 +8382,7 @@
               </a:rPr>
               <a:t>External schema: Payroll Clerk</a:t>
             </a:r>
-            <a:endParaRPr lang="en-US" sz="1350" dirty="0"/>
+            <a:endParaRPr lang="en-US" sz="1800" dirty="0"/>
           </a:p>
         </p:txBody>
       </p:sp>
@@ -5261,7 +8411,7 @@
               <a:buNone/>
             </a:pPr>
             <a:r>
-              <a:rPr lang="en-US" sz="1050" dirty="0">
+              <a:rPr lang="en-US" sz="1800" dirty="0">
                 <a:solidFill>
                   <a:srgbClr val="FFFFFF"/>
                 </a:solidFill>
@@ -5271,7 +8421,7 @@
               </a:rPr>
               <a:t>InstructorName, Department, Salary — no student data at all</a:t>
             </a:r>
-            <a:endParaRPr lang="en-US" sz="1050" dirty="0"/>
+            <a:endParaRPr lang="en-US" sz="1800" dirty="0"/>
           </a:p>
         </p:txBody>
       </p:sp>
@@ -5300,7 +8450,7 @@
               <a:buNone/>
             </a:pPr>
             <a:r>
-              <a:rPr lang="en-US" sz="1250" dirty="0">
+              <a:rPr lang="en-US" sz="1800" dirty="0">
                 <a:solidFill>
                   <a:srgbClr val="8A939B"/>
                 </a:solidFill>
@@ -5310,7 +8460,7 @@
               </a:rPr>
               <a:t>Neither view shows the whole conceptual schema, and neither is aware the other exists — each is tailored to exactly what its user group is authorized to see and needs to work with.</a:t>
             </a:r>
-            <a:endParaRPr lang="en-US" sz="1250" dirty="0"/>
+            <a:endParaRPr lang="en-US" sz="1800" dirty="0"/>
           </a:p>
         </p:txBody>
       </p:sp>
@@ -5410,7 +8560,7 @@
               <a:buNone/>
             </a:pPr>
             <a:r>
-              <a:rPr lang="en-US" sz="1000" u="sng" dirty="0">
+              <a:rPr lang="en-US" sz="1200" u="sng" dirty="0">
                 <a:solidFill>
                   <a:srgbClr val="8A939B"/>
                 </a:solidFill>
@@ -5431,7 +8581,7 @@
               <a:buNone/>
             </a:pPr>
             <a:r>
-              <a:rPr lang="en-US" sz="1000" dirty="0">
+              <a:rPr lang="en-US" sz="1200" dirty="0">
                 <a:solidFill>
                   <a:srgbClr val="8A939B"/>
                 </a:solidFill>
@@ -5439,9 +8589,9 @@
                 <a:ea typeface="Calibri" pitchFamily="34" charset="-122"/>
                 <a:cs typeface="Calibri" pitchFamily="34" charset="-120"/>
               </a:rPr>
-              <a:t>  ·  7</a:t>
-            </a:r>
-            <a:endParaRPr lang="en-US" sz="1000" dirty="0"/>
+              <a:t>  ·  12</a:t>
+            </a:r>
+            <a:endParaRPr lang="en-US" sz="1200" dirty="0"/>
           </a:p>
         </p:txBody>
       </p:sp>
@@ -5529,7 +8679,7 @@
               <a:buNone/>
             </a:pPr>
             <a:r>
-              <a:rPr lang="en-US" sz="1500" b="1" dirty="0">
+              <a:rPr lang="en-US" sz="1800" b="1" dirty="0">
                 <a:solidFill>
                   <a:srgbClr val="1F2429"/>
                 </a:solidFill>
@@ -5539,7 +8689,7 @@
               </a:rPr>
               <a:t>Conceptual Level</a:t>
             </a:r>
-            <a:endParaRPr lang="en-US" sz="1500" dirty="0"/>
+            <a:endParaRPr lang="en-US" sz="1800" dirty="0"/>
           </a:p>
         </p:txBody>
       </p:sp>
@@ -5552,7 +8702,7 @@
         <p:spPr>
           <a:xfrm>
             <a:off x="1234440" y="1874520"/>
-            <a:ext cx="9875520" cy="822960"/>
+            <a:ext cx="9875520" cy="914400"/>
           </a:xfrm>
           <a:prstGeom prst="rect">
             <a:avLst/>
@@ -5568,7 +8718,7 @@
               <a:buNone/>
             </a:pPr>
             <a:r>
-              <a:rPr lang="en-US" sz="1300" dirty="0">
+              <a:rPr lang="en-US" sz="1800" dirty="0">
                 <a:solidFill>
                   <a:srgbClr val="1F2429"/>
                 </a:solidFill>
@@ -5578,7 +8728,7 @@
               </a:rPr>
               <a:t>Exactly one conceptual schema: a single, complete, community-wide view of the entire database's logical structure — every entity, relationship, and constraint — described without reference to physical storage, and without favoring any one external view.</a:t>
             </a:r>
-            <a:endParaRPr lang="en-US" sz="1300" dirty="0"/>
+            <a:endParaRPr lang="en-US" sz="1800" dirty="0"/>
           </a:p>
         </p:txBody>
       </p:sp>
@@ -5590,7 +8740,7 @@
         </p:nvSpPr>
         <p:spPr>
           <a:xfrm>
-            <a:off x="1234440" y="2606040"/>
+            <a:off x="1234440" y="2852928"/>
             <a:ext cx="9875520" cy="777240"/>
           </a:xfrm>
           <a:prstGeom prst="rect">
@@ -5607,7 +8757,7 @@
               <a:buNone/>
             </a:pPr>
             <a:r>
-              <a:rPr lang="en-US" sz="1200" i="1" dirty="0">
+              <a:rPr lang="en-US" sz="1800" i="1" dirty="0">
                 <a:solidFill>
                   <a:srgbClr val="8A939B"/>
                 </a:solidFill>
@@ -5617,7 +8767,7 @@
               </a:rPr>
               <a:t>For the university example: the full set of relations (Student, Course, Enrollment, Instructor) with all attributes, primary and foreign keys, and business rules — independent of whether data ends up on a hard disk, an SSD, or split across several servers.</a:t>
             </a:r>
-            <a:endParaRPr lang="en-US" sz="1200" dirty="0"/>
+            <a:endParaRPr lang="en-US" sz="1800" dirty="0"/>
           </a:p>
         </p:txBody>
       </p:sp>
@@ -5629,7 +8779,7 @@
         </p:nvSpPr>
         <p:spPr>
           <a:xfrm>
-            <a:off x="640080" y="3611880"/>
+            <a:off x="640080" y="3886200"/>
             <a:ext cx="457200" cy="457200"/>
           </a:xfrm>
           <a:prstGeom prst="ellipse">
@@ -5649,7 +8799,7 @@
         </p:nvSpPr>
         <p:spPr>
           <a:xfrm>
-            <a:off x="640080" y="3611880"/>
+            <a:off x="640080" y="3886200"/>
             <a:ext cx="457200" cy="457200"/>
           </a:xfrm>
           <a:prstGeom prst="rect">
@@ -5688,7 +8838,7 @@
         </p:nvSpPr>
         <p:spPr>
           <a:xfrm>
-            <a:off x="1234440" y="3584448"/>
+            <a:off x="1234440" y="3858768"/>
             <a:ext cx="9921240" cy="320040"/>
           </a:xfrm>
           <a:prstGeom prst="rect">
@@ -5705,7 +8855,7 @@
               <a:buNone/>
             </a:pPr>
             <a:r>
-              <a:rPr lang="en-US" sz="1500" b="1" dirty="0">
+              <a:rPr lang="en-US" sz="1800" b="1" dirty="0">
                 <a:solidFill>
                   <a:srgbClr val="1F2429"/>
                 </a:solidFill>
@@ -5715,7 +8865,7 @@
               </a:rPr>
               <a:t>Internal Level</a:t>
             </a:r>
-            <a:endParaRPr lang="en-US" sz="1500" dirty="0"/>
+            <a:endParaRPr lang="en-US" sz="1800" dirty="0"/>
           </a:p>
         </p:txBody>
       </p:sp>
@@ -5727,7 +8877,46 @@
         </p:nvSpPr>
         <p:spPr>
           <a:xfrm>
-            <a:off x="1234440" y="4114800"/>
+            <a:off x="1234440" y="4389120"/>
+            <a:ext cx="9875520" cy="914400"/>
+          </a:xfrm>
+          <a:prstGeom prst="rect">
+            <a:avLst/>
+          </a:prstGeom>
+          <a:noFill/>
+          <a:ln/>
+        </p:spPr>
+        <p:txBody>
+          <a:bodyPr wrap="square" lIns="0" tIns="0" rIns="0" bIns="0" rtlCol="0" anchor="t"/>
+          <a:lstStyle/>
+          <a:p>
+            <a:pPr indent="0" marL="0">
+              <a:buNone/>
+            </a:pPr>
+            <a:r>
+              <a:rPr lang="en-US" sz="1800" dirty="0">
+                <a:solidFill>
+                  <a:srgbClr val="1F2429"/>
+                </a:solidFill>
+                <a:latin typeface="Calibri" pitchFamily="34" charset="0"/>
+                <a:ea typeface="Calibri" pitchFamily="34" charset="-122"/>
+                <a:cs typeface="Calibri" pitchFamily="34" charset="-120"/>
+              </a:rPr>
+              <a:t>Exactly one internal schema, describing the physical storage representation: what files exist, what indexes exist, how records are laid out on disk, what compression or encoding is used. The only level that concerns itself with actual storage media.</a:t>
+            </a:r>
+            <a:endParaRPr lang="en-US" sz="1800" dirty="0"/>
+          </a:p>
+        </p:txBody>
+      </p:sp>
+      <p:sp>
+        <p:nvSpPr>
+          <p:cNvPr id="13" name="Text 11"/>
+          <p:cNvSpPr txBox="1"/>
+          <p:nvPr/>
+        </p:nvSpPr>
+        <p:spPr>
+          <a:xfrm>
+            <a:off x="1234440" y="5394960"/>
             <a:ext cx="9875520" cy="822960"/>
           </a:xfrm>
           <a:prstGeom prst="rect">
@@ -5744,46 +8933,7 @@
               <a:buNone/>
             </a:pPr>
             <a:r>
-              <a:rPr lang="en-US" sz="1300" dirty="0">
-                <a:solidFill>
-                  <a:srgbClr val="1F2429"/>
-                </a:solidFill>
-                <a:latin typeface="Calibri" pitchFamily="34" charset="0"/>
-                <a:ea typeface="Calibri" pitchFamily="34" charset="-122"/>
-                <a:cs typeface="Calibri" pitchFamily="34" charset="-120"/>
-              </a:rPr>
-              <a:t>Exactly one internal schema, describing the physical storage representation: what files exist, what indexes exist, how records are laid out on disk, what compression or encoding is used. The only level that concerns itself with actual storage media.</a:t>
-            </a:r>
-            <a:endParaRPr lang="en-US" sz="1300" dirty="0"/>
-          </a:p>
-        </p:txBody>
-      </p:sp>
-      <p:sp>
-        <p:nvSpPr>
-          <p:cNvPr id="13" name="Text 11"/>
-          <p:cNvSpPr txBox="1"/>
-          <p:nvPr/>
-        </p:nvSpPr>
-        <p:spPr>
-          <a:xfrm>
-            <a:off x="1234440" y="4846320"/>
-            <a:ext cx="9875520" cy="777240"/>
-          </a:xfrm>
-          <a:prstGeom prst="rect">
-            <a:avLst/>
-          </a:prstGeom>
-          <a:noFill/>
-          <a:ln/>
-        </p:spPr>
-        <p:txBody>
-          <a:bodyPr wrap="square" lIns="0" tIns="0" rIns="0" bIns="0" rtlCol="0" anchor="t"/>
-          <a:lstStyle/>
-          <a:p>
-            <a:pPr indent="0" marL="0">
-              <a:buNone/>
-            </a:pPr>
-            <a:r>
-              <a:rPr lang="en-US" sz="1200" i="1" dirty="0">
+              <a:rPr lang="en-US" sz="1800" i="1" dirty="0">
                 <a:solidFill>
                   <a:srgbClr val="8A939B"/>
                 </a:solidFill>
@@ -5793,7 +8943,7 @@
               </a:rPr>
               <a:t>For the university example: Student records stored in a B-tree-indexed file ordered by studentId, with a separate hash index on cnic — details no external-level user, and not even the conceptual schema, needs to know about.</a:t>
             </a:r>
-            <a:endParaRPr lang="en-US" sz="1200" dirty="0"/>
+            <a:endParaRPr lang="en-US" sz="1800" dirty="0"/>
           </a:p>
         </p:txBody>
       </p:sp>
@@ -5893,7 +9043,7 @@
               <a:buNone/>
             </a:pPr>
             <a:r>
-              <a:rPr lang="en-US" sz="1000" u="sng" dirty="0">
+              <a:rPr lang="en-US" sz="1200" u="sng" dirty="0">
                 <a:solidFill>
                   <a:srgbClr val="8A939B"/>
                 </a:solidFill>
@@ -5914,7 +9064,7 @@
               <a:buNone/>
             </a:pPr>
             <a:r>
-              <a:rPr lang="en-US" sz="1000" dirty="0">
+              <a:rPr lang="en-US" sz="1200" dirty="0">
                 <a:solidFill>
                   <a:srgbClr val="8A939B"/>
                 </a:solidFill>
@@ -5922,9 +9072,9 @@
                 <a:ea typeface="Calibri" pitchFamily="34" charset="-122"/>
                 <a:cs typeface="Calibri" pitchFamily="34" charset="-120"/>
               </a:rPr>
-              <a:t>  ·  8</a:t>
-            </a:r>
-            <a:endParaRPr lang="en-US" sz="1000" dirty="0"/>
+              <a:t>  ·  14</a:t>
+            </a:r>
+            <a:endParaRPr lang="en-US" sz="1200" dirty="0"/>
           </a:p>
         </p:txBody>
       </p:sp>
@@ -5953,7 +9103,7 @@
               <a:buNone/>
             </a:pPr>
             <a:r>
-              <a:rPr lang="en-US" sz="1400" dirty="0">
+              <a:rPr lang="en-US" sz="1800" dirty="0">
                 <a:solidFill>
                   <a:srgbClr val="1F2429"/>
                 </a:solidFill>
@@ -5963,7 +9113,7 @@
               </a:rPr>
               <a:t>Because the three levels describe the same data differently, the DBMS needs a way to translate a request made at one level into an action at another:</a:t>
             </a:r>
-            <a:endParaRPr lang="en-US" sz="1400" dirty="0"/>
+            <a:endParaRPr lang="en-US" sz="1800" dirty="0"/>
           </a:p>
         </p:txBody>
       </p:sp>
@@ -6014,7 +9164,7 @@
               <a:buNone/>
             </a:pPr>
             <a:r>
-              <a:rPr lang="en-US" sz="1400" b="1" dirty="0">
+              <a:rPr lang="en-US" sz="1800" b="1" dirty="0">
                 <a:solidFill>
                   <a:srgbClr val="FFFFFF"/>
                 </a:solidFill>
@@ -6024,7 +9174,7 @@
               </a:rPr>
               <a:t>External Level</a:t>
             </a:r>
-            <a:endParaRPr lang="en-US" sz="1400" dirty="0"/>
+            <a:endParaRPr lang="en-US" sz="1800" dirty="0"/>
           </a:p>
         </p:txBody>
       </p:sp>
@@ -6053,7 +9203,7 @@
               <a:buNone/>
             </a:pPr>
             <a:r>
-              <a:rPr lang="en-US" sz="1050" dirty="0">
+              <a:rPr lang="en-US" sz="1800" dirty="0">
                 <a:solidFill>
                   <a:srgbClr val="FFFFFF"/>
                 </a:solidFill>
@@ -6063,7 +9213,7 @@
               </a:rPr>
               <a:t>Course Advisor's view, Payroll Clerk's view, ...</a:t>
             </a:r>
-            <a:endParaRPr lang="en-US" sz="1050" dirty="0"/>
+            <a:endParaRPr lang="en-US" sz="1800" dirty="0"/>
           </a:p>
         </p:txBody>
       </p:sp>
@@ -6134,7 +9284,7 @@
               <a:buNone/>
             </a:pPr>
             <a:r>
-              <a:rPr lang="en-US" sz="1400" b="1" dirty="0">
+              <a:rPr lang="en-US" sz="1800" b="1" dirty="0">
                 <a:solidFill>
                   <a:srgbClr val="FFFFFF"/>
                 </a:solidFill>
@@ -6144,7 +9294,7 @@
               </a:rPr>
               <a:t>External/Conceptual Mapping</a:t>
             </a:r>
-            <a:endParaRPr lang="en-US" sz="1400" dirty="0"/>
+            <a:endParaRPr lang="en-US" sz="1800" dirty="0"/>
           </a:p>
         </p:txBody>
       </p:sp>
@@ -6173,7 +9323,7 @@
               <a:buNone/>
             </a:pPr>
             <a:r>
-              <a:rPr lang="en-US" sz="1050" dirty="0">
+              <a:rPr lang="en-US" sz="1800" dirty="0">
                 <a:solidFill>
                   <a:srgbClr val="FFFFFF"/>
                 </a:solidFill>
@@ -6183,7 +9333,7 @@
               </a:rPr>
               <a:t>Relates each external schema to the one conceptual schema</a:t>
             </a:r>
-            <a:endParaRPr lang="en-US" sz="1050" dirty="0"/>
+            <a:endParaRPr lang="en-US" sz="1800" dirty="0"/>
           </a:p>
         </p:txBody>
       </p:sp>
@@ -6254,7 +9404,7 @@
               <a:buNone/>
             </a:pPr>
             <a:r>
-              <a:rPr lang="en-US" sz="1400" b="1" dirty="0">
+              <a:rPr lang="en-US" sz="1800" b="1" dirty="0">
                 <a:solidFill>
                   <a:srgbClr val="FFFFFF"/>
                 </a:solidFill>
@@ -6264,7 +9414,7 @@
               </a:rPr>
               <a:t>Conceptual Level</a:t>
             </a:r>
-            <a:endParaRPr lang="en-US" sz="1400" dirty="0"/>
+            <a:endParaRPr lang="en-US" sz="1800" dirty="0"/>
           </a:p>
         </p:txBody>
       </p:sp>
@@ -6293,7 +9443,7 @@
               <a:buNone/>
             </a:pPr>
             <a:r>
-              <a:rPr lang="en-US" sz="1050" dirty="0">
+              <a:rPr lang="en-US" sz="1800" dirty="0">
                 <a:solidFill>
                   <a:srgbClr val="FFFFFF"/>
                 </a:solidFill>
@@ -6303,7 +9453,7 @@
               </a:rPr>
               <a:t>The single, complete community schema</a:t>
             </a:r>
-            <a:endParaRPr lang="en-US" sz="1050" dirty="0"/>
+            <a:endParaRPr lang="en-US" sz="1800" dirty="0"/>
           </a:p>
         </p:txBody>
       </p:sp>
@@ -6374,7 +9524,7 @@
               <a:buNone/>
             </a:pPr>
             <a:r>
-              <a:rPr lang="en-US" sz="1400" b="1" dirty="0">
+              <a:rPr lang="en-US" sz="1800" b="1" dirty="0">
                 <a:solidFill>
                   <a:srgbClr val="FFFFFF"/>
                 </a:solidFill>
@@ -6384,7 +9534,7 @@
               </a:rPr>
               <a:t>Conceptual/Internal Mapping</a:t>
             </a:r>
-            <a:endParaRPr lang="en-US" sz="1400" dirty="0"/>
+            <a:endParaRPr lang="en-US" sz="1800" dirty="0"/>
           </a:p>
         </p:txBody>
       </p:sp>
@@ -6413,7 +9563,7 @@
               <a:buNone/>
             </a:pPr>
             <a:r>
-              <a:rPr lang="en-US" sz="1050" dirty="0">
+              <a:rPr lang="en-US" sz="1800" dirty="0">
                 <a:solidFill>
                   <a:srgbClr val="FFFFFF"/>
                 </a:solidFill>
@@ -6423,7 +9573,7 @@
               </a:rPr>
               <a:t>Relates the conceptual schema to physical storage</a:t>
             </a:r>
-            <a:endParaRPr lang="en-US" sz="1050" dirty="0"/>
+            <a:endParaRPr lang="en-US" sz="1800" dirty="0"/>
           </a:p>
         </p:txBody>
       </p:sp>
@@ -6494,7 +9644,7 @@
               <a:buNone/>
             </a:pPr>
             <a:r>
-              <a:rPr lang="en-US" sz="1400" b="1" dirty="0">
+              <a:rPr lang="en-US" sz="1800" b="1" dirty="0">
                 <a:solidFill>
                   <a:srgbClr val="FFFFFF"/>
                 </a:solidFill>
@@ -6504,7 +9654,7 @@
               </a:rPr>
               <a:t>Internal Level</a:t>
             </a:r>
-            <a:endParaRPr lang="en-US" sz="1400" dirty="0"/>
+            <a:endParaRPr lang="en-US" sz="1800" dirty="0"/>
           </a:p>
         </p:txBody>
       </p:sp>
@@ -6533,7 +9683,7 @@
               <a:buNone/>
             </a:pPr>
             <a:r>
-              <a:rPr lang="en-US" sz="1050" dirty="0">
+              <a:rPr lang="en-US" sz="1800" dirty="0">
                 <a:solidFill>
                   <a:srgbClr val="FFFFFF"/>
                 </a:solidFill>
@@ -6543,7 +9693,7 @@
               </a:rPr>
               <a:t>Files, indexes, physical record layout</a:t>
             </a:r>
-            <a:endParaRPr lang="en-US" sz="1050" dirty="0"/>
+            <a:endParaRPr lang="en-US" sz="1800" dirty="0"/>
           </a:p>
         </p:txBody>
       </p:sp>
@@ -6643,7 +9793,7 @@
               <a:buNone/>
             </a:pPr>
             <a:r>
-              <a:rPr lang="en-US" sz="1000" u="sng" dirty="0">
+              <a:rPr lang="en-US" sz="1200" u="sng" dirty="0">
                 <a:solidFill>
                   <a:srgbClr val="8A939B"/>
                 </a:solidFill>
@@ -6664,7 +9814,7 @@
               <a:buNone/>
             </a:pPr>
             <a:r>
-              <a:rPr lang="en-US" sz="1000" dirty="0">
+              <a:rPr lang="en-US" sz="1200" dirty="0">
                 <a:solidFill>
                   <a:srgbClr val="8A939B"/>
                 </a:solidFill>
@@ -6672,9 +9822,9 @@
                 <a:ea typeface="Calibri" pitchFamily="34" charset="-122"/>
                 <a:cs typeface="Calibri" pitchFamily="34" charset="-120"/>
               </a:rPr>
-              <a:t>  ·  9</a:t>
-            </a:r>
-            <a:endParaRPr lang="en-US" sz="1000" dirty="0"/>
+              <a:t>  ·  16</a:t>
+            </a:r>
+            <a:endParaRPr lang="en-US" sz="1200" dirty="0"/>
           </a:p>
         </p:txBody>
       </p:sp>
@@ -6725,7 +9875,7 @@
               <a:buNone/>
             </a:pPr>
             <a:r>
-              <a:rPr lang="en-US" sz="1500" b="1" dirty="0">
+              <a:rPr lang="en-US" sz="1800" b="1" dirty="0">
                 <a:solidFill>
                   <a:srgbClr val="FFFFFF"/>
                 </a:solidFill>
@@ -6735,7 +9885,7 @@
               </a:rPr>
               <a:t>The capacity to change the conceptual schema without having to change existing external schemas or the application programs built against them.</a:t>
             </a:r>
-            <a:endParaRPr lang="en-US" sz="1500" dirty="0"/>
+            <a:endParaRPr lang="en-US" sz="1800" dirty="0"/>
           </a:p>
         </p:txBody>
       </p:sp>
@@ -6764,7 +9914,7 @@
               <a:buNone/>
             </a:pPr>
             <a:r>
-              <a:rPr lang="en-US" sz="1350" dirty="0">
+              <a:rPr lang="en-US" sz="1800" dirty="0">
                 <a:solidFill>
                   <a:srgbClr val="1F2429"/>
                 </a:solidFill>
@@ -6774,7 +9924,7 @@
               </a:rPr>
               <a:t>It is achieved because a change to the conceptual schema only requires updating the external/conceptual mapping — the external schemas themselves stay exactly as they were.</a:t>
             </a:r>
-            <a:endParaRPr lang="en-US" sz="1350" dirty="0"/>
+            <a:endParaRPr lang="en-US" sz="1800" dirty="0"/>
           </a:p>
         </p:txBody>
       </p:sp>
@@ -6830,7 +9980,7 @@
               <a:buNone/>
             </a:pPr>
             <a:r>
-              <a:rPr lang="en-US" sz="1250" b="1" dirty="0">
+              <a:rPr lang="en-US" sz="1800" b="1" dirty="0">
                 <a:solidFill>
                   <a:srgbClr val="1F2429"/>
                 </a:solidFill>
@@ -6844,7 +9994,7 @@
               <a:buNone/>
             </a:pPr>
             <a:r>
-              <a:rPr lang="en-US" sz="1250" dirty="0">
+              <a:rPr lang="en-US" sz="1800" dirty="0">
                 <a:solidFill>
                   <a:srgbClr val="1F2429"/>
                 </a:solidFill>
@@ -6854,7 +10004,7 @@
               </a:rPr>
               <a:t>The university adds a new Instructor.officePhone attribute to the conceptual schema. The Course Advisor's external schema never referenced instructor data at all, so nothing about it needs to change, and every application built against it keeps working — completely unaware the conceptual schema grew a new column.</a:t>
             </a:r>
-            <a:endParaRPr lang="en-US" sz="1250" dirty="0"/>
+            <a:endParaRPr lang="en-US" sz="1800" dirty="0"/>
           </a:p>
         </p:txBody>
       </p:sp>
@@ -6883,7 +10033,7 @@
               <a:buNone/>
             </a:pPr>
             <a:r>
-              <a:rPr lang="en-US" sz="1200" i="1" dirty="0">
+              <a:rPr lang="en-US" sz="1800" i="1" dirty="0">
                 <a:solidFill>
                   <a:srgbClr val="8A939B"/>
                 </a:solidFill>
@@ -6893,7 +10043,7 @@
               </a:rPr>
               <a:t>If the change is “we added a column” or “we split a relation in two,” think logical.</a:t>
             </a:r>
-            <a:endParaRPr lang="en-US" sz="1200" dirty="0"/>
+            <a:endParaRPr lang="en-US" sz="1800" dirty="0"/>
           </a:p>
         </p:txBody>
       </p:sp>

</xml_diff>